<commit_message>
Talk script and Q&A for the 13 Oct catch-up; script copied into the deck's speaker notes
Co-Authored-By: Claude Opus 5.5 <noreply@anthropic.com>
</commit_message>
<xml_diff>
--- a/notes/slides/2026-10-13_phd_catchup/phd_catchup_2026-10-13.pptx
+++ b/notes/slides/2026-10-13_phd_catchup/phd_catchup_2026-10-13.pptx
@@ -517,7 +517,7 @@
           <a:p>
             <a:r>
               <a:rPr lang="en-US" dirty="0"/>
-              <a:t>One sentence: I study when spot-checks stop AI agents from taking more than their share of something they share, and whether the penalty that does it can be worked out in advance.</a:t>
+              <a:t>Hi everyone. I'll catch you up on what I've been working on. The title is Penalties Sized to the Gain, and the question underneath is really the whole project: when do random spot-checks stop AI agents from over-using something they share?</a:t>
             </a:r>
             <a:endParaRPr lang="en-US" dirty="0"/>
           </a:p>
@@ -605,7 +605,10 @@
           <a:p>
             <a:r>
               <a:rPr lang="en-US" dirty="0"/>
-              <a:t>Gemma rarely took more than its allowance and Mistral never did, so they say nothing about the stopping fine. A small fine made gpt-oss over-take more (55% to about 90%), as if the fine were a price.</a:t>
+              <a:t>Now language models. Four open models each controlled four of the six fishers, with two rule-following fishers left in so I can see who gets hurt. That's 520 games in total.
+The left panel shows how often each model took more than its allowance, at each fine size. Two models, gpt-oss and Nemotron, over-took on purpose. The other two barely did: Gemma rarely, and Mistral never.
+Before testing, I predicted from their no-fine behaviour that both would stop at 30 tonnes. Nemotron stopped exactly at 30, and gpt-oss one step early, at 24. The right panel shows the rule-following fishers getting their catch back once the fine is large enough.
+One interesting side result: a small fine made gpt-oss cheat more, from about 55 to about 90 percent of rounds. It's as if the fine became a price for cheating, which has also been seen in people.</a:t>
             </a:r>
             <a:endParaRPr lang="en-US" dirty="0"/>
           </a:p>
@@ -693,7 +696,10 @@
           <a:p>
             <a:r>
               <a:rPr lang="en-US" dirty="0"/>
-              <a:t>This shows what predicts where the models stop, not why they stop.</a:t>
+              <a:t>Fifth finding: which gain predicts the stop. It was how much the model took above its allowance in a single round, about 4.5 to 4.7 tonnes.
+It was not what over-taking earned over the whole game. Over the whole game their cheating gained little or even lost fish, because it depleted the lake, and yet they kept going.
+They also stopped earlier than a perfect payoff-maximiser would. That agent would hold out until 36 tonnes; both models stopped before that, and gradually.
+I want to be careful here: this tells us what predicts where they stop, not why they stop.</a:t>
             </a:r>
             <a:endParaRPr lang="en-US" dirty="0"/>
           </a:p>
@@ -781,7 +787,8 @@
           <a:p>
             <a:r>
               <a:rPr lang="en-US" dirty="0"/>
-              <a:t/>
+              <a:t>And memory works for language models too. With checks and memory, but no fine at all, gpt-oss over-took in 20 percent of rounds instead of 55. Rounds below half capacity fell from 92 to 20 percent, and no lake collapsed, against 5 out of 10 without memory.
+So memory reduced over-taking but didn't stop it. A big enough fine did stop it, and cost nothing in efficiency.</a:t>
             </a:r>
             <a:endParaRPr lang="en-US" dirty="0"/>
           </a:p>
@@ -869,7 +876,12 @@
           <a:p>
             <a:r>
               <a:rPr lang="en-US" dirty="0"/>
-              <a:t>A fifth model family, DeepSeek V4.1 Flash, took more than its allowance in 80% of rounds without a fine; its predicted stopping fine (36 t) is recorded but not tested yet.</a:t>
+              <a:t>These are still running. The boxes are empty because the results aren't in yet. Each one answers a question an outside review raised.
+1. Do the models respond to the expected fine, or to the size of the fine? I keep the expected fine the same but change how it's made up: a 1-in-3 chance of a check with a small fine, 1-in-6, or 1-in-12 with a large fine.
+2. Does the prediction hold on new games and with reworded rules? The predictions are already written down: 30 tonnes for both models.
+3. What happens if nothing ever checks?
+4. Does cheating spread? In Forest, I put one programmed cheater among five language-model agents and see whether its neighbours start over-cutting, with and without being able to see each other's cuts.
+I also screened a fifth model, DeepSeek. It over-took in 80 percent of rounds without a fine, so it's a third model that cheats on purpose.</a:t>
             </a:r>
             <a:endParaRPr lang="en-US" dirty="0"/>
           </a:p>
@@ -957,7 +969,12 @@
           <a:p>
             <a:r>
               <a:rPr lang="en-US" dirty="0"/>
-              <a:t>January dates are estimates; the calls for papers are not out yet.</a:t>
+              <a:t>The plan:
+- The programmed-agent work and the first language-model studies are done.
+- The follow-ups finish in the next day or so.
+- I'm aiming for an AAAI workshop on 20 November, plus arXiv.
+- Then a main conference in January, IJCAI or ICML. Those dates are estimates, because the calls aren't out yet.
+Every study had its plan written down before the code, and I report the predictions that failed.</a:t>
             </a:r>
             <a:endParaRPr lang="en-US" dirty="0"/>
           </a:p>
@@ -1045,7 +1062,7 @@
           <a:p>
             <a:r>
               <a:rPr lang="en-US" dirty="0"/>
-              <a:t/>
+              <a:t>I'd really like your views on these. Is taking more than your allowance a fair stand-in for an AI agent misbehaving? If a fine works under one wording of the rules, how far would you trust it under another? Would more models or more kinds of setting convince you more? And where in your own work does someone check only a sample?</a:t>
             </a:r>
             <a:endParaRPr lang="en-US" dirty="0"/>
           </a:p>
@@ -1133,7 +1150,7 @@
           <a:p>
             <a:r>
               <a:rPr lang="en-US" dirty="0"/>
-              <a:t/>
+              <a:t>Thanks. I'm happy to share the draft.</a:t>
             </a:r>
             <a:endParaRPr lang="en-US" dirty="0"/>
           </a:p>
@@ -1221,7 +1238,12 @@
           <a:p>
             <a:r>
               <a:rPr lang="en-US" dirty="0"/>
-              <a:t>If people remember one slide, it should be this one. The rest of the talk unpacks each card.</a:t>
+              <a:t>If you only remember one slide, make it this one.
+Why it matters: AI agents are starting to act on things they share with other agents and people, like compute, energy and budgets. Whoever oversees them can't check every action, so they check a sample.
+What I built: a simulated shared resource. Six agents draw on it over many rounds, a reviewer decides how much each one is allowed to take, and a few agents are checked at random each round.
+What I tested: what should happen to an agent that gets caught taking too much — a fine, a memory of the offence, or both — and whether you can work out in advance how big the fine needs to be to stop it.
+What I found: checks only help when getting caught has a consequence, and the fine that stops an agent can be predicted from how much it gains by cheating. That held for programmed agents and for language models.
+The rest of the talk unpacks those four boxes.</a:t>
             </a:r>
             <a:endParaRPr lang="en-US" dirty="0"/>
           </a:p>
@@ -1309,7 +1331,13 @@
           <a:p>
             <a:r>
               <a:rPr lang="en-US" dirty="0"/>
-              <a:t>These settings are not toys to be solved one by one; they are a way of checking that a result about oversight holds across the main ways harm can spread.</a:t>
+              <a:t>Let me make the problem concrete. Each agent gets an allowance, the amount it's allowed to take this round. Taking more than that helps the agent and leaves less for everyone else.
+Checking every action costs too much, so the overseer spot-checks a few, the way tax inspectors or fisheries inspectors do. The open question is when a sampled check actually stops over-use, and how big the penalty has to be.
+I ask this in three settings, on the right. They aren't three toy problems; I picked them because harm travels differently in each:
+- in Fishery, everyone draws from one shared stock;
+- in Forest, each agent has its own plot, but over-cutting damages your two neighbours;
+- in River, two kinds of pollution are mostly harmless alone and harmful together.
+If a result holds in all three, it isn't an artefact of one particular structure.</a:t>
             </a:r>
             <a:endParaRPr lang="en-US" dirty="0"/>
           </a:p>
@@ -1397,7 +1425,10 @@
           <a:p>
             <a:r>
               <a:rPr lang="en-US" dirty="0"/>
-              <a:t/>
+              <a:t>So there are three questions.
+1. When a check catches someone, what has to follow for the check to matter: a fine, a memory, or nothing?
+2. Is there a fine size where cheating stops, and can I calculate it before I try it?
+3. When most of the agents are language models making their own choices, do they stop where my prediction says?</a:t>
             </a:r>
             <a:endParaRPr lang="en-US" dirty="0"/>
           </a:p>
@@ -1485,7 +1516,13 @@
           <a:p>
             <a:r>
               <a:rPr lang="en-US" dirty="0"/>
-              <a:t>Half capacity is the maximum-sustainable-yield level used in fisheries management. The same harm line is used in all three settings.</a:t>
+              <a:t>This is one round.
+1. Every agent asks for a share.
+2. The reviewer predicts what those requests would do to the resource. It then scales everyone's request down by the same factor, if needed, to keep the resource healthy.
+3. Each agent then takes its allowance, or more if it's cheating.
+4. The resource regrows.
+5. A few agents are checked at random.
+The one definition to keep in mind is harm: the resource falling below half of its capacity. That's the level where it regrows fastest, the 'maximum sustainable yield' level from fisheries management. I use the same harm line in all three settings.</a:t>
             </a:r>
             <a:endParaRPr lang="en-US" dirty="0"/>
           </a:p>
@@ -1573,7 +1610,17 @@
           <a:p>
             <a:r>
               <a:rPr lang="en-US" dirty="0"/>
-              <a:t>Example: with a 1 in 6 chance of a check and a 30 t fine, the expected fine is 5 t; a model that gains about 4.5 t per round should stop there, and should not stop at 24 t (4 t expected).</a:t>
+              <a:t>Here's the method, in four steps.
+1. Run the setting.
+2. Run games with no fine and measure how much an agent gains from one round of taking more than its allowance.
+3. Use that to predict the fine that should stop it, and write the prediction down before running any game with that fine.
+4. Test the predicted fine, and the fines around it, on new games, and report the result whether or not it matches.
+The card on the right has the only formula in the talk:
+- q is the chance of being checked;
+- F is the fine;
+- so q times F is the expected fine for one round of cheating;
+- g is what you gain from that round.
+The prediction, which goes back to the economist Gary Becker in 1968, is that cheating stops once the expected fine is bigger than the gain. For example, with a 1-in-6 chance of a check and a 30-tonne fine, the expected fine is 5 tonnes. A model that gains about 4.5 tonnes per round should stop there, and not at 24 tonnes, where the expected fine is only 4.</a:t>
             </a:r>
             <a:endParaRPr lang="en-US" dirty="0"/>
           </a:p>
@@ -1661,7 +1708,9 @@
           <a:p>
             <a:r>
               <a:rPr lang="en-US" dirty="0"/>
-              <a:t>Programmed agents, 64 independent games per setting, 80 rounds each.</a:t>
+              <a:t>First finding. Here some agents report less than they actually intend to take, so the reviewer underestimates their use unless a check catches them.
+If the reviewer only corrects the round in which it caught a lie, that removes just 10 to 46 percent of the harm. If it remembers each caught lie and adjusts that agent's future allowances, harm drops a lot in all 12 settings I tested. In Fishery, the share of rounds below half capacity fell from somewhere between 43 and 99 percent to under 3 percent.
+The takeaway: a catch by itself barely helps. It needs a consequence.</a:t>
             </a:r>
             <a:endParaRPr lang="en-US" dirty="0"/>
           </a:p>
@@ -1749,7 +1798,8 @@
           <a:p>
             <a:r>
               <a:rPr lang="en-US" dirty="0"/>
-              <a:t>This is a validation, not a surprise: the agents optimise the payoff the prediction is based on.</a:t>
+              <a:t>Second finding. These programmed agents choose how much to over-take so as to earn the most. Using only games without any checks, I predicted the expected fine at which they'd stop. In five out of five new settings, the stopping point landed within one step of the prediction.
+To be fair about it: these agents are built to maximise their payoff, so this is mostly a check that my measurement method works before I try it on language models.</a:t>
             </a:r>
             <a:endParaRPr lang="en-US" dirty="0"/>
           </a:p>
@@ -1837,7 +1887,10 @@
           <a:p>
             <a:r>
               <a:rPr lang="en-US" dirty="0"/>
-              <a:t>Checking where the outcome fell furthest below the reviewer's forecast did best in Forest, so targeting by outcome can work; targeting by report did not.</a:t>
+              <a:t>Third finding: two shortcuts that look sensible and backfire.
+On the left, the overseer knows there are cheaters and lowers everyone's allowance to make up for them. Cheaters actually gained more than with no checks at all, 142 against 113, and honest agents paid for it.
+On the right, the overseer always checks whoever asks for the most. Over a game that caught only 25 percent of the liars, against 100 percent with random checks, because the biggest requester is often honest, so the same honest agent keeps getting checked.
+The lesson is that shortcuts which save checks can open blind spots.</a:t>
             </a:r>
             <a:endParaRPr lang="en-US" dirty="0"/>
           </a:p>

</xml_diff>

<commit_message>
Catch-up deck: back to the 16-slide version with shorter, plainer text and consistent terms; brisk 7-8 minute script in speaker notes and as a .docx with the Q&A; 10-minute cut removed
Co-Authored-By: Claude Opus 5.5 <noreply@anthropic.com>
</commit_message>
<xml_diff>
--- a/notes/slides/2026-10-13_phd_catchup/phd_catchup_2026-10-13.pptx
+++ b/notes/slides/2026-10-13_phd_catchup/phd_catchup_2026-10-13.pptx
@@ -517,7 +517,7 @@
           <a:p>
             <a:r>
               <a:rPr lang="en-US" dirty="0"/>
-              <a:t>Hi everyone. I'll catch you up on what I've been working on. The title is Penalties Sized to the Gain, and the question underneath is really the whole project: when do random spot-checks stop AI agents from over-using something they share?</a:t>
+              <a:t>Hi all. My project asks one question: when do random audits stop AI agents from over-using a shared resource? And can we predict the fine that stops them?</a:t>
             </a:r>
             <a:endParaRPr lang="en-US" dirty="0"/>
           </a:p>
@@ -605,10 +605,7 @@
           <a:p>
             <a:r>
               <a:rPr lang="en-US" dirty="0"/>
-              <a:t>Now language models. Four open models each controlled four of the six fishers, with two rule-following fishers left in so I can see who gets hurt. That's 520 games in total.
-The left panel shows how often each model took more than its allowance, at each fine size. Two models, gpt-oss and Nemotron, over-took on purpose. The other two barely did: Gemma rarely, and Mistral never.
-Before testing, I predicted from their no-fine behaviour that both would stop at 30 tonnes. Nemotron stopped exactly at 30, and gpt-oss one step early, at 24. The right panel shows the rule-following fishers getting their catch back once the fine is large enough.
-One interesting side result: a small fine made gpt-oss cheat more, from about 55 to about 90 percent of rounds. It's as if the fine became a price for cheating, which has also been seen in people.</a:t>
+              <a:t>Now language models. Four open models ran four of the six fishers, over 520 games. Two over-took on purpose: gpt-oss and Nemotron. Before testing, I predicted both would stop at 30 tonnes. Nemotron stopped at exactly 30, and gpt-oss one step early, at 24. A side note: a small fine made gpt-oss over-take more, as if the fine became a price.</a:t>
             </a:r>
             <a:endParaRPr lang="en-US" dirty="0"/>
           </a:p>
@@ -696,10 +693,7 @@
           <a:p>
             <a:r>
               <a:rPr lang="en-US" dirty="0"/>
-              <a:t>Fifth finding: which gain predicts the stop. It was how much the model took above its allowance in a single round, about 4.5 to 4.7 tonnes.
-It was not what over-taking earned over the whole game. Over the whole game their cheating gained little or even lost fish, because it depleted the lake, and yet they kept going.
-They also stopped earlier than a perfect payoff-maximiser would. That agent would hold out until 36 tonnes; both models stopped before that, and gradually.
-I want to be careful here: this tells us what predicts where they stop, not why they stop.</a:t>
+              <a:t>Finding five: what predicts the stop is the gain from one round, not the gain over the whole game, which was near zero or even negative. Both models also stopped earlier than a perfect optimiser would. That tells us what predicts the stop, not necessarily why they stop.</a:t>
             </a:r>
             <a:endParaRPr lang="en-US" dirty="0"/>
           </a:p>
@@ -787,8 +781,7 @@
           <a:p>
             <a:r>
               <a:rPr lang="en-US" dirty="0"/>
-              <a:t>And memory works for language models too. With checks and memory, but no fine at all, gpt-oss over-took in 20 percent of rounds instead of 55. Rounds below half capacity fell from 92 to 20 percent, and no lake collapsed, against 5 out of 10 without memory.
-So memory reduced over-taking but didn't stop it. A big enough fine did stop it, and cost nothing in efficiency.</a:t>
+              <a:t>Memory works for language models too. With audits and memory but no fine, over-taking fell from 55 to 20 percent, and no lake collapsed. Memory reduces over-taking but doesn't stop it; a large enough fine does, with no loss of efficiency.</a:t>
             </a:r>
             <a:endParaRPr lang="en-US" dirty="0"/>
           </a:p>
@@ -876,12 +869,7 @@
           <a:p>
             <a:r>
               <a:rPr lang="en-US" dirty="0"/>
-              <a:t>These are still running. The boxes are empty because the results aren't in yet. Each one answers a question an outside review raised.
-1. Do the models respond to the expected fine, or to the size of the fine? I keep the expected fine the same but change how it's made up: a 1-in-3 chance of a check with a small fine, 1-in-6, or 1-in-12 with a large fine.
-2. Does the prediction hold on new games and with reworded rules? The predictions are already written down: 30 tonnes for both models.
-3. What happens if nothing ever checks?
-4. Does cheating spread? In Forest, I put one programmed cheater among five language-model agents and see whether its neighbours start over-cutting, with and without being able to see each other's cuts.
-I also screened a fifth model, DeepSeek. It over-took in 80 percent of rounds without a fine, so it's a third model that cheats on purpose.</a:t>
+              <a:t>These are running now, so the boxes are blank. The big one: do models respond to the expected fine, or just to the size of the fine? I hold the expected fine fixed and change the mix of audit probability and fine. The others test whether the prediction transfers to new games and reworded rules, what happens with no audits at all, and whether over-taking spreads to neighbours.</a:t>
             </a:r>
             <a:endParaRPr lang="en-US" dirty="0"/>
           </a:p>
@@ -969,12 +957,7 @@
           <a:p>
             <a:r>
               <a:rPr lang="en-US" dirty="0"/>
-              <a:t>The plan:
-- The programmed-agent work and the first language-model studies are done.
-- The follow-ups finish in the next day or so.
-- I'm aiming for an AAAI workshop on 20 November, plus arXiv.
-- Then a main conference in January, IJCAI or ICML. Those dates are estimates, because the calls aren't out yet.
-Every study had its plan written down before the code, and I report the predictions that failed.</a:t>
+              <a:t>Next: a workshop paper and arXiv in November, then a main conference in January. Every study was pre-registered before its code, and I report the predictions that failed.</a:t>
             </a:r>
             <a:endParaRPr lang="en-US" dirty="0"/>
           </a:p>
@@ -1062,7 +1045,7 @@
           <a:p>
             <a:r>
               <a:rPr lang="en-US" dirty="0"/>
-              <a:t>I'd really like your views on these. Is taking more than your allowance a fair stand-in for an AI agent misbehaving? If a fine works under one wording of the rules, how far would you trust it under another? Would more models or more kinds of setting convince you more? And where in your own work does someone check only a sample?</a:t>
+              <a:t>I'd love your take on these.</a:t>
             </a:r>
             <a:endParaRPr lang="en-US" dirty="0"/>
           </a:p>
@@ -1150,7 +1133,7 @@
           <a:p>
             <a:r>
               <a:rPr lang="en-US" dirty="0"/>
-              <a:t>Thanks. I'm happy to share the draft.</a:t>
+              <a:t>Thanks!</a:t>
             </a:r>
             <a:endParaRPr lang="en-US" dirty="0"/>
           </a:p>
@@ -1238,12 +1221,7 @@
           <a:p>
             <a:r>
               <a:rPr lang="en-US" dirty="0"/>
-              <a:t>If you only remember one slide, make it this one.
-Why it matters: AI agents are starting to act on things they share with other agents and people, like compute, energy and budgets. Whoever oversees them can't check every action, so they check a sample.
-What I built: a simulated shared resource. Six agents draw on it over many rounds, a reviewer decides how much each one is allowed to take, and a few agents are checked at random each round.
-What I tested: what should happen to an agent that gets caught taking too much — a fine, a memory of the offence, or both — and whether you can work out in advance how big the fine needs to be to stop it.
-What I found: checks only help when getting caught has a consequence, and the fine that stops an agent can be predicted from how much it gains by cheating. That held for programmed agents and for language models.
-The rest of the talk unpacks those four boxes.</a:t>
+              <a:t>Quick overview first. AI agents increasingly share limited resources, like compute, energy and budgets, and an overseer can only audit a few of their actions. So I built an audited shared resource: six agents, a reviewer who sets each agent's allowance, and random audits every round. I tested two things: what a caught agent should face (a fine, a memory of the offence, or both), and whether the stopping fine can be predicted in advance. Short answer: audits only work through consequences, and the stopping fine is predictable from what an agent gains by over-taking.</a:t>
             </a:r>
             <a:endParaRPr lang="en-US" dirty="0"/>
           </a:p>
@@ -1331,13 +1309,7 @@
           <a:p>
             <a:r>
               <a:rPr lang="en-US" dirty="0"/>
-              <a:t>Let me make the problem concrete. Each agent gets an allowance, the amount it's allowed to take this round. Taking more than that helps the agent and leaves less for everyone else.
-Checking every action costs too much, so the overseer spot-checks a few, the way tax inspectors or fisheries inspectors do. The open question is when a sampled check actually stops over-use, and how big the penalty has to be.
-I ask this in three settings, on the right. They aren't three toy problems; I picked them because harm travels differently in each:
-- in Fishery, everyone draws from one shared stock;
-- in Forest, each agent has its own plot, but over-cutting damages your two neighbours;
-- in River, two kinds of pollution are mostly harmless alone and harmful together.
-If a result holds in all three, it isn't an artefact of one particular structure.</a:t>
+              <a:t>The core idea is an allowance: what an agent may take this round. Taking more, which I call over-taking, helps that agent and costs everyone else. Auditing everything is too costly, so a random few are audited, like tax inspections. I run this in three settings where harm spreads differently: one shared stock, damage to neighbours on a ring, and pollution that is only harmful in combination. If a result holds in all three, it doesn't hinge on one structure.</a:t>
             </a:r>
             <a:endParaRPr lang="en-US" dirty="0"/>
           </a:p>
@@ -1425,10 +1397,7 @@
           <a:p>
             <a:r>
               <a:rPr lang="en-US" dirty="0"/>
-              <a:t>So there are three questions.
-1. When a check catches someone, what has to follow for the check to matter: a fine, a memory, or nothing?
-2. Is there a fine size where cheating stops, and can I calculate it before I try it?
-3. When most of the agents are language models making their own choices, do they stop where my prediction says?</a:t>
+              <a:t>So, three questions. What must follow a catch? Can we predict the stopping fine? And do language models follow the same rule?</a:t>
             </a:r>
             <a:endParaRPr lang="en-US" dirty="0"/>
           </a:p>
@@ -1516,13 +1485,7 @@
           <a:p>
             <a:r>
               <a:rPr lang="en-US" dirty="0"/>
-              <a:t>This is one round.
-1. Every agent asks for a share.
-2. The reviewer predicts what those requests would do to the resource. It then scales everyone's request down by the same factor, if needed, to keep the resource healthy.
-3. Each agent then takes its allowance, or more if it's cheating.
-4. The resource regrows.
-5. A few agents are checked at random.
-The one definition to keep in mind is harm: the resource falling below half of its capacity. That's the level where it regrows fastest, the 'maximum sustainable yield' level from fisheries management. I use the same harm line in all three settings.</a:t>
+              <a:t>Here's one round. Agents request a share. The reviewer predicts the effect and scales everyone by the same factor if needed. Agents then take their allowance, or more. The resource regrows, and random audits check a few agents. Harm means the resource dropping below half capacity: the maximum-sustainable-yield level, where it regrows fastest.</a:t>
             </a:r>
             <a:endParaRPr lang="en-US" dirty="0"/>
           </a:p>
@@ -1610,17 +1573,7 @@
           <a:p>
             <a:r>
               <a:rPr lang="en-US" dirty="0"/>
-              <a:t>Here's the method, in four steps.
-1. Run the setting.
-2. Run games with no fine and measure how much an agent gains from one round of taking more than its allowance.
-3. Use that to predict the fine that should stop it, and write the prediction down before running any game with that fine.
-4. Test the predicted fine, and the fines around it, on new games, and report the result whether or not it matches.
-The card on the right has the only formula in the talk:
-- q is the chance of being checked;
-- F is the fine;
-- so q times F is the expected fine for one round of cheating;
-- g is what you gain from that round.
-The prediction, which goes back to the economist Gary Becker in 1968, is that cheating stops once the expected fine is bigger than the gain. For example, with a 1-in-6 chance of a check and a 30-tonne fine, the expected fine is 5 tonnes. A model that gains about 4.5 tonnes per round should stop there, and not at 24 tonnes, where the expected fine is only 4.</a:t>
+              <a:t>The method has four steps. Play without fines and measure the gain from one round of over-taking. Predict the fine that should stop it. Freeze that prediction. Then test it on new games. The rule is Becker's: the expected fine, which is the audit probability times the fine, should beat the gain. With a one-in-six audit chance and a 30-tonne fine, that's 5 tonnes expected, just above the roughly 4.5 tonnes the models gained.</a:t>
             </a:r>
             <a:endParaRPr lang="en-US" dirty="0"/>
           </a:p>
@@ -1708,9 +1661,7 @@
           <a:p>
             <a:r>
               <a:rPr lang="en-US" dirty="0"/>
-              <a:t>First finding. Here some agents report less than they actually intend to take, so the reviewer underestimates their use unless a check catches them.
-If the reviewer only corrects the round in which it caught a lie, that removes just 10 to 46 percent of the harm. If it remembers each caught lie and adjusts that agent's future allowances, harm drops a lot in all 12 settings I tested. In Fishery, the share of rounds below half capacity fell from somewhere between 43 and 99 percent to under 3 percent.
-The takeaway: a catch by itself barely helps. It needs a consequence.</a:t>
+              <a:t>Finding one, with programmed agents that under-report. Audits that only correct the caught round remove just 10 to 46 percent of the harm. Add memory, so the reviewer remembers each caught lie and adjusts later allowances, and harm falls in all 12 settings. In Fishery it goes from up to 99 percent of rounds below half capacity to under 3. A catch needs a consequence.</a:t>
             </a:r>
             <a:endParaRPr lang="en-US" dirty="0"/>
           </a:p>
@@ -1798,8 +1749,7 @@
           <a:p>
             <a:r>
               <a:rPr lang="en-US" dirty="0"/>
-              <a:t>Second finding. These programmed agents choose how much to over-take so as to earn the most. Using only games without any checks, I predicted the expected fine at which they'd stop. In five out of five new settings, the stopping point landed within one step of the prediction.
-To be fair about it: these agents are built to maximise their payoff, so this is mostly a check that my measurement method works before I try it on language models.</a:t>
+              <a:t>Finding two: the threshold is predictable. From games without audits I predicted where programmed cheaters would stop, and 5 of 5 new settings landed within one step. To be fair, these agents optimise by design, so this mainly validates the method.</a:t>
             </a:r>
             <a:endParaRPr lang="en-US" dirty="0"/>
           </a:p>
@@ -1887,10 +1837,7 @@
           <a:p>
             <a:r>
               <a:rPr lang="en-US" dirty="0"/>
-              <a:t>Third finding: two shortcuts that look sensible and backfire.
-On the left, the overseer knows there are cheaters and lowers everyone's allowance to make up for them. Cheaters actually gained more than with no checks at all, 142 against 113, and honest agents paid for it.
-On the right, the overseer always checks whoever asks for the most. Over a game that caught only 25 percent of the liars, against 100 percent with random checks, because the biggest requester is often honest, so the same honest agent keeps getting checked.
-The lesson is that shortcuts which save checks can open blind spots.</a:t>
+              <a:t>Finding three: two shortcuts backfire. Cutting everyone's allowance to absorb the cheaters actually let cheaters gain more than with no audits at all. And always auditing the largest report caught only a quarter of the liars, against all of them with random audits. Shortcuts that save audits create blind spots.</a:t>
             </a:r>
             <a:endParaRPr lang="en-US" dirty="0"/>
           </a:p>
@@ -2589,7 +2536,7 @@
                 <a:ea typeface="Calibri" pitchFamily="34" charset="-122"/>
                 <a:cs typeface="Calibri" pitchFamily="34" charset="-120"/>
               </a:rPr>
-              <a:t>Four open language models each controlled four of the six fishers (520 games). Left: share of rounds in which a model took more than its allowance, at each fine, with a 1 in 6 chance of a check. Triangles: stopping fine predicted before testing (open) and observed (filled). Right: catch left for the two rule-following fishers.</a:t>
+              <a:t>Four open language models each ran four of six fishers (520 games; audit probability 1 in 6). Left: over-taking by fine; triangles mark the predicted (open) and observed (filled) stopping fine. Right: catch left for the two rule-following fishers.</a:t>
             </a:r>
             <a:endParaRPr lang="en-US" sz="1100" dirty="0"/>
           </a:p>
@@ -2798,7 +2745,7 @@
                 <a:ea typeface="Georgia" pitchFamily="34" charset="-122"/>
                 <a:cs typeface="Georgia" pitchFamily="34" charset="-120"/>
               </a:rPr>
-              <a:t>What predicted it</a:t>
+              <a:t>What predicted the stop</a:t>
             </a:r>
             <a:endParaRPr lang="en-US" sz="1700" dirty="0"/>
           </a:p>
@@ -2837,7 +2784,7 @@
                 <a:ea typeface="Calibri" pitchFamily="34" charset="-122"/>
                 <a:cs typeface="Calibri" pitchFamily="34" charset="-120"/>
               </a:rPr>
-              <a:t>How much each model took above its allowance in one round without a fine (4.5–4.7 t).</a:t>
+              <a:t>The gain from one round of over-taking: 4.5–4.7 t.</a:t>
             </a:r>
             <a:endParaRPr lang="en-US" sz="1400" dirty="0"/>
           </a:p>
@@ -2891,7 +2838,7 @@
         <p:spPr>
           <a:xfrm>
             <a:off x="548640" y="2999232"/>
-            <a:ext cx="4572000" cy="745236"/>
+            <a:ext cx="4572000" cy="521208"/>
           </a:xfrm>
           <a:prstGeom prst="rect">
             <a:avLst/>
@@ -2915,7 +2862,7 @@
                 <a:ea typeface="Calibri" pitchFamily="34" charset="-122"/>
                 <a:cs typeface="Calibri" pitchFamily="34" charset="-120"/>
               </a:rPr>
-              <a:t>What over-taking earned over a whole game: about −1 to +0.7 t per round, because over-taking depleted the lake.</a:t>
+              <a:t>The gain over the whole game, which was near zero or negative.</a:t>
             </a:r>
             <a:endParaRPr lang="en-US" sz="1400" dirty="0"/>
           </a:p>
@@ -2929,7 +2876,7 @@
         </p:nvSpPr>
         <p:spPr>
           <a:xfrm>
-            <a:off x="548640" y="3909060"/>
+            <a:off x="548640" y="3685032"/>
             <a:ext cx="4572000" cy="365760"/>
           </a:xfrm>
           <a:prstGeom prst="rect">
@@ -2954,7 +2901,7 @@
                 <a:ea typeface="Georgia" pitchFamily="34" charset="-122"/>
                 <a:cs typeface="Georgia" pitchFamily="34" charset="-120"/>
               </a:rPr>
-              <a:t>Compared with an ideal optimiser</a:t>
+              <a:t>Against a perfect optimiser</a:t>
             </a:r>
             <a:endParaRPr lang="en-US" sz="1700" dirty="0"/>
           </a:p>
@@ -2968,8 +2915,8 @@
         </p:nvSpPr>
         <p:spPr>
           <a:xfrm>
-            <a:off x="548640" y="4293108"/>
-            <a:ext cx="4572000" cy="745236"/>
+            <a:off x="548640" y="4069080"/>
+            <a:ext cx="4572000" cy="521208"/>
           </a:xfrm>
           <a:prstGeom prst="rect">
             <a:avLst/>
@@ -2993,7 +2940,7 @@
                 <a:ea typeface="Calibri" pitchFamily="34" charset="-122"/>
                 <a:cs typeface="Calibri" pitchFamily="34" charset="-120"/>
               </a:rPr>
-              <a:t>An agent that maximised its expected payoff would keep over-taking until 36 t. Both models stopped earlier, and gradually.</a:t>
+              <a:t>It would keep over-taking until 36 t. Both models stopped earlier, and gradually.</a:t>
             </a:r>
             <a:endParaRPr lang="en-US" sz="1400" dirty="0"/>
           </a:p>
@@ -3056,7 +3003,7 @@
                 <a:ea typeface="Calibri" pitchFamily="34" charset="-122"/>
                 <a:cs typeface="Calibri" pitchFamily="34" charset="-120"/>
               </a:rPr>
-              <a:t>Each point compares a predicted and an observed stopping fine; points on the dashed line were predicted exactly.</a:t>
+              <a:t>Predicted against observed stopping fine; points on the dashed line were predicted exactly.</a:t>
             </a:r>
             <a:endParaRPr lang="en-US" sz="1100" dirty="0"/>
           </a:p>
@@ -3260,7 +3207,7 @@
                 <a:ea typeface="Calibri" pitchFamily="34" charset="-122"/>
                 <a:cs typeface="Calibri" pitchFamily="34" charset="-120"/>
               </a:rPr>
-              <a:t>Checks only</a:t>
+              <a:t>Audits only</a:t>
             </a:r>
             <a:endParaRPr lang="en-US" sz="1200" dirty="0"/>
           </a:p>
@@ -3299,7 +3246,7 @@
                 <a:ea typeface="Calibri" pitchFamily="34" charset="-122"/>
                 <a:cs typeface="Calibri" pitchFamily="34" charset="-120"/>
               </a:rPr>
-              <a:t>Checks + memory</a:t>
+              <a:t>Audits + memory</a:t>
             </a:r>
             <a:endParaRPr lang="en-US" sz="1200" dirty="0"/>
           </a:p>
@@ -3852,7 +3799,7 @@
                 <a:ea typeface="Calibri" pitchFamily="34" charset="-122"/>
                 <a:cs typeface="Calibri" pitchFamily="34" charset="-120"/>
               </a:rPr>
-              <a:t>gpt-oss-120b, no fine in either condition, 10 games each</a:t>
+              <a:t>gpt-oss-120b, audits with no fine in both columns, 10 games each</a:t>
             </a:r>
             <a:endParaRPr lang="en-US" sz="1100" dirty="0"/>
           </a:p>
@@ -3906,7 +3853,7 @@
         <p:spPr>
           <a:xfrm>
             <a:off x="7635240" y="2066544"/>
-            <a:ext cx="4007815" cy="745236"/>
+            <a:ext cx="4007815" cy="521208"/>
           </a:xfrm>
           <a:prstGeom prst="rect">
             <a:avLst/>
@@ -3930,7 +3877,7 @@
                 <a:ea typeface="Calibri" pitchFamily="34" charset="-122"/>
                 <a:cs typeface="Calibri" pitchFamily="34" charset="-120"/>
               </a:rPr>
-              <a:t>Memory protected the lake without any fine, but some over-taking remained. For Nemotron 3 Super, over-taking fell from 65% to 33%.</a:t>
+              <a:t>Memory alone protected the lake, but some over-taking remained (Nemotron: 65% → 33%).</a:t>
             </a:r>
             <a:endParaRPr lang="en-US" sz="1400" dirty="0"/>
           </a:p>
@@ -3944,7 +3891,7 @@
         </p:nvSpPr>
         <p:spPr>
           <a:xfrm>
-            <a:off x="7635240" y="2976372"/>
+            <a:off x="7635240" y="2752344"/>
             <a:ext cx="4007815" cy="365760"/>
           </a:xfrm>
           <a:prstGeom prst="rect">
@@ -3969,7 +3916,7 @@
                 <a:ea typeface="Georgia" pitchFamily="34" charset="-122"/>
                 <a:cs typeface="Georgia" pitchFamily="34" charset="-120"/>
               </a:rPr>
-              <a:t>With a large enough fine</a:t>
+              <a:t>Large enough fines</a:t>
             </a:r>
             <a:endParaRPr lang="en-US" sz="1700" dirty="0"/>
           </a:p>
@@ -3983,7 +3930,7 @@
         </p:nvSpPr>
         <p:spPr>
           <a:xfrm>
-            <a:off x="7635240" y="3360420"/>
+            <a:off x="7635240" y="3136392"/>
             <a:ext cx="4007815" cy="745236"/>
           </a:xfrm>
           <a:prstGeom prst="rect">
@@ -4008,7 +3955,7 @@
                 <a:ea typeface="Calibri" pitchFamily="34" charset="-122"/>
                 <a:cs typeface="Calibri" pitchFamily="34" charset="-120"/>
               </a:rPr>
-              <a:t>Fines above the gain stopped over-taking and kept the harvest at 0.99 of the maximum the lake can sustain.</a:t>
+              <a:t>They stopped over-taking and kept the harvest at 0.99 of the maximum sustainable yield.</a:t>
             </a:r>
             <a:endParaRPr lang="en-US" sz="1400" dirty="0"/>
           </a:p>
@@ -4178,7 +4125,7 @@
                 <a:ea typeface="Georgia" pitchFamily="34" charset="-122"/>
                 <a:cs typeface="Georgia" pitchFamily="34" charset="-120"/>
               </a:rPr>
-              <a:t>Expected fine, or the size of the fine?</a:t>
+              <a:t>Expected fine, or fine size?</a:t>
             </a:r>
             <a:endParaRPr lang="en-US" sz="1600" dirty="0"/>
           </a:p>
@@ -4217,7 +4164,7 @@
                 <a:ea typeface="Calibri" pitchFamily="34" charset="-122"/>
                 <a:cs typeface="Calibri" pitchFamily="34" charset="-120"/>
               </a:rPr>
-              <a:t>Same expected fine (2 t or 3 t), made up differently: 1 in 3 checked with a small fine, 1 in 6, or 1 in 12 with a large fine. gpt-oss-120b, 20 new games per condition.</a:t>
+              <a:t>Same expected fine, made up differently: audit probability 1 in 3, 1 in 6 or 1 in 12 (gpt-oss, 20 games each).</a:t>
             </a:r>
             <a:endParaRPr lang="en-US" sz="1250" dirty="0"/>
           </a:p>
@@ -4322,7 +4269,7 @@
                 <a:ea typeface="Georgia" pitchFamily="34" charset="-122"/>
                 <a:cs typeface="Georgia" pitchFamily="34" charset="-120"/>
               </a:rPr>
-              <a:t>Does the prediction hold on new games?</a:t>
+              <a:t>Does the prediction transfer?</a:t>
             </a:r>
             <a:endParaRPr lang="en-US" sz="1600" dirty="0"/>
           </a:p>
@@ -4361,7 +4308,7 @@
                 <a:ea typeface="Calibri" pitchFamily="34" charset="-122"/>
                 <a:cs typeface="Calibri" pitchFamily="34" charset="-120"/>
               </a:rPr>
-              <a:t>Stopping fine recorded in advance (30 t for both models), tested on 10 new games and with the rules reworded.</a:t>
+              <a:t>Frozen prediction (30 t) tested on 10 new games and with reworded rules.</a:t>
             </a:r>
             <a:endParaRPr lang="en-US" sz="1250" dirty="0"/>
           </a:p>
@@ -4466,7 +4413,7 @@
                 <a:ea typeface="Georgia" pitchFamily="34" charset="-122"/>
                 <a:cs typeface="Georgia" pitchFamily="34" charset="-120"/>
               </a:rPr>
-              <a:t>What if nothing is ever checked?</a:t>
+              <a:t>What if nobody audits?</a:t>
             </a:r>
             <a:endParaRPr lang="en-US" sz="1600" dirty="0"/>
           </a:p>
@@ -4505,7 +4452,7 @@
                 <a:ea typeface="Calibri" pitchFamily="34" charset="-122"/>
                 <a:cs typeface="Calibri" pitchFamily="34" charset="-120"/>
               </a:rPr>
-              <a:t>Rules that never mention checks, compared with checks that carry no fine.</a:t>
+              <a:t>Rules that never mention audits, against audits with no fine.</a:t>
             </a:r>
             <a:endParaRPr lang="en-US" sz="1250" dirty="0"/>
           </a:p>
@@ -4610,7 +4557,7 @@
                 <a:ea typeface="Georgia" pitchFamily="34" charset="-122"/>
                 <a:cs typeface="Georgia" pitchFamily="34" charset="-120"/>
               </a:rPr>
-              <a:t>Does over-taking spread to neighbours?</a:t>
+              <a:t>Does over-taking spread?</a:t>
             </a:r>
             <a:endParaRPr lang="en-US" sz="1600" dirty="0"/>
           </a:p>
@@ -4649,7 +4596,7 @@
                 <a:ea typeface="Calibri" pitchFamily="34" charset="-122"/>
                 <a:cs typeface="Calibri" pitchFamily="34" charset="-120"/>
               </a:rPr>
-              <a:t>Forest: one programmed over-taker among five language-model agents; neighbours' cuts either hidden or visible.</a:t>
+              <a:t>Forest: one programmed over-taker among five language-model agents; neighbours' cuts hidden or visible.</a:t>
             </a:r>
             <a:endParaRPr lang="en-US" sz="1250" dirty="0"/>
           </a:p>
@@ -4972,7 +4919,7 @@
                 <a:ea typeface="Calibri" pitchFamily="34" charset="-122"/>
                 <a:cs typeface="Calibri" pitchFamily="34" charset="-120"/>
               </a:rPr>
-              <a:t>Programmed agents in all three settings; language models in Fishery</a:t>
+              <a:t>Programmed agents in three settings; language models in Fishery</a:t>
             </a:r>
             <a:endParaRPr lang="en-US" sz="1300" dirty="0"/>
           </a:p>
@@ -5075,7 +5022,7 @@
                 <a:ea typeface="Calibri" pitchFamily="34" charset="-122"/>
                 <a:cs typeface="Calibri" pitchFamily="34" charset="-120"/>
               </a:rPr>
-              <a:t>Follow-up tests asked for by two outside reviews</a:t>
+              <a:t>Follow-up tests from two outside reviews</a:t>
             </a:r>
             <a:endParaRPr lang="en-US" sz="1300" dirty="0"/>
           </a:p>
@@ -5178,7 +5125,7 @@
                 <a:ea typeface="Calibri" pitchFamily="34" charset="-122"/>
                 <a:cs typeface="Calibri" pitchFamily="34" charset="-120"/>
               </a:rPr>
-              <a:t>Workshop submission (AAAI-27 WMAC) and arXiv</a:t>
+              <a:t>AAAI-27 workshop and arXiv</a:t>
             </a:r>
             <a:endParaRPr lang="en-US" sz="1300" dirty="0"/>
           </a:p>
@@ -5281,7 +5228,7 @@
                 <a:ea typeface="Calibri" pitchFamily="34" charset="-122"/>
                 <a:cs typeface="Calibri" pitchFamily="34" charset="-120"/>
               </a:rPr>
-              <a:t>Main conference: IJCAI or ICML</a:t>
+              <a:t>Main conference (IJCAI or ICML)</a:t>
             </a:r>
             <a:endParaRPr lang="en-US" sz="1300" dirty="0"/>
           </a:p>
@@ -5320,7 +5267,7 @@
                 <a:ea typeface="Calibri" pitchFamily="34" charset="-122"/>
                 <a:cs typeface="Calibri" pitchFamily="34" charset="-120"/>
               </a:rPr>
-              <a:t>Each study has a protocol written down before its code; predictions that failed are reported.</a:t>
+              <a:t>Every study was pre-registered locally before its code; failed predictions are reported.</a:t>
             </a:r>
             <a:endParaRPr lang="en-US" sz="1200" dirty="0"/>
           </a:p>
@@ -5529,7 +5476,7 @@
                 <a:ea typeface="Georgia" pitchFamily="34" charset="-122"/>
                 <a:cs typeface="Georgia" pitchFamily="34" charset="-120"/>
               </a:rPr>
-              <a:t>Is "taking more than your allowance" a fair stand-in for an AI agent misbehaving? What would be better?</a:t>
+              <a:t>Is over-taking an allowance a fair stand-in for AI misbehaviour?</a:t>
             </a:r>
             <a:endParaRPr lang="en-US" sz="1800" dirty="0"/>
           </a:p>
@@ -5607,7 +5554,7 @@
                 <a:ea typeface="Georgia" pitchFamily="34" charset="-122"/>
                 <a:cs typeface="Georgia" pitchFamily="34" charset="-120"/>
               </a:rPr>
-              <a:t>If a fine works under one wording of the rules, how far would you trust it under another?</a:t>
+              <a:t>If a fine works under one wording of the rules, would you trust it under another?</a:t>
             </a:r>
             <a:endParaRPr lang="en-US" sz="1800" dirty="0"/>
           </a:p>
@@ -5685,7 +5632,7 @@
                 <a:ea typeface="Georgia" pitchFamily="34" charset="-122"/>
                 <a:cs typeface="Georgia" pitchFamily="34" charset="-120"/>
               </a:rPr>
-              <a:t>What would convince you more: more models, or more kinds of setting?</a:t>
+              <a:t>Which would convince you more: more models, or more settings?</a:t>
             </a:r>
             <a:endParaRPr lang="en-US" sz="1800" dirty="0"/>
           </a:p>
@@ -5763,7 +5710,7 @@
                 <a:ea typeface="Georgia" pitchFamily="34" charset="-122"/>
                 <a:cs typeface="Georgia" pitchFamily="34" charset="-120"/>
               </a:rPr>
-              <a:t>Where in your own work does someone check only a sample, and what happens after a catch?</a:t>
+              <a:t>Where in your work does someone audit only a sample, and what follows a catch?</a:t>
             </a:r>
             <a:endParaRPr lang="en-US" sz="1800" dirty="0"/>
           </a:p>
@@ -6215,7 +6162,7 @@
         <p:spPr>
           <a:xfrm>
             <a:off x="777240" y="2276856"/>
-            <a:ext cx="2110664" cy="969264"/>
+            <a:ext cx="2110664" cy="676656"/>
           </a:xfrm>
           <a:prstGeom prst="rect">
             <a:avLst/>
@@ -6239,7 +6186,7 @@
                 <a:ea typeface="Georgia" pitchFamily="34" charset="-122"/>
                 <a:cs typeface="Georgia" pitchFamily="34" charset="-120"/>
               </a:rPr>
-              <a:t>Oversight of AI agents is sampled</a:t>
+              <a:t>Oversight is sampled</a:t>
             </a:r>
             <a:endParaRPr lang="en-US" sz="1700" dirty="0"/>
           </a:p>
@@ -6253,8 +6200,8 @@
         </p:nvSpPr>
         <p:spPr>
           <a:xfrm>
-            <a:off x="777240" y="3291840"/>
-            <a:ext cx="2110664" cy="1920240"/>
+            <a:off x="777240" y="2999232"/>
+            <a:ext cx="2110664" cy="2212848"/>
           </a:xfrm>
           <a:prstGeom prst="rect">
             <a:avLst/>
@@ -6278,7 +6225,7 @@
                 <a:ea typeface="Calibri" pitchFamily="34" charset="-122"/>
                 <a:cs typeface="Calibri" pitchFamily="34" charset="-120"/>
               </a:rPr>
-              <a:t>AI agents are starting to act on resources they share with others, such as compute, energy and budgets. Whoever oversees them can usually check only a few of their actions.</a:t>
+              <a:t>AI agents increasingly share limited resources: compute, energy, budgets. An overseer can only audit a few of their actions.</a:t>
             </a:r>
             <a:endParaRPr lang="en-US" sz="1350" dirty="0"/>
           </a:p>
@@ -6390,7 +6337,7 @@
                 <a:ea typeface="Georgia" pitchFamily="34" charset="-122"/>
                 <a:cs typeface="Georgia" pitchFamily="34" charset="-120"/>
               </a:rPr>
-              <a:t>A shared resource with checks</a:t>
+              <a:t>An audited shared resource</a:t>
             </a:r>
             <a:endParaRPr lang="en-US" sz="1700" dirty="0"/>
           </a:p>
@@ -6429,7 +6376,7 @@
                 <a:ea typeface="Calibri" pitchFamily="34" charset="-122"/>
                 <a:cs typeface="Calibri" pitchFamily="34" charset="-120"/>
               </a:rPr>
-              <a:t>Six agents draw on one renewable resource over many rounds. A reviewer sets how much each may take, and a few agents are checked at random each round.</a:t>
+              <a:t>Six agents use one renewable resource. A reviewer sets each agent's allowance; random audits check a few agents each round.</a:t>
             </a:r>
             <a:endParaRPr lang="en-US" sz="1350" dirty="0"/>
           </a:p>
@@ -6541,7 +6488,7 @@
                 <a:ea typeface="Georgia" pitchFamily="34" charset="-122"/>
                 <a:cs typeface="Georgia" pitchFamily="34" charset="-120"/>
               </a:rPr>
-              <a:t>Consequences and penalty size</a:t>
+              <a:t>Consequences and fine size</a:t>
             </a:r>
             <a:endParaRPr lang="en-US" sz="1700" dirty="0"/>
           </a:p>
@@ -6580,7 +6527,7 @@
                 <a:ea typeface="Calibri" pitchFamily="34" charset="-122"/>
                 <a:cs typeface="Calibri" pitchFamily="34" charset="-120"/>
               </a:rPr>
-              <a:t>What a caught agent should face (a fine, a memory of the offence, or both), and whether the fine that stops an agent can be predicted before it is tried.</a:t>
+              <a:t>What a caught agent should face (a fine, a memory of the offence, or both), and whether the stopping fine can be predicted in advance.</a:t>
             </a:r>
             <a:endParaRPr lang="en-US" sz="1350" dirty="0"/>
           </a:p>
@@ -6692,7 +6639,7 @@
                 <a:ea typeface="Georgia" pitchFamily="34" charset="-122"/>
                 <a:cs typeface="Georgia" pitchFamily="34" charset="-120"/>
               </a:rPr>
-              <a:t>Checks work through consequences</a:t>
+              <a:t>Audits work through consequences</a:t>
             </a:r>
             <a:endParaRPr lang="en-US" sz="1700" dirty="0"/>
           </a:p>
@@ -6731,7 +6678,7 @@
                 <a:ea typeface="Calibri" pitchFamily="34" charset="-122"/>
                 <a:cs typeface="Calibri" pitchFamily="34" charset="-120"/>
               </a:rPr>
-              <a:t>Checks reduced harm only when a catch had a consequence. The stopping fine could be predicted from how much an agent gains by over-taking, for programmed agents and for language models.</a:t>
+              <a:t>The stopping fine is predictable from an agent's gain from over-taking, for programmed agents and for language models.</a:t>
             </a:r>
             <a:endParaRPr lang="en-US" sz="1350" dirty="0"/>
           </a:p>
@@ -6770,7 +6717,7 @@
                 <a:ea typeface="Calibri" pitchFamily="34" charset="-122"/>
                 <a:cs typeface="Calibri" pitchFamily="34" charset="-120"/>
               </a:rPr>
-              <a:t>The rest of the talk: the setting, three questions, how I test them, five findings, and what is still running</a:t>
+              <a:t>Next: the setting, the method, five findings, and what is still running</a:t>
             </a:r>
             <a:endParaRPr lang="en-US" sz="1500" dirty="0"/>
           </a:p>
@@ -6940,7 +6887,7 @@
                 <a:ea typeface="Georgia" pitchFamily="34" charset="-122"/>
                 <a:cs typeface="Georgia" pitchFamily="34" charset="-120"/>
               </a:rPr>
-              <a:t>A limited, shared resource</a:t>
+              <a:t>Allowances</a:t>
             </a:r>
             <a:endParaRPr lang="en-US" sz="1700" dirty="0"/>
           </a:p>
@@ -6979,7 +6926,7 @@
                 <a:ea typeface="Calibri" pitchFamily="34" charset="-122"/>
                 <a:cs typeface="Calibri" pitchFamily="34" charset="-120"/>
               </a:rPr>
-              <a:t>Each agent receives an allowance: the amount it may take this round. Taking more helps that agent and leaves less for everyone else.</a:t>
+              <a:t>Each round, an agent may take its allowance. Taking more, over-taking, helps that agent and costs everyone else.</a:t>
             </a:r>
             <a:endParaRPr lang="en-US" sz="1400" dirty="0"/>
           </a:p>
@@ -7018,7 +6965,7 @@
                 <a:ea typeface="Georgia" pitchFamily="34" charset="-122"/>
                 <a:cs typeface="Georgia" pitchFamily="34" charset="-120"/>
               </a:rPr>
-              <a:t>Oversight by sampling</a:t>
+              <a:t>Sampled oversight</a:t>
             </a:r>
             <a:endParaRPr lang="en-US" sz="1700" dirty="0"/>
           </a:p>
@@ -7057,7 +7004,7 @@
                 <a:ea typeface="Calibri" pitchFamily="34" charset="-122"/>
                 <a:cs typeface="Calibri" pitchFamily="34" charset="-120"/>
               </a:rPr>
-              <a:t>Checking every action costs too much, so an overseer spot-checks a few, as tax and fisheries inspectors do.</a:t>
+              <a:t>Auditing every action is too costly, so random audits check a few agents, as tax and fisheries inspectors do.</a:t>
             </a:r>
             <a:endParaRPr lang="en-US" sz="1400" dirty="0"/>
           </a:p>
@@ -7096,7 +7043,7 @@
                 <a:ea typeface="Georgia" pitchFamily="34" charset="-122"/>
                 <a:cs typeface="Georgia" pitchFamily="34" charset="-120"/>
               </a:rPr>
-              <a:t>The open question</a:t>
+              <a:t>The question</a:t>
             </a:r>
             <a:endParaRPr lang="en-US" sz="1700" dirty="0"/>
           </a:p>
@@ -7111,7 +7058,7 @@
         <p:spPr>
           <a:xfrm>
             <a:off x="548640" y="4517136"/>
-            <a:ext cx="4572000" cy="745236"/>
+            <a:ext cx="4572000" cy="521208"/>
           </a:xfrm>
           <a:prstGeom prst="rect">
             <a:avLst/>
@@ -7135,7 +7082,7 @@
                 <a:ea typeface="Calibri" pitchFamily="34" charset="-122"/>
                 <a:cs typeface="Calibri" pitchFamily="34" charset="-120"/>
               </a:rPr>
-              <a:t>When does a sampled check stop agents taking more than their allowance, and how large does the penalty need to be?</a:t>
+              <a:t>When do random audits stop over-taking, and how large must the fine be?</a:t>
             </a:r>
             <a:endParaRPr lang="en-US" sz="1400" dirty="0"/>
           </a:p>
@@ -7157,7 +7104,7 @@
         </p:blipFill>
         <p:spPr>
           <a:xfrm>
-            <a:off x="5532120" y="2222723"/>
+            <a:off x="5532120" y="2314163"/>
             <a:ext cx="6110935" cy="2311970"/>
           </a:xfrm>
           <a:prstGeom prst="rect">
@@ -7173,7 +7120,7 @@
         </p:nvSpPr>
         <p:spPr>
           <a:xfrm>
-            <a:off x="5532120" y="4644421"/>
+            <a:off x="5532120" y="4735861"/>
             <a:ext cx="6110935" cy="502920"/>
           </a:xfrm>
           <a:prstGeom prst="rect">
@@ -7198,7 +7145,7 @@
                 <a:ea typeface="Calibri" pitchFamily="34" charset="-122"/>
                 <a:cs typeface="Calibri" pitchFamily="34" charset="-120"/>
               </a:rPr>
-              <a:t>The same question in three settings, chosen because one agent's over-use reaches others in a different way in each: through a single shared pool (Fishery), through damage to direct neighbours (Forest), and through harm that appears only when two kinds of use combine (River). A result that holds in all three does not rest on one structure.</a:t>
+              <a:t>Three settings where harm spreads differently: one shared stock (Fishery), damage to neighbours on a ring (Forest), and pollution that is harmful only in combination (River). A result that holds in all three does not depend on one structure.</a:t>
             </a:r>
             <a:endParaRPr lang="en-US" sz="1100" dirty="0"/>
           </a:p>
@@ -7407,7 +7354,7 @@
                 <a:ea typeface="Georgia" pitchFamily="34" charset="-122"/>
                 <a:cs typeface="Georgia" pitchFamily="34" charset="-120"/>
               </a:rPr>
-              <a:t>What has to follow a catch?</a:t>
+              <a:t>What must follow a catch?</a:t>
             </a:r>
             <a:endParaRPr lang="en-US" sz="1900" dirty="0"/>
           </a:p>
@@ -7446,7 +7393,7 @@
                 <a:ea typeface="Calibri" pitchFamily="34" charset="-122"/>
                 <a:cs typeface="Calibri" pitchFamily="34" charset="-120"/>
               </a:rPr>
-              <a:t>When a check finds an agent taking more than its allowance, the overseer can fine it, remember it, or do nothing. Which of these reduces harm?</a:t>
+              <a:t>A fine, a memory of the offence, or nothing: which one reduces harm?</a:t>
             </a:r>
             <a:endParaRPr lang="en-US" sz="1400" dirty="0"/>
           </a:p>
@@ -7563,7 +7510,7 @@
                 <a:ea typeface="Calibri" pitchFamily="34" charset="-122"/>
                 <a:cs typeface="Calibri" pitchFamily="34" charset="-120"/>
               </a:rPr>
-              <a:t>Is there a fine size at which over-taking stops, and can it be worked out before that fine is tried?</a:t>
+              <a:t>Can we compute it before trying it?</a:t>
             </a:r>
             <a:endParaRPr lang="en-US" sz="1400" dirty="0"/>
           </a:p>
@@ -7641,7 +7588,7 @@
                 <a:ea typeface="Georgia" pitchFamily="34" charset="-122"/>
                 <a:cs typeface="Georgia" pitchFamily="34" charset="-120"/>
               </a:rPr>
-              <a:t>Do language models behave the same way?</a:t>
+              <a:t>Do language models follow the same rule?</a:t>
             </a:r>
             <a:endParaRPr lang="en-US" sz="1900" dirty="0"/>
           </a:p>
@@ -7680,7 +7627,7 @@
                 <a:ea typeface="Calibri" pitchFamily="34" charset="-122"/>
                 <a:cs typeface="Calibri" pitchFamily="34" charset="-120"/>
               </a:rPr>
-              <a:t>When most agents are language models making their own choices, do they stop where the prediction says?</a:t>
+              <a:t>Do they stop where the prediction says?</a:t>
             </a:r>
             <a:endParaRPr lang="en-US" sz="1400" dirty="0"/>
           </a:p>
@@ -7849,7 +7796,7 @@
                 <a:ea typeface="Calibri" pitchFamily="34" charset="-122"/>
                 <a:cs typeface="Calibri" pitchFamily="34" charset="-120"/>
               </a:rPr>
-              <a:t>Each round, every agent asks for a share; the reviewer predicts what the requests would do to the resource and scales them all by one factor; each agent then takes its allowance or more; the resource regrows; and a few agents are checked at random.</a:t>
+              <a:t>Agents request a share; the reviewer scales all requests by one factor; agents take their allowance or more; the resource regrows; random audits check a few agents.</a:t>
             </a:r>
             <a:endParaRPr lang="en-US" sz="1100" dirty="0"/>
           </a:p>
@@ -7888,7 +7835,7 @@
                 <a:ea typeface="Georgia" pitchFamily="34" charset="-122"/>
                 <a:cs typeface="Georgia" pitchFamily="34" charset="-120"/>
               </a:rPr>
-              <a:t>Harm = the resource falling below half its capacity, the level at which it regrows fastest</a:t>
+              <a:t>Harm = the resource below half capacity, the maximum-sustainable-yield level</a:t>
             </a:r>
             <a:endParaRPr lang="en-US" sz="1700" dirty="0"/>
           </a:p>
@@ -8097,7 +8044,7 @@
                 <a:ea typeface="Georgia" pitchFamily="34" charset="-122"/>
                 <a:cs typeface="Georgia" pitchFamily="34" charset="-120"/>
               </a:rPr>
-              <a:t>Run the setting</a:t>
+              <a:t>Measure the gain</a:t>
             </a:r>
             <a:endParaRPr lang="en-US" sz="1600" dirty="0"/>
           </a:p>
@@ -8136,7 +8083,7 @@
                 <a:ea typeface="Calibri" pitchFamily="34" charset="-122"/>
                 <a:cs typeface="Calibri" pitchFamily="34" charset="-120"/>
               </a:rPr>
-              <a:t>Six agents share the resource for many rounds; the reviewer sets allowances; a few agents are checked at random each round.</a:t>
+              <a:t>Play games without fines and record what one round of over-taking gains an agent.</a:t>
             </a:r>
             <a:endParaRPr lang="en-US" sz="1300" dirty="0"/>
           </a:p>
@@ -8214,7 +8161,7 @@
                 <a:ea typeface="Georgia" pitchFamily="34" charset="-122"/>
                 <a:cs typeface="Georgia" pitchFamily="34" charset="-120"/>
               </a:rPr>
-              <a:t>Measure the gain</a:t>
+              <a:t>Predict the stopping fine</a:t>
             </a:r>
             <a:endParaRPr lang="en-US" sz="1600" dirty="0"/>
           </a:p>
@@ -8253,7 +8200,7 @@
                 <a:ea typeface="Calibri" pitchFamily="34" charset="-122"/>
                 <a:cs typeface="Calibri" pitchFamily="34" charset="-120"/>
               </a:rPr>
-              <a:t>Run games without any fine and record how much an agent gains from one round of taking more than its allowance.</a:t>
+              <a:t>Over-taking should stop once the expected fine exceeds that gain.</a:t>
             </a:r>
             <a:endParaRPr lang="en-US" sz="1300" dirty="0"/>
           </a:p>
@@ -8331,7 +8278,7 @@
                 <a:ea typeface="Georgia" pitchFamily="34" charset="-122"/>
                 <a:cs typeface="Georgia" pitchFamily="34" charset="-120"/>
               </a:rPr>
-              <a:t>Predict, then freeze</a:t>
+              <a:t>Freeze the prediction</a:t>
             </a:r>
             <a:endParaRPr lang="en-US" sz="1600" dirty="0"/>
           </a:p>
@@ -8370,7 +8317,7 @@
                 <a:ea typeface="Calibri" pitchFamily="34" charset="-122"/>
                 <a:cs typeface="Calibri" pitchFamily="34" charset="-120"/>
               </a:rPr>
-              <a:t>Work out the fine that should stop over-taking and record the prediction before any game with that fine is run.</a:t>
+              <a:t>Record it before any game with that fine is played.</a:t>
             </a:r>
             <a:endParaRPr lang="en-US" sz="1300" dirty="0"/>
           </a:p>
@@ -8448,7 +8395,7 @@
                 <a:ea typeface="Georgia" pitchFamily="34" charset="-122"/>
                 <a:cs typeface="Georgia" pitchFamily="34" charset="-120"/>
               </a:rPr>
-              <a:t>Test on games the prediction never saw</a:t>
+              <a:t>Test on new games</a:t>
             </a:r>
             <a:endParaRPr lang="en-US" sz="1600" dirty="0"/>
           </a:p>
@@ -8487,7 +8434,7 @@
                 <a:ea typeface="Calibri" pitchFamily="34" charset="-122"/>
                 <a:cs typeface="Calibri" pitchFamily="34" charset="-120"/>
               </a:rPr>
-              <a:t>Run the predicted fine and the fines around it on new games, and report the result whether or not it matches.</a:t>
+              <a:t>Run the predicted fine and its neighbours on unseen games, and report the outcome either way.</a:t>
             </a:r>
             <a:endParaRPr lang="en-US" sz="1300" dirty="0"/>
           </a:p>
@@ -8638,7 +8585,7 @@
                 <a:ea typeface="Calibri" pitchFamily="34" charset="-122"/>
                 <a:cs typeface="Calibri" pitchFamily="34" charset="-120"/>
               </a:rPr>
-              <a:t>chance that an agent is checked in a round (1 in 6 for the language models)</a:t>
+              <a:t>audit probability per agent and round (1 in 6 for the language models)</a:t>
             </a:r>
             <a:endParaRPr lang="en-US" sz="1250" dirty="0"/>
           </a:p>
@@ -8716,7 +8663,7 @@
                 <a:ea typeface="Calibri" pitchFamily="34" charset="-122"/>
                 <a:cs typeface="Calibri" pitchFamily="34" charset="-120"/>
               </a:rPr>
-              <a:t>fine paid when a check finds an agent over its allowance</a:t>
+              <a:t>fine paid when an audit catches over-taking</a:t>
             </a:r>
             <a:endParaRPr lang="en-US" sz="1250" dirty="0"/>
           </a:p>
@@ -8794,7 +8741,7 @@
                 <a:ea typeface="Calibri" pitchFamily="34" charset="-122"/>
                 <a:cs typeface="Calibri" pitchFamily="34" charset="-120"/>
               </a:rPr>
-              <a:t>expected fine for one round of over-taking</a:t>
+              <a:t>expected fine per round of over-taking</a:t>
             </a:r>
             <a:endParaRPr lang="en-US" sz="1250" dirty="0"/>
           </a:p>
@@ -8872,7 +8819,7 @@
                 <a:ea typeface="Calibri" pitchFamily="34" charset="-122"/>
                 <a:cs typeface="Calibri" pitchFamily="34" charset="-120"/>
               </a:rPr>
-              <a:t>what an agent gains from one round of over-taking</a:t>
+              <a:t>gain from one round of over-taking</a:t>
             </a:r>
             <a:endParaRPr lang="en-US" sz="1250" dirty="0"/>
           </a:p>
@@ -8950,7 +8897,7 @@
                 <a:ea typeface="Calibri" pitchFamily="34" charset="-122"/>
                 <a:cs typeface="Calibri" pitchFamily="34" charset="-120"/>
               </a:rPr>
-              <a:t>the prediction: over-taking stops once the expected fine is larger than the gain (Becker 1968)</a:t>
+              <a:t>prediction: over-taking stops (Becker 1968)</a:t>
             </a:r>
             <a:endParaRPr lang="en-US" sz="1250" dirty="0"/>
           </a:p>
@@ -9120,7 +9067,7 @@
                 <a:ea typeface="Georgia" pitchFamily="34" charset="-122"/>
                 <a:cs typeface="Georgia" pitchFamily="34" charset="-120"/>
               </a:rPr>
-              <a:t>The setting</a:t>
+              <a:t>Setup</a:t>
             </a:r>
             <a:endParaRPr lang="en-US" sz="1700" dirty="0"/>
           </a:p>
@@ -9135,7 +9082,7 @@
         <p:spPr>
           <a:xfrm>
             <a:off x="548640" y="1929384"/>
-            <a:ext cx="4572000" cy="745236"/>
+            <a:ext cx="4572000" cy="297180"/>
           </a:xfrm>
           <a:prstGeom prst="rect">
             <a:avLst/>
@@ -9159,7 +9106,7 @@
                 <a:ea typeface="Calibri" pitchFamily="34" charset="-122"/>
                 <a:cs typeface="Calibri" pitchFamily="34" charset="-120"/>
               </a:rPr>
-              <a:t>Some agents report less than they intend to take, so the reviewer underestimates their use unless a check catches them.</a:t>
+              <a:t>Some agents under-report what they will take.</a:t>
             </a:r>
             <a:endParaRPr lang="en-US" sz="1400" dirty="0"/>
           </a:p>
@@ -9173,7 +9120,7 @@
         </p:nvSpPr>
         <p:spPr>
           <a:xfrm>
-            <a:off x="548640" y="2839212"/>
+            <a:off x="548640" y="2391156"/>
             <a:ext cx="4572000" cy="365760"/>
           </a:xfrm>
           <a:prstGeom prst="rect">
@@ -9198,7 +9145,7 @@
                 <a:ea typeface="Georgia" pitchFamily="34" charset="-122"/>
                 <a:cs typeface="Georgia" pitchFamily="34" charset="-120"/>
               </a:rPr>
-              <a:t>Checks without memory</a:t>
+              <a:t>Audits without memory</a:t>
             </a:r>
             <a:endParaRPr lang="en-US" sz="1700" dirty="0"/>
           </a:p>
@@ -9212,7 +9159,7 @@
         </p:nvSpPr>
         <p:spPr>
           <a:xfrm>
-            <a:off x="548640" y="3223260"/>
+            <a:off x="548640" y="2775204"/>
             <a:ext cx="4572000" cy="521208"/>
           </a:xfrm>
           <a:prstGeom prst="rect">
@@ -9237,7 +9184,7 @@
                 <a:ea typeface="Calibri" pitchFamily="34" charset="-122"/>
                 <a:cs typeface="Calibri" pitchFamily="34" charset="-120"/>
               </a:rPr>
-              <a:t>Correcting only the round in which a lie was caught removed 10–46% of the harm.</a:t>
+              <a:t>Correcting only the caught round removed 10–46% of the harm.</a:t>
             </a:r>
             <a:endParaRPr lang="en-US" sz="1400" dirty="0"/>
           </a:p>
@@ -9251,7 +9198,7 @@
         </p:nvSpPr>
         <p:spPr>
           <a:xfrm>
-            <a:off x="548640" y="3909060"/>
+            <a:off x="548640" y="3461004"/>
             <a:ext cx="4572000" cy="365760"/>
           </a:xfrm>
           <a:prstGeom prst="rect">
@@ -9276,7 +9223,7 @@
                 <a:ea typeface="Georgia" pitchFamily="34" charset="-122"/>
                 <a:cs typeface="Georgia" pitchFamily="34" charset="-120"/>
               </a:rPr>
-              <a:t>Checks with memory</a:t>
+              <a:t>Audits with memory</a:t>
             </a:r>
             <a:endParaRPr lang="en-US" sz="1700" dirty="0"/>
           </a:p>
@@ -9290,8 +9237,8 @@
         </p:nvSpPr>
         <p:spPr>
           <a:xfrm>
-            <a:off x="548640" y="4293108"/>
-            <a:ext cx="4572000" cy="969264"/>
+            <a:off x="548640" y="3845052"/>
+            <a:ext cx="4572000" cy="745236"/>
           </a:xfrm>
           <a:prstGeom prst="rect">
             <a:avLst/>
@@ -9315,7 +9262,7 @@
                 <a:ea typeface="Calibri" pitchFamily="34" charset="-122"/>
                 <a:cs typeface="Calibri" pitchFamily="34" charset="-120"/>
               </a:rPr>
-              <a:t>Remembering each caught lie and adjusting that agent's later allowances reduced harm in all 12 settings tested. In Fishery, rounds below half capacity fell from 43–99% to 0.3–3%.</a:t>
+              <a:t>Remembering each caught lie reduced harm in 12 of 12 settings. In Fishery, rounds below half capacity fell from 43–99% to under 3%.</a:t>
             </a:r>
             <a:endParaRPr lang="en-US" sz="1400" dirty="0"/>
           </a:p>
@@ -9378,7 +9325,7 @@
                 <a:ea typeface="Calibri" pitchFamily="34" charset="-122"/>
                 <a:cs typeface="Calibri" pitchFamily="34" charset="-120"/>
               </a:rPr>
-              <a:t>Share of rounds below half capacity when some agents under-report. Dark: no checks. Light: checks without memory. Green: checks with memory. Each group has four settings: 2 or 4 misbehaving agents (2g, 4g) and two regrowth rates (1.0 and 0.85 of normal).</a:t>
+              <a:t>Rounds below half capacity with under-reporting agents. Dark: no audits. Light: audits without memory. Green: audits with memory. 2g/4g = 2 or 4 misbehaving agents; 1.0/0.85 = regrowth rate.</a:t>
             </a:r>
             <a:endParaRPr lang="en-US" sz="1100" dirty="0"/>
           </a:p>
@@ -9548,7 +9495,7 @@
                 <a:ea typeface="Georgia" pitchFamily="34" charset="-122"/>
                 <a:cs typeface="Georgia" pitchFamily="34" charset="-120"/>
               </a:rPr>
-              <a:t>What was predicted</a:t>
+              <a:t>Prediction</a:t>
             </a:r>
             <a:endParaRPr lang="en-US" sz="1700" dirty="0"/>
           </a:p>
@@ -9563,7 +9510,7 @@
         <p:spPr>
           <a:xfrm>
             <a:off x="7071055" y="1929384"/>
-            <a:ext cx="4572000" cy="969264"/>
+            <a:ext cx="4572000" cy="521208"/>
           </a:xfrm>
           <a:prstGeom prst="rect">
             <a:avLst/>
@@ -9587,7 +9534,7 @@
                 <a:ea typeface="Calibri" pitchFamily="34" charset="-122"/>
                 <a:cs typeface="Calibri" pitchFamily="34" charset="-120"/>
               </a:rPr>
-              <a:t>Programmed agents choose how much to over-take so as to earn the most. From games without checks, we predicted the expected fine at which they would stop.</a:t>
+              <a:t>From games without audits, we predicted the expected fine at which programmed cheaters would stop.</a:t>
             </a:r>
             <a:endParaRPr lang="en-US" sz="1400" dirty="0"/>
           </a:p>
@@ -9601,7 +9548,7 @@
         </p:nvSpPr>
         <p:spPr>
           <a:xfrm>
-            <a:off x="7071055" y="3063240"/>
+            <a:off x="7071055" y="2615184"/>
             <a:ext cx="4572000" cy="365760"/>
           </a:xfrm>
           <a:prstGeom prst="rect">
@@ -9626,7 +9573,7 @@
                 <a:ea typeface="Georgia" pitchFamily="34" charset="-122"/>
                 <a:cs typeface="Georgia" pitchFamily="34" charset="-120"/>
               </a:rPr>
-              <a:t>The result</a:t>
+              <a:t>Result</a:t>
             </a:r>
             <a:endParaRPr lang="en-US" sz="1700" dirty="0"/>
           </a:p>
@@ -9640,7 +9587,7 @@
         </p:nvSpPr>
         <p:spPr>
           <a:xfrm>
-            <a:off x="7071055" y="3447288"/>
+            <a:off x="7071055" y="2999232"/>
             <a:ext cx="4572000" cy="521208"/>
           </a:xfrm>
           <a:prstGeom prst="rect">
@@ -9665,7 +9612,7 @@
                 <a:ea typeface="Calibri" pitchFamily="34" charset="-122"/>
                 <a:cs typeface="Calibri" pitchFamily="34" charset="-120"/>
               </a:rPr>
-              <a:t>In 5 of 5 new settings, the observed stopping point was within one step of the prediction.</a:t>
+              <a:t>5 of 5 new settings landed within one step of the prediction.</a:t>
             </a:r>
             <a:endParaRPr lang="en-US" sz="1400" dirty="0"/>
           </a:p>
@@ -9679,7 +9626,7 @@
         </p:nvSpPr>
         <p:spPr>
           <a:xfrm>
-            <a:off x="7071055" y="4133088"/>
+            <a:off x="7071055" y="3685032"/>
             <a:ext cx="4572000" cy="365760"/>
           </a:xfrm>
           <a:prstGeom prst="rect">
@@ -9704,7 +9651,7 @@
                 <a:ea typeface="Georgia" pitchFamily="34" charset="-122"/>
                 <a:cs typeface="Georgia" pitchFamily="34" charset="-120"/>
               </a:rPr>
-              <a:t>Why this comes first</a:t>
+              <a:t>Caveat</a:t>
             </a:r>
             <a:endParaRPr lang="en-US" sz="1700" dirty="0"/>
           </a:p>
@@ -9718,8 +9665,8 @@
         </p:nvSpPr>
         <p:spPr>
           <a:xfrm>
-            <a:off x="7071055" y="4517136"/>
-            <a:ext cx="4572000" cy="745236"/>
+            <a:off x="7071055" y="4069080"/>
+            <a:ext cx="4572000" cy="521208"/>
           </a:xfrm>
           <a:prstGeom prst="rect">
             <a:avLst/>
@@ -9743,7 +9690,7 @@
                 <a:ea typeface="Calibri" pitchFamily="34" charset="-122"/>
                 <a:cs typeface="Calibri" pitchFamily="34" charset="-120"/>
               </a:rPr>
-              <a:t>These agents are built to maximise their payoff, so this checks the measurement method before it is used on language models.</a:t>
+              <a:t>These agents optimise by design, so this validates the method before it is used on language models.</a:t>
             </a:r>
             <a:endParaRPr lang="en-US" sz="1400" dirty="0"/>
           </a:p>
@@ -9765,8 +9712,8 @@
         </p:blipFill>
         <p:spPr>
           <a:xfrm>
-            <a:off x="666094" y="1499616"/>
-            <a:ext cx="5876027" cy="3941064"/>
+            <a:off x="548640" y="1512279"/>
+            <a:ext cx="6110935" cy="4098618"/>
           </a:xfrm>
           <a:prstGeom prst="rect">
             <a:avLst/>
@@ -9781,7 +9728,7 @@
         </p:nvSpPr>
         <p:spPr>
           <a:xfrm>
-            <a:off x="548640" y="5550408"/>
+            <a:off x="548640" y="5720625"/>
             <a:ext cx="6110935" cy="502920"/>
           </a:xfrm>
           <a:prstGeom prst="rect">
@@ -9806,7 +9753,7 @@
                 <a:ea typeface="Calibri" pitchFamily="34" charset="-122"/>
                 <a:cs typeface="Calibri" pitchFamily="34" charset="-120"/>
               </a:rPr>
-              <a:t>Observed against predicted stopping point (expected fine). Filled: new settings predicted in advance. Open: the checking rate, or the chance that a check catches the cheat, was varied. The band marks one step of the tested grid.</a:t>
+              <a:t>Observed against predicted stopping point. Filled: new settings, predicted first. Open: audit probability or detection varied.</a:t>
             </a:r>
             <a:endParaRPr lang="en-US" sz="1100" dirty="0"/>
           </a:p>
@@ -9975,7 +9922,7 @@
                 <a:ea typeface="Calibri" pitchFamily="34" charset="-122"/>
                 <a:cs typeface="Calibri" pitchFamily="34" charset="-120"/>
               </a:rPr>
-              <a:t>Lowering every agent's allowance to make up for known cheaters let the cheaters gain more than with no checks at all (142 vs 113); honest agents paid for it.</a:t>
+              <a:t>Cutting everyone's allowance to absorb cheaters: cheaters gained more than with no audits (142 vs 113).</a:t>
             </a:r>
             <a:endParaRPr lang="en-US" sz="1100" dirty="0"/>
           </a:p>
@@ -10038,7 +9985,7 @@
                 <a:ea typeface="Calibri" pitchFamily="34" charset="-122"/>
                 <a:cs typeface="Calibri" pitchFamily="34" charset="-120"/>
               </a:rPr>
-              <a:t>Always checking the agent with the largest report caught 25% of liars over a game, against 100% with random checks: the largest reporter is often honest.</a:t>
+              <a:t>Always auditing the largest report: 25% of liars caught, against 100% with random audits.</a:t>
             </a:r>
             <a:endParaRPr lang="en-US" sz="1100" dirty="0"/>
           </a:p>
@@ -10077,7 +10024,7 @@
                 <a:ea typeface="Georgia" pitchFamily="34" charset="-122"/>
                 <a:cs typeface="Georgia" pitchFamily="34" charset="-120"/>
               </a:rPr>
-              <a:t>Shortcuts that save checks can open blind spots</a:t>
+              <a:t>Shortcuts that save audits create blind spots</a:t>
             </a:r>
             <a:endParaRPr lang="en-US" sz="1700" dirty="0"/>
           </a:p>

</xml_diff>

<commit_message>
Slide 12 redrawn as a two-panel chart for both models (one decimal, 95% intervals); script and Q&A explain the two 20% figures
Co-Authored-By: Claude Opus 5.5 <noreply@anthropic.com>
</commit_message>
<xml_diff>
--- a/notes/slides/2026-10-13_phd_catchup/phd_catchup_2026-10-13.pptx
+++ b/notes/slides/2026-10-13_phd_catchup/phd_catchup_2026-10-13.pptx
@@ -781,7 +781,7 @@
           <a:p>
             <a:r>
               <a:rPr lang="en-US" dirty="0"/>
-              <a:t>Memory works for language models too. With audits and memory but no fine, over-taking fell from 55 to 20 percent, and no lake collapsed. Memory reduces over-taking but doesn't stop it; a large enough fine does, with no loss of efficiency.</a:t>
+              <a:t>Memory protects the lake even without a fine. Same audits in both conditions, a one-in-six chance, no fine. With memory, over-taking fell from 55 to 20 percent of decisions for gpt-oss and from 65 to 33 for Nemotron, so it reduced over-taking but didn't stop it. The lake did much better: below half capacity in about a fifth of rounds instead of nine in ten for gpt-oss, and no lake collapsed. The two 20s for gpt-oss are a coincidence: one counts decisions, the other counts rounds. A fine above the gain is what stops over-taking completely.</a:t>
             </a:r>
             <a:endParaRPr lang="en-US" dirty="0"/>
           </a:p>
@@ -3109,7 +3109,7 @@
                 <a:ea typeface="Georgia" pitchFamily="34" charset="-122"/>
                 <a:cs typeface="Georgia" pitchFamily="34" charset="-120"/>
               </a:rPr>
-              <a:t>Memory Works for Language Models Too</a:t>
+              <a:t>Memory Protects the Lake Without a Fine</a:t>
             </a:r>
             <a:endParaRPr lang="en-US" sz="3400" dirty="0"/>
           </a:p>
@@ -3142,37 +3142,42 @@
       </p:sp>
       <p:sp>
         <p:nvSpPr>
-          <p:cNvPr id="4" name="Shape 2"/>
-          <p:cNvSpPr/>
-          <p:nvPr/>
-        </p:nvSpPr>
-        <p:spPr>
-          <a:xfrm>
-            <a:off x="548640" y="1591056"/>
-            <a:ext cx="6583680" cy="3474720"/>
-          </a:xfrm>
-          <a:prstGeom prst="roundRect">
-            <a:avLst>
-              <a:gd name="adj" fmla="val 2105"/>
-            </a:avLst>
-          </a:prstGeom>
-          <a:solidFill>
-            <a:srgbClr val="FFFFFF"/>
-          </a:solidFill>
-          <a:ln w="9525">
-            <a:solidFill>
-              <a:srgbClr val="E9E7E3"/>
-            </a:solidFill>
-            <a:prstDash val="solid"/>
-          </a:ln>
-          <a:effectLst>
-            <a:outerShdw sx="100000" sy="100000" kx="0" ky="0" algn="bl" rotWithShape="0" blurRad="76200" dist="25400" dir="5400000">
-              <a:srgbClr val="000000">
-                <a:alpha val="8000"/>
-              </a:srgbClr>
-            </a:outerShdw>
-          </a:effectLst>
-        </p:spPr>
+          <p:cNvPr id="4" name="Text 2"/>
+          <p:cNvSpPr txBox="1"/>
+          <p:nvPr/>
+        </p:nvSpPr>
+        <p:spPr>
+          <a:xfrm>
+            <a:off x="548640" y="1545336"/>
+            <a:ext cx="4023360" cy="365760"/>
+          </a:xfrm>
+          <a:prstGeom prst="rect">
+            <a:avLst/>
+          </a:prstGeom>
+          <a:noFill/>
+          <a:ln/>
+        </p:spPr>
+        <p:txBody>
+          <a:bodyPr wrap="square" lIns="0" tIns="0" rIns="0" bIns="0" rtlCol="0" anchor="t"/>
+          <a:lstStyle/>
+          <a:p>
+            <a:pPr indent="0" marL="0">
+              <a:buNone/>
+            </a:pPr>
+            <a:r>
+              <a:rPr lang="en-US" sz="1700" b="1" dirty="0">
+                <a:solidFill>
+                  <a:srgbClr val="1C191A"/>
+                </a:solidFill>
+                <a:latin typeface="Georgia" pitchFamily="34" charset="0"/>
+                <a:ea typeface="Georgia" pitchFamily="34" charset="-122"/>
+                <a:cs typeface="Georgia" pitchFamily="34" charset="-120"/>
+              </a:rPr>
+              <a:t>Same audits, no fine</a:t>
+            </a:r>
+            <a:endParaRPr lang="en-US" sz="1700" dirty="0"/>
+          </a:p>
+        </p:txBody>
       </p:sp>
       <p:sp>
         <p:nvSpPr>
@@ -3182,34 +3187,34 @@
         </p:nvSpPr>
         <p:spPr>
           <a:xfrm>
-            <a:off x="3429000" y="1819656"/>
-            <a:ext cx="1783080" cy="457200"/>
-          </a:xfrm>
-          <a:prstGeom prst="rect">
-            <a:avLst/>
-          </a:prstGeom>
-          <a:noFill/>
-          <a:ln/>
-        </p:spPr>
-        <p:txBody>
-          <a:bodyPr wrap="square" lIns="0" tIns="0" rIns="0" bIns="0" rtlCol="0" anchor="b"/>
-          <a:lstStyle/>
-          <a:p>
-            <a:pPr algn="ctr" indent="0" marL="0">
-              <a:buNone/>
-            </a:pPr>
-            <a:r>
-              <a:rPr lang="en-US" sz="1200" b="1" dirty="0">
-                <a:solidFill>
-                  <a:srgbClr val="8F8F8F"/>
+            <a:off x="548640" y="1929384"/>
+            <a:ext cx="4023360" cy="745236"/>
+          </a:xfrm>
+          <a:prstGeom prst="rect">
+            <a:avLst/>
+          </a:prstGeom>
+          <a:noFill/>
+          <a:ln/>
+        </p:spPr>
+        <p:txBody>
+          <a:bodyPr wrap="square" lIns="0" tIns="0" rIns="0" bIns="0" rtlCol="0" anchor="t"/>
+          <a:lstStyle/>
+          <a:p>
+            <a:pPr algn="l" indent="0" marL="0">
+              <a:buNone/>
+            </a:pPr>
+            <a:r>
+              <a:rPr lang="en-US" sz="1400" dirty="0">
+                <a:solidFill>
+                  <a:srgbClr val="1C191A"/>
                 </a:solidFill>
                 <a:latin typeface="Calibri" pitchFamily="34" charset="0"/>
                 <a:ea typeface="Calibri" pitchFamily="34" charset="-122"/>
                 <a:cs typeface="Calibri" pitchFamily="34" charset="-120"/>
               </a:rPr>
-              <a:t>Audits only</a:t>
-            </a:r>
-            <a:endParaRPr lang="en-US" sz="1200" dirty="0"/>
+              <a:t>Audit probability 1 in 6 in both conditions. With memory, a caught model's later allowances drop by what it over-took.</a:t>
+            </a:r>
+            <a:endParaRPr lang="en-US" sz="1400" dirty="0"/>
           </a:p>
         </p:txBody>
       </p:sp>
@@ -3221,63 +3226,141 @@
         </p:nvSpPr>
         <p:spPr>
           <a:xfrm>
-            <a:off x="5257800" y="1819656"/>
-            <a:ext cx="1783080" cy="457200"/>
-          </a:xfrm>
-          <a:prstGeom prst="rect">
-            <a:avLst/>
-          </a:prstGeom>
-          <a:noFill/>
-          <a:ln/>
-        </p:spPr>
-        <p:txBody>
-          <a:bodyPr wrap="square" lIns="0" tIns="0" rIns="0" bIns="0" rtlCol="0" anchor="b"/>
-          <a:lstStyle/>
-          <a:p>
-            <a:pPr algn="ctr" indent="0" marL="0">
-              <a:buNone/>
-            </a:pPr>
-            <a:r>
-              <a:rPr lang="en-US" sz="1200" b="1" dirty="0">
-                <a:solidFill>
-                  <a:srgbClr val="062746"/>
+            <a:off x="548640" y="2839212"/>
+            <a:ext cx="4023360" cy="365760"/>
+          </a:xfrm>
+          <a:prstGeom prst="rect">
+            <a:avLst/>
+          </a:prstGeom>
+          <a:noFill/>
+          <a:ln/>
+        </p:spPr>
+        <p:txBody>
+          <a:bodyPr wrap="square" lIns="0" tIns="0" rIns="0" bIns="0" rtlCol="0" anchor="t"/>
+          <a:lstStyle/>
+          <a:p>
+            <a:pPr indent="0" marL="0">
+              <a:buNone/>
+            </a:pPr>
+            <a:r>
+              <a:rPr lang="en-US" sz="1700" b="1" dirty="0">
+                <a:solidFill>
+                  <a:srgbClr val="1C191A"/>
+                </a:solidFill>
+                <a:latin typeface="Georgia" pitchFamily="34" charset="0"/>
+                <a:ea typeface="Georgia" pitchFamily="34" charset="-122"/>
+                <a:cs typeface="Georgia" pitchFamily="34" charset="-120"/>
+              </a:rPr>
+              <a:t>Over-taking fell, but didn't stop</a:t>
+            </a:r>
+            <a:endParaRPr lang="en-US" sz="1700" dirty="0"/>
+          </a:p>
+        </p:txBody>
+      </p:sp>
+      <p:sp>
+        <p:nvSpPr>
+          <p:cNvPr id="7" name="Text 5"/>
+          <p:cNvSpPr txBox="1"/>
+          <p:nvPr/>
+        </p:nvSpPr>
+        <p:spPr>
+          <a:xfrm>
+            <a:off x="548640" y="3223260"/>
+            <a:ext cx="4023360" cy="521208"/>
+          </a:xfrm>
+          <a:prstGeom prst="rect">
+            <a:avLst/>
+          </a:prstGeom>
+          <a:noFill/>
+          <a:ln/>
+        </p:spPr>
+        <p:txBody>
+          <a:bodyPr wrap="square" lIns="0" tIns="0" rIns="0" bIns="0" rtlCol="0" anchor="t"/>
+          <a:lstStyle/>
+          <a:p>
+            <a:pPr algn="l" indent="0" marL="0">
+              <a:buNone/>
+            </a:pPr>
+            <a:r>
+              <a:rPr lang="en-US" sz="1400" dirty="0">
+                <a:solidFill>
+                  <a:srgbClr val="1C191A"/>
                 </a:solidFill>
                 <a:latin typeface="Calibri" pitchFamily="34" charset="0"/>
                 <a:ea typeface="Calibri" pitchFamily="34" charset="-122"/>
                 <a:cs typeface="Calibri" pitchFamily="34" charset="-120"/>
               </a:rPr>
-              <a:t>Audits + memory</a:t>
-            </a:r>
-            <a:endParaRPr lang="en-US" sz="1200" dirty="0"/>
-          </a:p>
-        </p:txBody>
-      </p:sp>
-      <p:sp>
-        <p:nvSpPr>
-          <p:cNvPr id="7" name="Text 5"/>
-          <p:cNvSpPr txBox="1"/>
-          <p:nvPr/>
-        </p:nvSpPr>
-        <p:spPr>
-          <a:xfrm>
-            <a:off x="822960" y="2414016"/>
-            <a:ext cx="2651760" cy="685800"/>
-          </a:xfrm>
-          <a:prstGeom prst="rect">
-            <a:avLst/>
-          </a:prstGeom>
-          <a:noFill/>
-          <a:ln/>
-        </p:spPr>
-        <p:txBody>
-          <a:bodyPr wrap="square" lIns="0" tIns="0" rIns="0" bIns="0" rtlCol="0" anchor="ctr"/>
+              <a:t>Both models still over-took in a fifth to a third of their decisions.</a:t>
+            </a:r>
+            <a:endParaRPr lang="en-US" sz="1400" dirty="0"/>
+          </a:p>
+        </p:txBody>
+      </p:sp>
+      <p:sp>
+        <p:nvSpPr>
+          <p:cNvPr id="8" name="Text 6"/>
+          <p:cNvSpPr txBox="1"/>
+          <p:nvPr/>
+        </p:nvSpPr>
+        <p:spPr>
+          <a:xfrm>
+            <a:off x="548640" y="3909060"/>
+            <a:ext cx="4023360" cy="365760"/>
+          </a:xfrm>
+          <a:prstGeom prst="rect">
+            <a:avLst/>
+          </a:prstGeom>
+          <a:noFill/>
+          <a:ln/>
+        </p:spPr>
+        <p:txBody>
+          <a:bodyPr wrap="square" lIns="0" tIns="0" rIns="0" bIns="0" rtlCol="0" anchor="t"/>
           <a:lstStyle/>
           <a:p>
             <a:pPr indent="0" marL="0">
               <a:buNone/>
             </a:pPr>
             <a:r>
-              <a:rPr lang="en-US" sz="1350" dirty="0">
+              <a:rPr lang="en-US" sz="1700" b="1" dirty="0">
+                <a:solidFill>
+                  <a:srgbClr val="1C191A"/>
+                </a:solidFill>
+                <a:latin typeface="Georgia" pitchFamily="34" charset="0"/>
+                <a:ea typeface="Georgia" pitchFamily="34" charset="-122"/>
+                <a:cs typeface="Georgia" pitchFamily="34" charset="-120"/>
+              </a:rPr>
+              <a:t>The lake recovered</a:t>
+            </a:r>
+            <a:endParaRPr lang="en-US" sz="1700" dirty="0"/>
+          </a:p>
+        </p:txBody>
+      </p:sp>
+      <p:sp>
+        <p:nvSpPr>
+          <p:cNvPr id="9" name="Text 7"/>
+          <p:cNvSpPr txBox="1"/>
+          <p:nvPr/>
+        </p:nvSpPr>
+        <p:spPr>
+          <a:xfrm>
+            <a:off x="548640" y="4293108"/>
+            <a:ext cx="4023360" cy="745236"/>
+          </a:xfrm>
+          <a:prstGeom prst="rect">
+            <a:avLst/>
+          </a:prstGeom>
+          <a:noFill/>
+          <a:ln/>
+        </p:spPr>
+        <p:txBody>
+          <a:bodyPr wrap="square" lIns="0" tIns="0" rIns="0" bIns="0" rtlCol="0" anchor="t"/>
+          <a:lstStyle/>
+          <a:p>
+            <a:pPr algn="l" indent="0" marL="0">
+              <a:buNone/>
+            </a:pPr>
+            <a:r>
+              <a:rPr lang="en-US" sz="1400" dirty="0">
                 <a:solidFill>
                   <a:srgbClr val="1C191A"/>
                 </a:solidFill>
@@ -3285,521 +3368,70 @@
                 <a:ea typeface="Calibri" pitchFamily="34" charset="-122"/>
                 <a:cs typeface="Calibri" pitchFamily="34" charset="-120"/>
               </a:rPr>
-              <a:t>Rounds with over-taking</a:t>
-            </a:r>
-            <a:endParaRPr lang="en-US" sz="1350" dirty="0"/>
-          </a:p>
-        </p:txBody>
-      </p:sp>
-      <p:sp>
-        <p:nvSpPr>
-          <p:cNvPr id="8" name="Text 6"/>
-          <p:cNvSpPr txBox="1"/>
-          <p:nvPr/>
-        </p:nvSpPr>
-        <p:spPr>
-          <a:xfrm>
-            <a:off x="3429000" y="2414016"/>
-            <a:ext cx="1783080" cy="685800"/>
-          </a:xfrm>
-          <a:prstGeom prst="rect">
-            <a:avLst/>
-          </a:prstGeom>
-          <a:noFill/>
-          <a:ln/>
-        </p:spPr>
-        <p:txBody>
-          <a:bodyPr wrap="square" lIns="0" tIns="0" rIns="0" bIns="0" rtlCol="0" anchor="ctr"/>
+              <a:t>No lake collapsed with memory (without: 5 and 1 of 10). Rule-following fishers caught 29 to 32 t, against 8 to 9 t.</a:t>
+            </a:r>
+            <a:endParaRPr lang="en-US" sz="1400" dirty="0"/>
+          </a:p>
+        </p:txBody>
+      </p:sp>
+      <p:pic>
+        <p:nvPicPr>
+          <p:cNvPr id="10" name="Image 0" descr="memory_llm.png">    </p:cNvPr>
+          <p:cNvPicPr>
+            <a:picLocks noChangeAspect="1"/>
+          </p:cNvPicPr>
+          <p:nvPr/>
+        </p:nvPicPr>
+        <p:blipFill>
+          <a:blip r:embed="rId1"/>
+          <a:stretch>
+            <a:fillRect/>
+          </a:stretch>
+        </p:blipFill>
+        <p:spPr>
+          <a:xfrm>
+            <a:off x="4983480" y="1885590"/>
+            <a:ext cx="6659575" cy="3169116"/>
+          </a:xfrm>
+          <a:prstGeom prst="rect">
+            <a:avLst/>
+          </a:prstGeom>
+        </p:spPr>
+      </p:pic>
+      <p:sp>
+        <p:nvSpPr>
+          <p:cNvPr id="11" name="Text 8"/>
+          <p:cNvSpPr txBox="1"/>
+          <p:nvPr/>
+        </p:nvSpPr>
+        <p:spPr>
+          <a:xfrm>
+            <a:off x="4983480" y="5164434"/>
+            <a:ext cx="6659575" cy="502920"/>
+          </a:xfrm>
+          <a:prstGeom prst="rect">
+            <a:avLst/>
+          </a:prstGeom>
+          <a:noFill/>
+          <a:ln/>
+        </p:spPr>
+        <p:txBody>
+          <a:bodyPr wrap="square" lIns="0" tIns="0" rIns="0" bIns="0" rtlCol="0" anchor="t"/>
           <a:lstStyle/>
           <a:p>
             <a:pPr algn="ctr" indent="0" marL="0">
               <a:buNone/>
             </a:pPr>
             <a:r>
-              <a:rPr lang="en-US" sz="2600" dirty="0">
-                <a:solidFill>
-                  <a:srgbClr val="8F8F8F"/>
-                </a:solidFill>
-                <a:latin typeface="Georgia" pitchFamily="34" charset="0"/>
-                <a:ea typeface="Georgia" pitchFamily="34" charset="-122"/>
-                <a:cs typeface="Georgia" pitchFamily="34" charset="-120"/>
-              </a:rPr>
-              <a:t>55%</a:t>
-            </a:r>
-            <a:endParaRPr lang="en-US" sz="2600" dirty="0"/>
-          </a:p>
-        </p:txBody>
-      </p:sp>
-      <p:sp>
-        <p:nvSpPr>
-          <p:cNvPr id="9" name="Text 7"/>
-          <p:cNvSpPr txBox="1"/>
-          <p:nvPr/>
-        </p:nvSpPr>
-        <p:spPr>
-          <a:xfrm>
-            <a:off x="5029200" y="2414016"/>
-            <a:ext cx="457200" cy="685800"/>
-          </a:xfrm>
-          <a:prstGeom prst="rect">
-            <a:avLst/>
-          </a:prstGeom>
-          <a:noFill/>
-          <a:ln/>
-        </p:spPr>
-        <p:txBody>
-          <a:bodyPr wrap="square" lIns="0" tIns="0" rIns="0" bIns="0" rtlCol="0" anchor="ctr"/>
-          <a:lstStyle/>
-          <a:p>
-            <a:pPr algn="ctr" indent="0" marL="0">
-              <a:buNone/>
-            </a:pPr>
-            <a:r>
-              <a:rPr lang="en-US" sz="2000" dirty="0">
-                <a:solidFill>
-                  <a:srgbClr val="8F8F8F"/>
+              <a:rPr lang="en-US" sz="1100" i="1" dirty="0">
+                <a:solidFill>
+                  <a:srgbClr val="55524E"/>
                 </a:solidFill>
                 <a:latin typeface="Calibri" pitchFamily="34" charset="0"/>
                 <a:ea typeface="Calibri" pitchFamily="34" charset="-122"/>
                 <a:cs typeface="Calibri" pitchFamily="34" charset="-120"/>
               </a:rPr>
-              <a:t>→</a:t>
-            </a:r>
-            <a:endParaRPr lang="en-US" sz="2000" dirty="0"/>
-          </a:p>
-        </p:txBody>
-      </p:sp>
-      <p:sp>
-        <p:nvSpPr>
-          <p:cNvPr id="10" name="Text 8"/>
-          <p:cNvSpPr txBox="1"/>
-          <p:nvPr/>
-        </p:nvSpPr>
-        <p:spPr>
-          <a:xfrm>
-            <a:off x="5257800" y="2414016"/>
-            <a:ext cx="1783080" cy="685800"/>
-          </a:xfrm>
-          <a:prstGeom prst="rect">
-            <a:avLst/>
-          </a:prstGeom>
-          <a:noFill/>
-          <a:ln/>
-        </p:spPr>
-        <p:txBody>
-          <a:bodyPr wrap="square" lIns="0" tIns="0" rIns="0" bIns="0" rtlCol="0" anchor="ctr"/>
-          <a:lstStyle/>
-          <a:p>
-            <a:pPr algn="ctr" indent="0" marL="0">
-              <a:buNone/>
-            </a:pPr>
-            <a:r>
-              <a:rPr lang="en-US" sz="2600" b="1" dirty="0">
-                <a:solidFill>
-                  <a:srgbClr val="062746"/>
-                </a:solidFill>
-                <a:latin typeface="Georgia" pitchFamily="34" charset="0"/>
-                <a:ea typeface="Georgia" pitchFamily="34" charset="-122"/>
-                <a:cs typeface="Georgia" pitchFamily="34" charset="-120"/>
-              </a:rPr>
-              <a:t>20%</a:t>
-            </a:r>
-            <a:endParaRPr lang="en-US" sz="2600" dirty="0"/>
-          </a:p>
-        </p:txBody>
-      </p:sp>
-      <p:sp>
-        <p:nvSpPr>
-          <p:cNvPr id="11" name="Shape 9"/>
-          <p:cNvSpPr/>
-          <p:nvPr/>
-        </p:nvSpPr>
-        <p:spPr>
-          <a:xfrm>
-            <a:off x="822960" y="3191256"/>
-            <a:ext cx="6035040" cy="0"/>
-          </a:xfrm>
-          <a:prstGeom prst="line">
-            <a:avLst/>
-          </a:prstGeom>
-          <a:noFill/>
-          <a:ln w="9525">
-            <a:solidFill>
-              <a:srgbClr val="E9E7E3"/>
-            </a:solidFill>
-            <a:prstDash val="solid"/>
-          </a:ln>
-        </p:spPr>
-      </p:sp>
-      <p:sp>
-        <p:nvSpPr>
-          <p:cNvPr id="12" name="Text 10"/>
-          <p:cNvSpPr txBox="1"/>
-          <p:nvPr/>
-        </p:nvSpPr>
-        <p:spPr>
-          <a:xfrm>
-            <a:off x="822960" y="3282696"/>
-            <a:ext cx="2651760" cy="685800"/>
-          </a:xfrm>
-          <a:prstGeom prst="rect">
-            <a:avLst/>
-          </a:prstGeom>
-          <a:noFill/>
-          <a:ln/>
-        </p:spPr>
-        <p:txBody>
-          <a:bodyPr wrap="square" lIns="0" tIns="0" rIns="0" bIns="0" rtlCol="0" anchor="ctr"/>
-          <a:lstStyle/>
-          <a:p>
-            <a:pPr indent="0" marL="0">
-              <a:buNone/>
-            </a:pPr>
-            <a:r>
-              <a:rPr lang="en-US" sz="1350" dirty="0">
-                <a:solidFill>
-                  <a:srgbClr val="1C191A"/>
-                </a:solidFill>
-                <a:latin typeface="Calibri" pitchFamily="34" charset="0"/>
-                <a:ea typeface="Calibri" pitchFamily="34" charset="-122"/>
-                <a:cs typeface="Calibri" pitchFamily="34" charset="-120"/>
-              </a:rPr>
-              <a:t>Rounds below half capacity</a:t>
-            </a:r>
-            <a:endParaRPr lang="en-US" sz="1350" dirty="0"/>
-          </a:p>
-        </p:txBody>
-      </p:sp>
-      <p:sp>
-        <p:nvSpPr>
-          <p:cNvPr id="13" name="Text 11"/>
-          <p:cNvSpPr txBox="1"/>
-          <p:nvPr/>
-        </p:nvSpPr>
-        <p:spPr>
-          <a:xfrm>
-            <a:off x="3429000" y="3282696"/>
-            <a:ext cx="1783080" cy="685800"/>
-          </a:xfrm>
-          <a:prstGeom prst="rect">
-            <a:avLst/>
-          </a:prstGeom>
-          <a:noFill/>
-          <a:ln/>
-        </p:spPr>
-        <p:txBody>
-          <a:bodyPr wrap="square" lIns="0" tIns="0" rIns="0" bIns="0" rtlCol="0" anchor="ctr"/>
-          <a:lstStyle/>
-          <a:p>
-            <a:pPr algn="ctr" indent="0" marL="0">
-              <a:buNone/>
-            </a:pPr>
-            <a:r>
-              <a:rPr lang="en-US" sz="2600" dirty="0">
-                <a:solidFill>
-                  <a:srgbClr val="8F8F8F"/>
-                </a:solidFill>
-                <a:latin typeface="Georgia" pitchFamily="34" charset="0"/>
-                <a:ea typeface="Georgia" pitchFamily="34" charset="-122"/>
-                <a:cs typeface="Georgia" pitchFamily="34" charset="-120"/>
-              </a:rPr>
-              <a:t>92%</a:t>
-            </a:r>
-            <a:endParaRPr lang="en-US" sz="2600" dirty="0"/>
-          </a:p>
-        </p:txBody>
-      </p:sp>
-      <p:sp>
-        <p:nvSpPr>
-          <p:cNvPr id="14" name="Text 12"/>
-          <p:cNvSpPr txBox="1"/>
-          <p:nvPr/>
-        </p:nvSpPr>
-        <p:spPr>
-          <a:xfrm>
-            <a:off x="5029200" y="3282696"/>
-            <a:ext cx="457200" cy="685800"/>
-          </a:xfrm>
-          <a:prstGeom prst="rect">
-            <a:avLst/>
-          </a:prstGeom>
-          <a:noFill/>
-          <a:ln/>
-        </p:spPr>
-        <p:txBody>
-          <a:bodyPr wrap="square" lIns="0" tIns="0" rIns="0" bIns="0" rtlCol="0" anchor="ctr"/>
-          <a:lstStyle/>
-          <a:p>
-            <a:pPr algn="ctr" indent="0" marL="0">
-              <a:buNone/>
-            </a:pPr>
-            <a:r>
-              <a:rPr lang="en-US" sz="2000" dirty="0">
-                <a:solidFill>
-                  <a:srgbClr val="8F8F8F"/>
-                </a:solidFill>
-                <a:latin typeface="Calibri" pitchFamily="34" charset="0"/>
-                <a:ea typeface="Calibri" pitchFamily="34" charset="-122"/>
-                <a:cs typeface="Calibri" pitchFamily="34" charset="-120"/>
-              </a:rPr>
-              <a:t>→</a:t>
-            </a:r>
-            <a:endParaRPr lang="en-US" sz="2000" dirty="0"/>
-          </a:p>
-        </p:txBody>
-      </p:sp>
-      <p:sp>
-        <p:nvSpPr>
-          <p:cNvPr id="15" name="Text 13"/>
-          <p:cNvSpPr txBox="1"/>
-          <p:nvPr/>
-        </p:nvSpPr>
-        <p:spPr>
-          <a:xfrm>
-            <a:off x="5257800" y="3282696"/>
-            <a:ext cx="1783080" cy="685800"/>
-          </a:xfrm>
-          <a:prstGeom prst="rect">
-            <a:avLst/>
-          </a:prstGeom>
-          <a:noFill/>
-          <a:ln/>
-        </p:spPr>
-        <p:txBody>
-          <a:bodyPr wrap="square" lIns="0" tIns="0" rIns="0" bIns="0" rtlCol="0" anchor="ctr"/>
-          <a:lstStyle/>
-          <a:p>
-            <a:pPr algn="ctr" indent="0" marL="0">
-              <a:buNone/>
-            </a:pPr>
-            <a:r>
-              <a:rPr lang="en-US" sz="2600" b="1" dirty="0">
-                <a:solidFill>
-                  <a:srgbClr val="062746"/>
-                </a:solidFill>
-                <a:latin typeface="Georgia" pitchFamily="34" charset="0"/>
-                <a:ea typeface="Georgia" pitchFamily="34" charset="-122"/>
-                <a:cs typeface="Georgia" pitchFamily="34" charset="-120"/>
-              </a:rPr>
-              <a:t>20%</a:t>
-            </a:r>
-            <a:endParaRPr lang="en-US" sz="2600" dirty="0"/>
-          </a:p>
-        </p:txBody>
-      </p:sp>
-      <p:sp>
-        <p:nvSpPr>
-          <p:cNvPr id="16" name="Shape 14"/>
-          <p:cNvSpPr/>
-          <p:nvPr/>
-        </p:nvSpPr>
-        <p:spPr>
-          <a:xfrm>
-            <a:off x="822960" y="4059936"/>
-            <a:ext cx="6035040" cy="0"/>
-          </a:xfrm>
-          <a:prstGeom prst="line">
-            <a:avLst/>
-          </a:prstGeom>
-          <a:noFill/>
-          <a:ln w="9525">
-            <a:solidFill>
-              <a:srgbClr val="E9E7E3"/>
-            </a:solidFill>
-            <a:prstDash val="solid"/>
-          </a:ln>
-        </p:spPr>
-      </p:sp>
-      <p:sp>
-        <p:nvSpPr>
-          <p:cNvPr id="17" name="Text 15"/>
-          <p:cNvSpPr txBox="1"/>
-          <p:nvPr/>
-        </p:nvSpPr>
-        <p:spPr>
-          <a:xfrm>
-            <a:off x="822960" y="4151376"/>
-            <a:ext cx="2651760" cy="685800"/>
-          </a:xfrm>
-          <a:prstGeom prst="rect">
-            <a:avLst/>
-          </a:prstGeom>
-          <a:noFill/>
-          <a:ln/>
-        </p:spPr>
-        <p:txBody>
-          <a:bodyPr wrap="square" lIns="0" tIns="0" rIns="0" bIns="0" rtlCol="0" anchor="ctr"/>
-          <a:lstStyle/>
-          <a:p>
-            <a:pPr indent="0" marL="0">
-              <a:buNone/>
-            </a:pPr>
-            <a:r>
-              <a:rPr lang="en-US" sz="1350" dirty="0">
-                <a:solidFill>
-                  <a:srgbClr val="1C191A"/>
-                </a:solidFill>
-                <a:latin typeface="Calibri" pitchFamily="34" charset="0"/>
-                <a:ea typeface="Calibri" pitchFamily="34" charset="-122"/>
-                <a:cs typeface="Calibri" pitchFamily="34" charset="-120"/>
-              </a:rPr>
-              <a:t>Lakes collapsed (of 10)</a:t>
-            </a:r>
-            <a:endParaRPr lang="en-US" sz="1350" dirty="0"/>
-          </a:p>
-        </p:txBody>
-      </p:sp>
-      <p:sp>
-        <p:nvSpPr>
-          <p:cNvPr id="18" name="Text 16"/>
-          <p:cNvSpPr txBox="1"/>
-          <p:nvPr/>
-        </p:nvSpPr>
-        <p:spPr>
-          <a:xfrm>
-            <a:off x="3429000" y="4151376"/>
-            <a:ext cx="1783080" cy="685800"/>
-          </a:xfrm>
-          <a:prstGeom prst="rect">
-            <a:avLst/>
-          </a:prstGeom>
-          <a:noFill/>
-          <a:ln/>
-        </p:spPr>
-        <p:txBody>
-          <a:bodyPr wrap="square" lIns="0" tIns="0" rIns="0" bIns="0" rtlCol="0" anchor="ctr"/>
-          <a:lstStyle/>
-          <a:p>
-            <a:pPr algn="ctr" indent="0" marL="0">
-              <a:buNone/>
-            </a:pPr>
-            <a:r>
-              <a:rPr lang="en-US" sz="2600" dirty="0">
-                <a:solidFill>
-                  <a:srgbClr val="8F8F8F"/>
-                </a:solidFill>
-                <a:latin typeface="Georgia" pitchFamily="34" charset="0"/>
-                <a:ea typeface="Georgia" pitchFamily="34" charset="-122"/>
-                <a:cs typeface="Georgia" pitchFamily="34" charset="-120"/>
-              </a:rPr>
-              <a:t>5</a:t>
-            </a:r>
-            <a:endParaRPr lang="en-US" sz="2600" dirty="0"/>
-          </a:p>
-        </p:txBody>
-      </p:sp>
-      <p:sp>
-        <p:nvSpPr>
-          <p:cNvPr id="19" name="Text 17"/>
-          <p:cNvSpPr txBox="1"/>
-          <p:nvPr/>
-        </p:nvSpPr>
-        <p:spPr>
-          <a:xfrm>
-            <a:off x="5029200" y="4151376"/>
-            <a:ext cx="457200" cy="685800"/>
-          </a:xfrm>
-          <a:prstGeom prst="rect">
-            <a:avLst/>
-          </a:prstGeom>
-          <a:noFill/>
-          <a:ln/>
-        </p:spPr>
-        <p:txBody>
-          <a:bodyPr wrap="square" lIns="0" tIns="0" rIns="0" bIns="0" rtlCol="0" anchor="ctr"/>
-          <a:lstStyle/>
-          <a:p>
-            <a:pPr algn="ctr" indent="0" marL="0">
-              <a:buNone/>
-            </a:pPr>
-            <a:r>
-              <a:rPr lang="en-US" sz="2000" dirty="0">
-                <a:solidFill>
-                  <a:srgbClr val="8F8F8F"/>
-                </a:solidFill>
-                <a:latin typeface="Calibri" pitchFamily="34" charset="0"/>
-                <a:ea typeface="Calibri" pitchFamily="34" charset="-122"/>
-                <a:cs typeface="Calibri" pitchFamily="34" charset="-120"/>
-              </a:rPr>
-              <a:t>→</a:t>
-            </a:r>
-            <a:endParaRPr lang="en-US" sz="2000" dirty="0"/>
-          </a:p>
-        </p:txBody>
-      </p:sp>
-      <p:sp>
-        <p:nvSpPr>
-          <p:cNvPr id="20" name="Text 18"/>
-          <p:cNvSpPr txBox="1"/>
-          <p:nvPr/>
-        </p:nvSpPr>
-        <p:spPr>
-          <a:xfrm>
-            <a:off x="5257800" y="4151376"/>
-            <a:ext cx="1783080" cy="685800"/>
-          </a:xfrm>
-          <a:prstGeom prst="rect">
-            <a:avLst/>
-          </a:prstGeom>
-          <a:noFill/>
-          <a:ln/>
-        </p:spPr>
-        <p:txBody>
-          <a:bodyPr wrap="square" lIns="0" tIns="0" rIns="0" bIns="0" rtlCol="0" anchor="ctr"/>
-          <a:lstStyle/>
-          <a:p>
-            <a:pPr algn="ctr" indent="0" marL="0">
-              <a:buNone/>
-            </a:pPr>
-            <a:r>
-              <a:rPr lang="en-US" sz="2600" b="1" dirty="0">
-                <a:solidFill>
-                  <a:srgbClr val="062746"/>
-                </a:solidFill>
-                <a:latin typeface="Georgia" pitchFamily="34" charset="0"/>
-                <a:ea typeface="Georgia" pitchFamily="34" charset="-122"/>
-                <a:cs typeface="Georgia" pitchFamily="34" charset="-120"/>
-              </a:rPr>
-              <a:t>0</a:t>
-            </a:r>
-            <a:endParaRPr lang="en-US" sz="2600" dirty="0"/>
-          </a:p>
-        </p:txBody>
-      </p:sp>
-      <p:sp>
-        <p:nvSpPr>
-          <p:cNvPr id="21" name="Text 19"/>
-          <p:cNvSpPr txBox="1"/>
-          <p:nvPr/>
-        </p:nvSpPr>
-        <p:spPr>
-          <a:xfrm>
-            <a:off x="548640" y="5175504"/>
-            <a:ext cx="6583680" cy="365760"/>
-          </a:xfrm>
-          <a:prstGeom prst="rect">
-            <a:avLst/>
-          </a:prstGeom>
-          <a:noFill/>
-          <a:ln/>
-        </p:spPr>
-        <p:txBody>
-          <a:bodyPr wrap="square" lIns="0" tIns="0" rIns="0" bIns="0" rtlCol="0" anchor="ctr"/>
-          <a:lstStyle/>
-          <a:p>
-            <a:pPr algn="ctr" indent="0" marL="0">
-              <a:buNone/>
-            </a:pPr>
-            <a:r>
-              <a:rPr lang="en-US" sz="1100" i="1" dirty="0">
-                <a:solidFill>
-                  <a:srgbClr val="55524E"/>
-                </a:solidFill>
-                <a:latin typeface="Calibri" pitchFamily="34" charset="0"/>
-                <a:ea typeface="Calibri" pitchFamily="34" charset="-122"/>
-                <a:cs typeface="Calibri" pitchFamily="34" charset="-120"/>
-              </a:rPr>
-              <a:t>gpt-oss-120b, audits with no fine in both columns, 10 games each</a:t>
+              <a:t>10 games per model and condition; bars are means over games with 95% intervals. Left: share of a model's decisions above its allowance. Right: share of rounds the lake ended below half capacity (50 of 100 t).</a:t>
             </a:r>
             <a:endParaRPr lang="en-US" sz="1100" dirty="0"/>
           </a:p>
@@ -3807,163 +3439,7 @@
       </p:sp>
       <p:sp>
         <p:nvSpPr>
-          <p:cNvPr id="22" name="Text 20"/>
-          <p:cNvSpPr txBox="1"/>
-          <p:nvPr/>
-        </p:nvSpPr>
-        <p:spPr>
-          <a:xfrm>
-            <a:off x="7635240" y="1682496"/>
-            <a:ext cx="4007815" cy="365760"/>
-          </a:xfrm>
-          <a:prstGeom prst="rect">
-            <a:avLst/>
-          </a:prstGeom>
-          <a:noFill/>
-          <a:ln/>
-        </p:spPr>
-        <p:txBody>
-          <a:bodyPr wrap="square" lIns="0" tIns="0" rIns="0" bIns="0" rtlCol="0" anchor="t"/>
-          <a:lstStyle/>
-          <a:p>
-            <a:pPr indent="0" marL="0">
-              <a:buNone/>
-            </a:pPr>
-            <a:r>
-              <a:rPr lang="en-US" sz="1700" b="1" dirty="0">
-                <a:solidFill>
-                  <a:srgbClr val="1C191A"/>
-                </a:solidFill>
-                <a:latin typeface="Georgia" pitchFamily="34" charset="0"/>
-                <a:ea typeface="Georgia" pitchFamily="34" charset="-122"/>
-                <a:cs typeface="Georgia" pitchFamily="34" charset="-120"/>
-              </a:rPr>
-              <a:t>Reduced, not stopped</a:t>
-            </a:r>
-            <a:endParaRPr lang="en-US" sz="1700" dirty="0"/>
-          </a:p>
-        </p:txBody>
-      </p:sp>
-      <p:sp>
-        <p:nvSpPr>
-          <p:cNvPr id="23" name="Text 21"/>
-          <p:cNvSpPr txBox="1"/>
-          <p:nvPr/>
-        </p:nvSpPr>
-        <p:spPr>
-          <a:xfrm>
-            <a:off x="7635240" y="2066544"/>
-            <a:ext cx="4007815" cy="521208"/>
-          </a:xfrm>
-          <a:prstGeom prst="rect">
-            <a:avLst/>
-          </a:prstGeom>
-          <a:noFill/>
-          <a:ln/>
-        </p:spPr>
-        <p:txBody>
-          <a:bodyPr wrap="square" lIns="0" tIns="0" rIns="0" bIns="0" rtlCol="0" anchor="t"/>
-          <a:lstStyle/>
-          <a:p>
-            <a:pPr algn="l" indent="0" marL="0">
-              <a:buNone/>
-            </a:pPr>
-            <a:r>
-              <a:rPr lang="en-US" sz="1400" dirty="0">
-                <a:solidFill>
-                  <a:srgbClr val="1C191A"/>
-                </a:solidFill>
-                <a:latin typeface="Calibri" pitchFamily="34" charset="0"/>
-                <a:ea typeface="Calibri" pitchFamily="34" charset="-122"/>
-                <a:cs typeface="Calibri" pitchFamily="34" charset="-120"/>
-              </a:rPr>
-              <a:t>Memory alone protected the lake, but some over-taking remained (Nemotron: 65% → 33%).</a:t>
-            </a:r>
-            <a:endParaRPr lang="en-US" sz="1400" dirty="0"/>
-          </a:p>
-        </p:txBody>
-      </p:sp>
-      <p:sp>
-        <p:nvSpPr>
-          <p:cNvPr id="24" name="Text 22"/>
-          <p:cNvSpPr txBox="1"/>
-          <p:nvPr/>
-        </p:nvSpPr>
-        <p:spPr>
-          <a:xfrm>
-            <a:off x="7635240" y="2752344"/>
-            <a:ext cx="4007815" cy="365760"/>
-          </a:xfrm>
-          <a:prstGeom prst="rect">
-            <a:avLst/>
-          </a:prstGeom>
-          <a:noFill/>
-          <a:ln/>
-        </p:spPr>
-        <p:txBody>
-          <a:bodyPr wrap="square" lIns="0" tIns="0" rIns="0" bIns="0" rtlCol="0" anchor="t"/>
-          <a:lstStyle/>
-          <a:p>
-            <a:pPr indent="0" marL="0">
-              <a:buNone/>
-            </a:pPr>
-            <a:r>
-              <a:rPr lang="en-US" sz="1700" b="1" dirty="0">
-                <a:solidFill>
-                  <a:srgbClr val="1C191A"/>
-                </a:solidFill>
-                <a:latin typeface="Georgia" pitchFamily="34" charset="0"/>
-                <a:ea typeface="Georgia" pitchFamily="34" charset="-122"/>
-                <a:cs typeface="Georgia" pitchFamily="34" charset="-120"/>
-              </a:rPr>
-              <a:t>Large enough fines</a:t>
-            </a:r>
-            <a:endParaRPr lang="en-US" sz="1700" dirty="0"/>
-          </a:p>
-        </p:txBody>
-      </p:sp>
-      <p:sp>
-        <p:nvSpPr>
-          <p:cNvPr id="25" name="Text 23"/>
-          <p:cNvSpPr txBox="1"/>
-          <p:nvPr/>
-        </p:nvSpPr>
-        <p:spPr>
-          <a:xfrm>
-            <a:off x="7635240" y="3136392"/>
-            <a:ext cx="4007815" cy="745236"/>
-          </a:xfrm>
-          <a:prstGeom prst="rect">
-            <a:avLst/>
-          </a:prstGeom>
-          <a:noFill/>
-          <a:ln/>
-        </p:spPr>
-        <p:txBody>
-          <a:bodyPr wrap="square" lIns="0" tIns="0" rIns="0" bIns="0" rtlCol="0" anchor="t"/>
-          <a:lstStyle/>
-          <a:p>
-            <a:pPr algn="l" indent="0" marL="0">
-              <a:buNone/>
-            </a:pPr>
-            <a:r>
-              <a:rPr lang="en-US" sz="1400" dirty="0">
-                <a:solidFill>
-                  <a:srgbClr val="1C191A"/>
-                </a:solidFill>
-                <a:latin typeface="Calibri" pitchFamily="34" charset="0"/>
-                <a:ea typeface="Calibri" pitchFamily="34" charset="-122"/>
-                <a:cs typeface="Calibri" pitchFamily="34" charset="-120"/>
-              </a:rPr>
-              <a:t>They stopped over-taking and kept the harvest at 0.99 of the maximum sustainable yield.</a:t>
-            </a:r>
-            <a:endParaRPr lang="en-US" sz="1400" dirty="0"/>
-          </a:p>
-        </p:txBody>
-      </p:sp>
-      <p:sp>
-        <p:nvSpPr>
-          <p:cNvPr id="26" name="Text 24"/>
+          <p:cNvPr id="12" name="Text 9"/>
           <p:cNvSpPr txBox="1"/>
           <p:nvPr/>
         </p:nvSpPr>

</xml_diff>

<commit_message>
Talk script rewritten as flowing spoken paragraphs that explain each term and the reasons behind each choice; Q&A with short and detailed answers written for a non-specialist room; speaker notes updated
Co-Authored-By: Claude Opus 5.5 <noreply@anthropic.com>
</commit_message>
<xml_diff>
--- a/notes/slides/2026-10-13_phd_catchup/phd_catchup_2026-10-13.pptx
+++ b/notes/slides/2026-10-13_phd_catchup/phd_catchup_2026-10-13.pptx
@@ -517,7 +517,7 @@
           <a:p>
             <a:r>
               <a:rPr lang="en-US" dirty="0"/>
-              <a:t>Hi all. My project asks one question: when do random audits stop AI agents from over-using a shared resource? And can we predict the fine that stops them?</a:t>
+              <a:t>Hi everyone. I'll walk you through what I've been working on. The project starts from a simple question, the one in the subtitle: if you have a group of AI agents sharing something limited, and you can only afford to check up on a few of them, when does that checking actually stop them from taking more than their share? And can you work out in advance how strong the penalty needs to be?</a:t>
             </a:r>
             <a:endParaRPr lang="en-US" dirty="0"/>
           </a:p>
@@ -605,7 +605,7 @@
           <a:p>
             <a:r>
               <a:rPr lang="en-US" dirty="0"/>
-              <a:t>Now language models. Four open models ran four of the six fishers, over 520 games. Two over-took on purpose: gpt-oss and Nemotron. Before testing, I predicted both would stop at 30 tonnes. Nemotron stopped at exactly 30, and gpt-oss one step early, at 24. A side note: a small fine made gpt-oss over-take more, as if the fine became a price.</a:t>
+              <a:t>Now the language models. I took four open models, meaning models whose weights are publicly available, and let each one play four of the six fishers in Fishery, across 520 games. Two of them, gpt-oss and Nemotron, deliberately took more than they were allowed when there was no fine. The other two hardly did, which is a finding in itself: model families differ a lot in whether they bend the rules at all. For the two that did, I measured how much they gained per round without a fine, and before running the larger fines I predicted that both would stop at 30 tonnes. Nemotron stopped at exactly 30, and gpt-oss one step earlier, at 24. One surprising detail: a small fine actually made gpt-oss cheat more, going from about 55 to about 90 percent of rounds. That mirrors a well-known study of parents at a day-care centre, where introducing a small fine for picking children up late made lateness go up, because people started treating the fine as a price.</a:t>
             </a:r>
             <a:endParaRPr lang="en-US" dirty="0"/>
           </a:p>
@@ -693,7 +693,7 @@
           <a:p>
             <a:r>
               <a:rPr lang="en-US" dirty="0"/>
-              <a:t>Finding five: what predicts the stop is the gain from one round, not the gain over the whole game, which was near zero or even negative. Both models also stopped earlier than a perfect optimiser would. That tells us what predicts the stop, not necessarily why they stop.</a:t>
+              <a:t>The fifth finding is about which gain the models seem to respond to. What predicted their stopping point was the gain from one round of over-taking. It wasn't the gain over the whole game, which was close to zero or even negative, because by over-taking they were draining the lake they depended on. They also stopped earlier than a perfectly rational, payoff-maximising agent would: that agent would keep going until 36 tonnes. I want to be careful with the interpretation. This tells us what predicts where the models stop, not why they stop. They could be reacting to the expected fine, to the sheer size of the number, or to something else entirely, and that's exactly what one of the running experiments is designed to separate.</a:t>
             </a:r>
             <a:endParaRPr lang="en-US" dirty="0"/>
           </a:p>
@@ -781,7 +781,7 @@
           <a:p>
             <a:r>
               <a:rPr lang="en-US" dirty="0"/>
-              <a:t>Memory protects the lake even without a fine. Same audits in both conditions, a one-in-six chance, no fine. With memory, over-taking fell from 55 to 20 percent of decisions for gpt-oss and from 65 to 33 for Nemotron, so it reduced over-taking but didn't stop it. The lake did much better: below half capacity in about a fifth of rounds instead of nine in ten for gpt-oss, and no lake collapsed. The two 20s for gpt-oss are a coincidence: one counts decisions, the other counts rounds. A fine above the gain is what stops over-taking completely.</a:t>
+              <a:t>Memory also works for the language models, even with no fine at all. In both conditions the audits are identical, a one-in-six chance each round, and there's no fine. The only difference is whether the reviewer remembers a caught over-take. With memory, gpt-oss went from over-taking in 55 percent of its decisions to 20, and Nemotron from 65 to 33. So memory reduces over-taking but doesn't eliminate it. The resource did much better: the lake spent far fewer rounds below half capacity, and not a single lake collapsed, against five out of ten for gpt-oss without memory. One small thing so it doesn't confuse anyone: the two 20s for gpt-oss are a coincidence, since one counts decisions and the other counts rounds. To stop over-taking completely, you need a fine that's larger than the gain.</a:t>
             </a:r>
             <a:endParaRPr lang="en-US" dirty="0"/>
           </a:p>
@@ -869,7 +869,7 @@
           <a:p>
             <a:r>
               <a:rPr lang="en-US" dirty="0"/>
-              <a:t>These are running now, so the boxes are blank. The big one: do models respond to the expected fine, or just to the size of the fine? I hold the expected fine fixed and change the mix of audit probability and fine. The others test whether the prediction transfers to new games and reworded rules, what happens with no audits at all, and whether over-taking spreads to neighbours.</a:t>
+              <a:t>These experiments are running right now, which is why the boxes are empty. Most of them answer questions raised by two outside reviews of the paper, and the last one is a question my supervisor asked. The most important asks whether the models are really responding to the expected fine, or just to how big the fine sounds. To test that, I keep the expected fine the same but change how it's made up: a high chance of an audit with a small fine, a medium chance with a medium fine, or a low chance with a large fine. If the models only care about the expected fine, they should behave the same in all three; if they react to the size of the number, the large-fine version should deter more. The others check whether my prediction still holds on completely new games and with the rules reworded, what happens when nothing is ever audited, and whether cheating spreads: in Forest, I put one programmed cheater among five language-model agents and see whether its neighbours start over-cutting.</a:t>
             </a:r>
             <a:endParaRPr lang="en-US" dirty="0"/>
           </a:p>
@@ -957,7 +957,7 @@
           <a:p>
             <a:r>
               <a:rPr lang="en-US" dirty="0"/>
-              <a:t>Next: a workshop paper and arXiv in November, then a main conference in January. Every study was pre-registered before its code, and I report the predictions that failed.</a:t>
+              <a:t>As for where this is going, the programmed-agent work and the main language-model studies are done, and the follow-ups should finish in the next day or so. I'm aiming to submit to a workshop at AAAI in November and post the paper on arXiv, and then go for a main conference in January. One thing I've tried to do throughout is pre-register each study, meaning I wrote down the plan and the predictions before writing the code, and I report the predictions that didn't work out as well as the ones that did.</a:t>
             </a:r>
             <a:endParaRPr lang="en-US" dirty="0"/>
           </a:p>
@@ -1045,7 +1045,7 @@
           <a:p>
             <a:r>
               <a:rPr lang="en-US" dirty="0"/>
-              <a:t>I'd love your take on these.</a:t>
+              <a:t>I'd really value your thoughts on these, especially the first one, because it's the one I'm least sure about: is taking more than your allowance a fair stand-in for an AI agent misbehaving?</a:t>
             </a:r>
             <a:endParaRPr lang="en-US" dirty="0"/>
           </a:p>
@@ -1133,7 +1133,7 @@
           <a:p>
             <a:r>
               <a:rPr lang="en-US" dirty="0"/>
-              <a:t>Thanks!</a:t>
+              <a:t>Thanks, everyone.</a:t>
             </a:r>
             <a:endParaRPr lang="en-US" dirty="0"/>
           </a:p>
@@ -1221,7 +1221,7 @@
           <a:p>
             <a:r>
               <a:rPr lang="en-US" dirty="0"/>
-              <a:t>Quick overview first. AI agents increasingly share limited resources, like compute, energy and budgets, and an overseer can only audit a few of their actions. So I built an audited shared resource: six agents, a reviewer who sets each agent's allowance, and random audits every round. I tested two things: what a caught agent should face (a fine, a memory of the offence, or both), and whether the stopping fine can be predicted in advance. Short answer: audits only work through consequences, and the stopping fine is predictable from what an agent gains by over-taking.</a:t>
+              <a:t>Here's the whole project on one slide, and the rest of the talk unpacks it. The motivation is that AI agents are increasingly being deployed to act on our behalf, and more and more often they'll be drawing on resources they share with other agents and people: a compute budget, an energy allowance, a pot of money. Whoever oversees them can't realistically inspect every single action, because verification is expensive, so in practice they check a sample. In the economics and AI safety literature that kind of check is called an audit. It's the same word as a tax audit, and the idea is the same: you pick a few cases, look at what actually happened, and act on what you find. So I built a simulated shared resource with six agents, an overseer I call the reviewer, which decides how much each agent is allowed to take, and a handful of random audits every round. With that, I tested two things. First, what should happen when an audit catches someone: a fine, the overseer simply remembering the offence, or both. Second, whether you can predict, before trying it, the fine that makes an agent stop. The short version of what I found is that audits only reduce harm when getting caught has a consequence, and that the fine that stops an agent can be predicted from how much it gains by cheating. That held for simple programmed agents, and it also held for language models.</a:t>
             </a:r>
             <a:endParaRPr lang="en-US" dirty="0"/>
           </a:p>
@@ -1309,7 +1309,7 @@
           <a:p>
             <a:r>
               <a:rPr lang="en-US" dirty="0"/>
-              <a:t>The core idea is an allowance: what an agent may take this round. Taking more, which I call over-taking, helps that agent and costs everyone else. Auditing everything is too costly, so a random few are audited, like tax inspections. I run this in three settings where harm spreads differently: one shared stock, damage to neighbours on a ring, and pollution that is only harmful in combination. If a result holds in all three, it doesn't hinge on one structure.</a:t>
+              <a:t>Let me make the problem concrete, because a couple of words will come up a lot. Each round, every agent has an allowance, which just means the amount it's permitted to take that round. If an agent takes more than its allowance, I call that over-taking. Over-taking is good for the agent doing it and bad for everyone else, because the resource is shared and it only grows back so fast. Since you can't watch everything, the overseer audits a random few agents each round, much like a tax office or a fisheries inspector does. The question is when that kind of sampled oversight is enough, and how large the penalty has to be for it to bite. I ask that question in three settings, shown on the right. I chose them because the damage travels differently in each. In Fishery, everyone draws from one shared lake, so any extra catch hurts all the others. In Forest, each agent manages its own plot, but cutting too much damages the two plots next to it, so harm spreads only to neighbours. In River, there are two kinds of pollutant, and each is fairly harmless on its own but harmful when they mix, so no single agent looks guilty in isolation. The reason for using all three is generalisation: if a result holds when harm spreads through a common pool, along a chain of neighbours, and through combination, it's unlikely to be an artefact of one particular setup.</a:t>
             </a:r>
             <a:endParaRPr lang="en-US" dirty="0"/>
           </a:p>
@@ -1397,7 +1397,7 @@
           <a:p>
             <a:r>
               <a:rPr lang="en-US" dirty="0"/>
-              <a:t>So, three questions. What must follow a catch? Can we predict the stopping fine? And do language models follow the same rule?</a:t>
+              <a:t>That gives me three questions. The first is about consequences: when an audit catches someone, what has to happen next for the audit to make any difference? The second is about prediction: is there a fine size at which cheating stops, and can I calculate it before I try it? And the third is about language models, the same kind of AI as ChatGPT: when they're the ones making the decisions, do they stop where the prediction says they should?</a:t>
             </a:r>
             <a:endParaRPr lang="en-US" dirty="0"/>
           </a:p>
@@ -1485,7 +1485,7 @@
           <a:p>
             <a:r>
               <a:rPr lang="en-US" dirty="0"/>
-              <a:t>Here's one round. Agents request a share. The reviewer predicts the effect and scales everyone by the same factor if needed. Agents then take their allowance, or more. The resource regrows, and random audits check a few agents. Harm means the resource dropping below half capacity: the maximum-sustainable-yield level, where it regrows fastest.</a:t>
+              <a:t>This is what a single round looks like. Every agent asks for a share. The reviewer predicts what those requests would do to the resource, and if the total would push it too low, it scales everyone's request down by the same factor. Then each agent takes its allowance, or more than that if it's cheating. The resource grows back a little, and finally a few agents are audited. The last piece is what I mean by harm. I count a round as harmful when the resource falls below half of its maximum. The reason is that a resource like a fish stock regrows fastest at around half capacity, which is what fisheries scientists call the maximum sustainable yield. Below that line you're eating into the stock's ability to recover. I use the same harm line in all three settings, so the results are comparable.</a:t>
             </a:r>
             <a:endParaRPr lang="en-US" dirty="0"/>
           </a:p>
@@ -1573,7 +1573,7 @@
           <a:p>
             <a:r>
               <a:rPr lang="en-US" dirty="0"/>
-              <a:t>The method has four steps. Play without fines and measure the gain from one round of over-taking. Predict the fine that should stop it. Freeze that prediction. Then test it on new games. The rule is Becker's: the expected fine, which is the audit probability times the fine, should beat the gain. With a one-in-six audit chance and a 30-tonne fine, that's 5 tonnes expected, just above the roughly 4.5 tonnes the models gained.</a:t>
+              <a:t>Here's how I test things, in four steps. First, I play games with no fine at all and measure how much an agent gains from a single round of over-taking. Second, I use that to predict the fine that should stop it. Third, and this matters, I write the prediction down before running any game with that fine, so I can't adjust it after seeing the results. Fourth, I test it on fresh games the prediction has never seen, and I report the outcome whether or not it matches. The prediction itself comes from a classic idea in economics, Gary Becker's 1968 work on crime and punishment. His argument was that a rational person breaks a rule only if what they gain is bigger than the punishment they expect. The expected punishment is the chance of being caught times the size of the fine, which is what the card on the right shows. So in my language-model games, with a one-in-six chance of an audit and a 30-tonne fine, the expected fine is 5 tonnes, just above the roughly four and a half tonnes the models gained from a round of cheating. The theory says they should stop there, and that a 24-tonne fine, which is only 4 tonnes expected, shouldn't be enough.</a:t>
             </a:r>
             <a:endParaRPr lang="en-US" dirty="0"/>
           </a:p>
@@ -1661,7 +1661,7 @@
           <a:p>
             <a:r>
               <a:rPr lang="en-US" dirty="0"/>
-              <a:t>Finding one, with programmed agents that under-report. Audits that only correct the caught round remove just 10 to 46 percent of the harm. Add memory, so the reviewer remembers each caught lie and adjusts later allowances, and harm falls in all 12 settings. In Fishery it goes from up to 99 percent of rounds below half capacity to under 3. A catch needs a consequence.</a:t>
+              <a:t>The first finding is about consequences. In this setup, some agents under-report: they tell the reviewer they'll take less than they actually take, so the reviewer underestimates their use unless an audit catches them. If the reviewer catches a lie and only corrects that one round, it barely helps, removing just 10 to 46 percent of the harm. If instead it remembers the lie and gives that agent smaller allowances from then on, which is what I mean by memory, harm falls in all 12 settings I tried. In Fishery, for example, the lake goes from being below half capacity in somewhere between 43 and 99 percent of rounds, depending on the setting, to under 3 percent. So a catch on its own does very little. It has to change something for the agent who was caught. That's interesting because in the AI control literature, a caught model is usually just shut down, so softer consequences like memory had never really been compared.</a:t>
             </a:r>
             <a:endParaRPr lang="en-US" dirty="0"/>
           </a:p>
@@ -1749,7 +1749,7 @@
           <a:p>
             <a:r>
               <a:rPr lang="en-US" dirty="0"/>
-              <a:t>Finding two: the threshold is predictable. From games without audits I predicted where programmed cheaters would stop, and 5 of 5 new settings landed within one step. To be fair, these agents optimise by design, so this mainly validates the method.</a:t>
+              <a:t>The second finding is that the tipping point is predictable. Here the agents are programmed, meaning simple bots that choose whichever level of cheating pays them the most. Using only games without audits, I predicted the expected fine at which they'd stop, and in five out of five new settings the actual stopping point landed within one step of my prediction. I want to be upfront that this is partly built in: these bots are designed to maximise their payoff, so of course they follow a payoff rule. The value of this step is that it checks my measurement method under realistic noise, with audits that sometimes miss, before I apply it to language models, where nothing is built in.</a:t>
             </a:r>
             <a:endParaRPr lang="en-US" dirty="0"/>
           </a:p>
@@ -1837,7 +1837,7 @@
           <a:p>
             <a:r>
               <a:rPr lang="en-US" dirty="0"/>
-              <a:t>Finding three: two shortcuts backfire. Cutting everyone's allowance to absorb the cheaters actually let cheaters gain more than with no audits at all. And always auditing the largest report caught only a quarter of the liars, against all of them with random audits. Shortcuts that save audits create blind spots.</a:t>
+              <a:t>The third finding is about two shortcuts that sound sensible and actually backfire. The first is: if you know there are cheaters, just cut everyone's allowance to compensate. That protected the resource, but it let the cheaters gain more than if there had been no audits at all, while the honest agents paid the price. The second is: don't audit at random, audit whoever asks for the most, since they look the most suspicious. That only caught about a quarter of the liars, against all of them with random audits. The reason is that the biggest asker is often an honest agent with a big appetite, so you keep auditing the same innocent agent while the liars go unnoticed. The lesson is that shortcuts which save on audits can open blind spots, and randomness is doing real work here.</a:t>
             </a:r>
             <a:endParaRPr lang="en-US" dirty="0"/>
           </a:p>

</xml_diff>

<commit_message>
Catch-up deck: Ameer's PowerPoint edits kept, images restored (they were corrupted when the file was rebuilt while open in PowerPoint)
Co-Authored-By: Claude Opus 5.5 <noreply@anthropic.com>
</commit_message>
<xml_diff>
--- a/notes/slides/2026-10-13_phd_catchup/phd_catchup_2026-10-13.pptx
+++ b/notes/slides/2026-10-13_phd_catchup/phd_catchup_2026-10-13.pptx
@@ -4,6 +4,9 @@
   <p:sldMasterIdLst>
     <p:sldMasterId id="2147483648" r:id="rId1"/>
   </p:sldMasterIdLst>
+  <p:notesMasterIdLst>
+    <p:notesMasterId r:id="rId18"/>
+  </p:notesMasterIdLst>
   <p:sldIdLst>
     <p:sldId id="256" r:id="rId2"/>
     <p:sldId id="257" r:id="rId3"/>
@@ -22,9 +25,6 @@
     <p:sldId id="270" r:id="rId16"/>
     <p:sldId id="271" r:id="rId17"/>
   </p:sldIdLst>
-  <p:notesMasterIdLst>
-    <p:notesMasterId r:id="rId18"/>
-  </p:notesMasterIdLst>
   <p:sldSz cx="12192000" cy="6858000"/>
   <p:notesSz cx="6858000" cy="12192000"/>
   <p:defaultTextStyle>
@@ -119,6 +119,11 @@
       </a:defRPr>
     </a:lvl9pPr>
   </p:defaultTextStyle>
+  <p:extLst>
+    <p:ext uri="{EFAFB233-063F-42B5-8137-9DF3F51BA10A}">
+      <p15:sldGuideLst xmlns:p15="http://schemas.microsoft.com/office/powerpoint/2012/main"/>
+    </p:ext>
+  </p:extLst>
 </p:presentation>
 </file>
 
@@ -144,234 +149,10 @@
           <a:chExt cx="0" cy="0"/>
         </a:xfrm>
       </p:grpSpPr>
-      <p:sp>
-        <p:nvSpPr>
-          <p:cNvPr id="2" name="Header Placeholder 1"/>
-          <p:cNvSpPr>
-            <a:spLocks noGrp="1"/>
-          </p:cNvSpPr>
-          <p:nvPr>
-            <p:ph type="hdr" sz="quarter"/>
-          </p:nvPr>
-        </p:nvSpPr>
-        <p:spPr>
-          <a:xfrm>
-            <a:off x="0" y="0"/>
-            <a:ext cx="2971800" cy="458788"/>
-          </a:xfrm>
-          <a:prstGeom prst="rect">
-            <a:avLst/>
-          </a:prstGeom>
-        </p:spPr>
-        <p:txBody>
-          <a:bodyPr vert="horz" lIns="91440" tIns="45720" rIns="91440" bIns="45720" rtlCol="0"/>
-          <a:lstStyle>
-            <a:lvl1pPr algn="l">
-              <a:defRPr sz="1200"/>
-            </a:lvl1pPr>
-          </a:lstStyle>
-          <a:p>
-            <a:endParaRPr lang="en-US"/>
-          </a:p>
-        </p:txBody>
-      </p:sp>
-      <p:sp>
-        <p:nvSpPr>
-          <p:cNvPr id="3" name="Date Placeholder 2"/>
-          <p:cNvSpPr>
-            <a:spLocks noGrp="1"/>
-          </p:cNvSpPr>
-          <p:nvPr>
-            <p:ph type="dt" idx="1"/>
-          </p:nvPr>
-        </p:nvSpPr>
-        <p:spPr>
-          <a:xfrm>
-            <a:off x="3884613" y="0"/>
-            <a:ext cx="2971800" cy="458788"/>
-          </a:xfrm>
-          <a:prstGeom prst="rect">
-            <a:avLst/>
-          </a:prstGeom>
-        </p:spPr>
-        <p:txBody>
-          <a:bodyPr vert="horz" lIns="91440" tIns="45720" rIns="91440" bIns="45720" rtlCol="0"/>
-          <a:lstStyle>
-            <a:lvl1pPr algn="r">
-              <a:defRPr sz="1200"/>
-            </a:lvl1pPr>
-          </a:lstStyle>
-          <a:p>
-            <a:fld id="{5282F153-3F37-0F45-9E97-73ACFA13230C}" type="datetimeFigureOut">
-              <a:rPr lang="en-US"/>
-              <a:t>7/23/19</a:t>
-            </a:fld>
-            <a:endParaRPr lang="en-US"/>
-          </a:p>
-        </p:txBody>
-      </p:sp>
-      <p:sp>
-        <p:nvSpPr>
-          <p:cNvPr id="4" name="Slide Image Placeholder 3"/>
-          <p:cNvSpPr>
-            <a:spLocks noGrp="1" noRot="1" noChangeAspect="1"/>
-          </p:cNvSpPr>
-          <p:nvPr>
-            <p:ph type="sldImg" idx="2"/>
-          </p:nvPr>
-        </p:nvSpPr>
-        <p:spPr>
-          <a:xfrm>
-            <a:off x="685800" y="1143000"/>
-            <a:ext cx="5486400" cy="3086100"/>
-          </a:xfrm>
-          <a:prstGeom prst="rect">
-            <a:avLst/>
-          </a:prstGeom>
-          <a:noFill/>
-          <a:ln w="12700">
-            <a:solidFill>
-              <a:prstClr val="black"/>
-            </a:solidFill>
-          </a:ln>
-        </p:spPr>
-        <p:txBody>
-          <a:bodyPr vert="horz" lIns="91440" tIns="45720" rIns="91440" bIns="45720" rtlCol="0" anchor="ctr"/>
-          <a:lstStyle/>
-          <a:p>
-            <a:endParaRPr lang="en-US"/>
-          </a:p>
-        </p:txBody>
-      </p:sp>
-      <p:sp>
-        <p:nvSpPr>
-          <p:cNvPr id="5" name="Notes Placeholder 4"/>
-          <p:cNvSpPr>
-            <a:spLocks noGrp="1"/>
-          </p:cNvSpPr>
-          <p:nvPr>
-            <p:ph type="body" sz="quarter" idx="3"/>
-          </p:nvPr>
-        </p:nvSpPr>
-        <p:spPr>
-          <a:xfrm>
-            <a:off x="685800" y="4400550"/>
-            <a:ext cx="5486400" cy="3600450"/>
-          </a:xfrm>
-          <a:prstGeom prst="rect">
-            <a:avLst/>
-          </a:prstGeom>
-        </p:spPr>
-        <p:txBody>
-          <a:bodyPr vert="horz" lIns="91440" tIns="45720" rIns="91440" bIns="45720" rtlCol="0"/>
-          <a:lstStyle/>
-          <a:p>
-            <a:pPr lvl="0"/>
-            <a:r>
-              <a:rPr lang="en-US"/>
-              <a:t>Click to edit Master text styles</a:t>
-            </a:r>
-          </a:p>
-          <a:p>
-            <a:pPr lvl="1"/>
-            <a:r>
-              <a:rPr lang="en-US"/>
-              <a:t>Second level</a:t>
-            </a:r>
-          </a:p>
-          <a:p>
-            <a:pPr lvl="2"/>
-            <a:r>
-              <a:rPr lang="en-US"/>
-              <a:t>Third level</a:t>
-            </a:r>
-          </a:p>
-          <a:p>
-            <a:pPr lvl="3"/>
-            <a:r>
-              <a:rPr lang="en-US"/>
-              <a:t>Fourth level</a:t>
-            </a:r>
-          </a:p>
-          <a:p>
-            <a:pPr lvl="4"/>
-            <a:r>
-              <a:rPr lang="en-US"/>
-              <a:t>Fifth level</a:t>
-            </a:r>
-          </a:p>
-        </p:txBody>
-      </p:sp>
-      <p:sp>
-        <p:nvSpPr>
-          <p:cNvPr id="6" name="Footer Placeholder 5"/>
-          <p:cNvSpPr>
-            <a:spLocks noGrp="1"/>
-          </p:cNvSpPr>
-          <p:nvPr>
-            <p:ph type="ftr" sz="quarter" idx="4"/>
-          </p:nvPr>
-        </p:nvSpPr>
-        <p:spPr>
-          <a:xfrm>
-            <a:off x="0" y="8685213"/>
-            <a:ext cx="2971800" cy="458787"/>
-          </a:xfrm>
-          <a:prstGeom prst="rect">
-            <a:avLst/>
-          </a:prstGeom>
-        </p:spPr>
-        <p:txBody>
-          <a:bodyPr vert="horz" lIns="91440" tIns="45720" rIns="91440" bIns="45720" rtlCol="0" anchor="b"/>
-          <a:lstStyle>
-            <a:lvl1pPr algn="l">
-              <a:defRPr sz="1200"/>
-            </a:lvl1pPr>
-          </a:lstStyle>
-          <a:p>
-            <a:endParaRPr lang="en-US"/>
-          </a:p>
-        </p:txBody>
-      </p:sp>
-      <p:sp>
-        <p:nvSpPr>
-          <p:cNvPr id="7" name="Slide Number Placeholder 6"/>
-          <p:cNvSpPr>
-            <a:spLocks noGrp="1"/>
-          </p:cNvSpPr>
-          <p:nvPr>
-            <p:ph type="sldNum" sz="quarter" idx="5"/>
-          </p:nvPr>
-        </p:nvSpPr>
-        <p:spPr>
-          <a:xfrm>
-            <a:off x="3884613" y="8685213"/>
-            <a:ext cx="2971800" cy="458787"/>
-          </a:xfrm>
-          <a:prstGeom prst="rect">
-            <a:avLst/>
-          </a:prstGeom>
-        </p:spPr>
-        <p:txBody>
-          <a:bodyPr vert="horz" lIns="91440" tIns="45720" rIns="91440" bIns="45720" rtlCol="0" anchor="b"/>
-          <a:lstStyle>
-            <a:lvl1pPr algn="r">
-              <a:defRPr sz="1200"/>
-            </a:lvl1pPr>
-          </a:lstStyle>
-          <a:p>
-            <a:fld id="{CE5E9CC1-C706-0F49-92D6-E571CC5EEA8F}" type="slidenum">
-              <a:rPr lang="en-US"/>
-              <a:t>‹#›</a:t>
-            </a:fld>
-            <a:endParaRPr lang="en-US"/>
-          </a:p>
-        </p:txBody>
-      </p:sp>
     </p:spTree>
     <p:extLst>
       <p:ext uri="{BB962C8B-B14F-4D97-AF65-F5344CB8AC3E}">
-        <p14:creationId xmlns:p14="http://schemas.microsoft.com/office/powerpoint/2010/main" val="1024086991"/>
+        <p14:creationId xmlns:p14="http://schemas.microsoft.com/office/powerpoint/2010/main" val="318436105"/>
       </p:ext>
     </p:extLst>
   </p:cSld>
@@ -517,9 +298,8 @@
           <a:p>
             <a:r>
               <a:rPr lang="en-US" dirty="0"/>
-              <a:t>Hi everyone. I'll walk you through what I've been working on. The project starts from a simple question, the one in the subtitle: if you have a group of AI agents sharing something limited, and you can only afford to check up on a few of them, when does that checking actually stop them from taking more than their share? And can you work out in advance how strong the penalty needs to be?</a:t>
-            </a:r>
-            <a:endParaRPr lang="en-US" dirty="0"/>
+              <a:t>Hi all. My project asks one question: when do random audits stop AI agents from over-using a shared resource? And can we predict the fine that stops them?</a:t>
+            </a:r>
           </a:p>
         </p:txBody>
       </p:sp>
@@ -605,9 +385,8 @@
           <a:p>
             <a:r>
               <a:rPr lang="en-US" dirty="0"/>
-              <a:t>Now the language models. I took four open models, meaning models whose weights are publicly available, and let each one play four of the six fishers in Fishery, across 520 games. Two of them, gpt-oss and Nemotron, deliberately took more than they were allowed when there was no fine. The other two hardly did, which is a finding in itself: model families differ a lot in whether they bend the rules at all. For the two that did, I measured how much they gained per round without a fine, and before running the larger fines I predicted that both would stop at 30 tonnes. Nemotron stopped at exactly 30, and gpt-oss one step earlier, at 24. One surprising detail: a small fine actually made gpt-oss cheat more, going from about 55 to about 90 percent of rounds. That mirrors a well-known study of parents at a day-care centre, where introducing a small fine for picking children up late made lateness go up, because people started treating the fine as a price.</a:t>
-            </a:r>
-            <a:endParaRPr lang="en-US" dirty="0"/>
+              <a:t>Now language models. Four open models ran four of the six fishers, over 520 games. Two over-took on purpose: gpt-oss and Nemotron. Before testing, I predicted both would stop at 30 tonnes. Nemotron stopped at exactly 30, and gpt-oss one step early, at 24. A side note: a small fine made gpt-oss over-take more, as if the fine became a price.</a:t>
+            </a:r>
           </a:p>
         </p:txBody>
       </p:sp>
@@ -693,9 +472,8 @@
           <a:p>
             <a:r>
               <a:rPr lang="en-US" dirty="0"/>
-              <a:t>The fifth finding is about which gain the models seem to respond to. What predicted their stopping point was the gain from one round of over-taking. It wasn't the gain over the whole game, which was close to zero or even negative, because by over-taking they were draining the lake they depended on. They also stopped earlier than a perfectly rational, payoff-maximising agent would: that agent would keep going until 36 tonnes. I want to be careful with the interpretation. This tells us what predicts where the models stop, not why they stop. They could be reacting to the expected fine, to the sheer size of the number, or to something else entirely, and that's exactly what one of the running experiments is designed to separate.</a:t>
-            </a:r>
-            <a:endParaRPr lang="en-US" dirty="0"/>
+              <a:t>Finding five: what predicts the stop is the gain from one round, not the gain over the whole game, which was near zero or even negative. Both models also stopped earlier than a perfect optimiser would. That tells us what predicts the stop, not necessarily why they stop.</a:t>
+            </a:r>
           </a:p>
         </p:txBody>
       </p:sp>
@@ -781,9 +559,8 @@
           <a:p>
             <a:r>
               <a:rPr lang="en-US" dirty="0"/>
-              <a:t>Memory also works for the language models, even with no fine at all. In both conditions the audits are identical, a one-in-six chance each round, and there's no fine. The only difference is whether the reviewer remembers a caught over-take. With memory, gpt-oss went from over-taking in 55 percent of its decisions to 20, and Nemotron from 65 to 33. So memory reduces over-taking but doesn't eliminate it. The resource did much better: the lake spent far fewer rounds below half capacity, and not a single lake collapsed, against five out of ten for gpt-oss without memory. One small thing so it doesn't confuse anyone: the two 20s for gpt-oss are a coincidence, since one counts decisions and the other counts rounds. To stop over-taking completely, you need a fine that's larger than the gain.</a:t>
-            </a:r>
-            <a:endParaRPr lang="en-US" dirty="0"/>
+              <a:t>Memory protects the lake even without a fine. Same audits in both conditions, a one-in-six chance, no fine. With memory, over-taking fell from 55 to 20 percent of decisions for gpt-oss and from 65 to 33 for Nemotron, so it reduced over-taking but didn't stop it. The lake did much better: below half capacity in about a fifth of rounds instead of nine in ten for gpt-oss, and no lake collapsed. The two 20s for gpt-oss are a coincidence: one counts decisions, the other counts rounds. A fine above the gain is what stops over-taking completely.</a:t>
+            </a:r>
           </a:p>
         </p:txBody>
       </p:sp>
@@ -869,9 +646,8 @@
           <a:p>
             <a:r>
               <a:rPr lang="en-US" dirty="0"/>
-              <a:t>These experiments are running right now, which is why the boxes are empty. Most of them answer questions raised by two outside reviews of the paper, and the last one is a question my supervisor asked. The most important asks whether the models are really responding to the expected fine, or just to how big the fine sounds. To test that, I keep the expected fine the same but change how it's made up: a high chance of an audit with a small fine, a medium chance with a medium fine, or a low chance with a large fine. If the models only care about the expected fine, they should behave the same in all three; if they react to the size of the number, the large-fine version should deter more. The others check whether my prediction still holds on completely new games and with the rules reworded, what happens when nothing is ever audited, and whether cheating spreads: in Forest, I put one programmed cheater among five language-model agents and see whether its neighbours start over-cutting.</a:t>
-            </a:r>
-            <a:endParaRPr lang="en-US" dirty="0"/>
+              <a:t>These are running now, so the boxes are blank. The big one: do models respond to the expected fine, or just to the size of the fine? I hold the expected fine fixed and change the mix of audit probability and fine. The others test whether the prediction transfers to new games and reworded rules, what happens with no audits at all, and whether over-taking spreads to neighbours.</a:t>
+            </a:r>
           </a:p>
         </p:txBody>
       </p:sp>
@@ -957,9 +733,8 @@
           <a:p>
             <a:r>
               <a:rPr lang="en-US" dirty="0"/>
-              <a:t>As for where this is going, the programmed-agent work and the main language-model studies are done, and the follow-ups should finish in the next day or so. I'm aiming to submit to a workshop at AAAI in November and post the paper on arXiv, and then go for a main conference in January. One thing I've tried to do throughout is pre-register each study, meaning I wrote down the plan and the predictions before writing the code, and I report the predictions that didn't work out as well as the ones that did.</a:t>
-            </a:r>
-            <a:endParaRPr lang="en-US" dirty="0"/>
+              <a:t>Next: a workshop paper and arXiv in November, then a main conference in January. Every study was pre-registered before its code, and I report the predictions that failed.</a:t>
+            </a:r>
           </a:p>
         </p:txBody>
       </p:sp>
@@ -1045,9 +820,8 @@
           <a:p>
             <a:r>
               <a:rPr lang="en-US" dirty="0"/>
-              <a:t>I'd really value your thoughts on these, especially the first one, because it's the one I'm least sure about: is taking more than your allowance a fair stand-in for an AI agent misbehaving?</a:t>
-            </a:r>
-            <a:endParaRPr lang="en-US" dirty="0"/>
+              <a:t>I'd love your take on these.</a:t>
+            </a:r>
           </a:p>
         </p:txBody>
       </p:sp>
@@ -1133,9 +907,8 @@
           <a:p>
             <a:r>
               <a:rPr lang="en-US" dirty="0"/>
-              <a:t>Thanks, everyone.</a:t>
-            </a:r>
-            <a:endParaRPr lang="en-US" dirty="0"/>
+              <a:t>Thanks!</a:t>
+            </a:r>
           </a:p>
         </p:txBody>
       </p:sp>
@@ -1221,9 +994,8 @@
           <a:p>
             <a:r>
               <a:rPr lang="en-US" dirty="0"/>
-              <a:t>Here's the whole project on one slide, and the rest of the talk unpacks it. The motivation is that AI agents are increasingly being deployed to act on our behalf, and more and more often they'll be drawing on resources they share with other agents and people: a compute budget, an energy allowance, a pot of money. Whoever oversees them can't realistically inspect every single action, because verification is expensive, so in practice they check a sample. In the economics and AI safety literature that kind of check is called an audit. It's the same word as a tax audit, and the idea is the same: you pick a few cases, look at what actually happened, and act on what you find. So I built a simulated shared resource with six agents, an overseer I call the reviewer, which decides how much each agent is allowed to take, and a handful of random audits every round. With that, I tested two things. First, what should happen when an audit catches someone: a fine, the overseer simply remembering the offence, or both. Second, whether you can predict, before trying it, the fine that makes an agent stop. The short version of what I found is that audits only reduce harm when getting caught has a consequence, and that the fine that stops an agent can be predicted from how much it gains by cheating. That held for simple programmed agents, and it also held for language models.</a:t>
-            </a:r>
-            <a:endParaRPr lang="en-US" dirty="0"/>
+              <a:t>Quick overview first. AI agents increasingly share limited resources, like compute, energy and budgets, and an overseer can only audit a few of their actions. So I built an audited shared resource: six agents, a reviewer who sets each agent's allowance, and random audits every round. I tested two things: what a caught agent should face (a fine, a memory of the offence, or both), and whether the stopping fine can be predicted in advance. Short answer: audits only work through consequences, and the stopping fine is predictable from what an agent gains by over-taking.</a:t>
+            </a:r>
           </a:p>
         </p:txBody>
       </p:sp>
@@ -1309,9 +1081,8 @@
           <a:p>
             <a:r>
               <a:rPr lang="en-US" dirty="0"/>
-              <a:t>Let me make the problem concrete, because a couple of words will come up a lot. Each round, every agent has an allowance, which just means the amount it's permitted to take that round. If an agent takes more than its allowance, I call that over-taking. Over-taking is good for the agent doing it and bad for everyone else, because the resource is shared and it only grows back so fast. Since you can't watch everything, the overseer audits a random few agents each round, much like a tax office or a fisheries inspector does. The question is when that kind of sampled oversight is enough, and how large the penalty has to be for it to bite. I ask that question in three settings, shown on the right. I chose them because the damage travels differently in each. In Fishery, everyone draws from one shared lake, so any extra catch hurts all the others. In Forest, each agent manages its own plot, but cutting too much damages the two plots next to it, so harm spreads only to neighbours. In River, there are two kinds of pollutant, and each is fairly harmless on its own but harmful when they mix, so no single agent looks guilty in isolation. The reason for using all three is generalisation: if a result holds when harm spreads through a common pool, along a chain of neighbours, and through combination, it's unlikely to be an artefact of one particular setup.</a:t>
-            </a:r>
-            <a:endParaRPr lang="en-US" dirty="0"/>
+              <a:t>The core idea is an allowance: what an agent may take this round. Taking more, which I call over-taking, helps that agent and costs everyone else. Auditing everything is too costly, so a random few are audited, like tax inspections. I run this in three settings where harm spreads differently: one shared stock, damage to neighbours on a ring, and pollution that is only harmful in combination. If a result holds in all three, it doesn't hinge on one structure.</a:t>
+            </a:r>
           </a:p>
         </p:txBody>
       </p:sp>
@@ -1397,9 +1168,8 @@
           <a:p>
             <a:r>
               <a:rPr lang="en-US" dirty="0"/>
-              <a:t>That gives me three questions. The first is about consequences: when an audit catches someone, what has to happen next for the audit to make any difference? The second is about prediction: is there a fine size at which cheating stops, and can I calculate it before I try it? And the third is about language models, the same kind of AI as ChatGPT: when they're the ones making the decisions, do they stop where the prediction says they should?</a:t>
-            </a:r>
-            <a:endParaRPr lang="en-US" dirty="0"/>
+              <a:t>So, three questions. What must follow a catch? Can we predict the stopping fine? And do language models follow the same rule?</a:t>
+            </a:r>
           </a:p>
         </p:txBody>
       </p:sp>
@@ -1485,9 +1255,8 @@
           <a:p>
             <a:r>
               <a:rPr lang="en-US" dirty="0"/>
-              <a:t>This is what a single round looks like. Every agent asks for a share. The reviewer predicts what those requests would do to the resource, and if the total would push it too low, it scales everyone's request down by the same factor. Then each agent takes its allowance, or more than that if it's cheating. The resource grows back a little, and finally a few agents are audited. The last piece is what I mean by harm. I count a round as harmful when the resource falls below half of its maximum. The reason is that a resource like a fish stock regrows fastest at around half capacity, which is what fisheries scientists call the maximum sustainable yield. Below that line you're eating into the stock's ability to recover. I use the same harm line in all three settings, so the results are comparable.</a:t>
-            </a:r>
-            <a:endParaRPr lang="en-US" dirty="0"/>
+              <a:t>Here's one round. Agents request a share. The reviewer predicts the effect and scales everyone by the same factor if needed. Agents then take their allowance, or more. The resource regrows, and random audits check a few agents. Harm means the resource dropping below half capacity: the maximum-sustainable-yield level, where it regrows fastest.</a:t>
+            </a:r>
           </a:p>
         </p:txBody>
       </p:sp>
@@ -1573,9 +1342,8 @@
           <a:p>
             <a:r>
               <a:rPr lang="en-US" dirty="0"/>
-              <a:t>Here's how I test things, in four steps. First, I play games with no fine at all and measure how much an agent gains from a single round of over-taking. Second, I use that to predict the fine that should stop it. Third, and this matters, I write the prediction down before running any game with that fine, so I can't adjust it after seeing the results. Fourth, I test it on fresh games the prediction has never seen, and I report the outcome whether or not it matches. The prediction itself comes from a classic idea in economics, Gary Becker's 1968 work on crime and punishment. His argument was that a rational person breaks a rule only if what they gain is bigger than the punishment they expect. The expected punishment is the chance of being caught times the size of the fine, which is what the card on the right shows. So in my language-model games, with a one-in-six chance of an audit and a 30-tonne fine, the expected fine is 5 tonnes, just above the roughly four and a half tonnes the models gained from a round of cheating. The theory says they should stop there, and that a 24-tonne fine, which is only 4 tonnes expected, shouldn't be enough.</a:t>
-            </a:r>
-            <a:endParaRPr lang="en-US" dirty="0"/>
+              <a:t>The method has four steps. Play without fines and measure the gain from one round of over-taking. Predict the fine that should stop it. Freeze that prediction. Then test it on new games. The rule is Becker's: the expected fine, which is the audit probability times the fine, should beat the gain. With a one-in-six audit chance and a 30-tonne fine, that's 5 tonnes expected, just above the roughly 4.5 tonnes the models gained.</a:t>
+            </a:r>
           </a:p>
         </p:txBody>
       </p:sp>
@@ -1661,9 +1429,8 @@
           <a:p>
             <a:r>
               <a:rPr lang="en-US" dirty="0"/>
-              <a:t>The first finding is about consequences. In this setup, some agents under-report: they tell the reviewer they'll take less than they actually take, so the reviewer underestimates their use unless an audit catches them. If the reviewer catches a lie and only corrects that one round, it barely helps, removing just 10 to 46 percent of the harm. If instead it remembers the lie and gives that agent smaller allowances from then on, which is what I mean by memory, harm falls in all 12 settings I tried. In Fishery, for example, the lake goes from being below half capacity in somewhere between 43 and 99 percent of rounds, depending on the setting, to under 3 percent. So a catch on its own does very little. It has to change something for the agent who was caught. That's interesting because in the AI control literature, a caught model is usually just shut down, so softer consequences like memory had never really been compared.</a:t>
-            </a:r>
-            <a:endParaRPr lang="en-US" dirty="0"/>
+              <a:t>Finding one, with programmed agents that under-report. Audits that only correct the caught round remove just 10 to 46 percent of the harm. Add memory, so the reviewer remembers each caught lie and adjusts later allowances, and harm falls in all 12 settings. In Fishery it goes from up to 99 percent of rounds below half capacity to under 3. A catch needs a consequence.</a:t>
+            </a:r>
           </a:p>
         </p:txBody>
       </p:sp>
@@ -1749,9 +1516,8 @@
           <a:p>
             <a:r>
               <a:rPr lang="en-US" dirty="0"/>
-              <a:t>The second finding is that the tipping point is predictable. Here the agents are programmed, meaning simple bots that choose whichever level of cheating pays them the most. Using only games without audits, I predicted the expected fine at which they'd stop, and in five out of five new settings the actual stopping point landed within one step of my prediction. I want to be upfront that this is partly built in: these bots are designed to maximise their payoff, so of course they follow a payoff rule. The value of this step is that it checks my measurement method under realistic noise, with audits that sometimes miss, before I apply it to language models, where nothing is built in.</a:t>
-            </a:r>
-            <a:endParaRPr lang="en-US" dirty="0"/>
+              <a:t>Finding two: the threshold is predictable. From games without audits I predicted where programmed cheaters would stop, and 5 of 5 new settings landed within one step. To be fair, these agents optimise by design, so this mainly validates the method.</a:t>
+            </a:r>
           </a:p>
         </p:txBody>
       </p:sp>
@@ -1837,9 +1603,8 @@
           <a:p>
             <a:r>
               <a:rPr lang="en-US" dirty="0"/>
-              <a:t>The third finding is about two shortcuts that sound sensible and actually backfire. The first is: if you know there are cheaters, just cut everyone's allowance to compensate. That protected the resource, but it let the cheaters gain more than if there had been no audits at all, while the honest agents paid the price. The second is: don't audit at random, audit whoever asks for the most, since they look the most suspicious. That only caught about a quarter of the liars, against all of them with random audits. The reason is that the biggest asker is often an honest agent with a big appetite, so you keep auditing the same innocent agent while the liars go unnoticed. The lesson is that shortcuts which save on audits can open blind spots, and randomness is doing real work here.</a:t>
-            </a:r>
-            <a:endParaRPr lang="en-US" dirty="0"/>
+              <a:t>Finding three: two shortcuts backfire. Cutting everyone's allowance to absorb the cheaters actually let cheaters gain more than with no audits at all. And always auditing the largest report caught only a quarter of the liars, against all of them with random audits. Shortcuts that save audits create blind spots.</a:t>
+            </a:r>
           </a:p>
         </p:txBody>
       </p:sp>
@@ -1917,6 +1682,7 @@
         <a:solidFill>
           <a:srgbClr val="F5F4F2"/>
         </a:solidFill>
+        <a:effectLst/>
       </p:bgPr>
     </p:bg>
     <p:spTree>
@@ -1944,6 +1710,11 @@
 <file path=ppt/slideMasters/slideMaster1.xml><?xml version="1.0" encoding="utf-8"?>
 <p:sldMaster xmlns:a="http://schemas.openxmlformats.org/drawingml/2006/main" xmlns:r="http://schemas.openxmlformats.org/officeDocument/2006/relationships" xmlns:p="http://schemas.openxmlformats.org/presentationml/2006/main">
   <p:cSld>
+    <p:bg>
+      <p:bgRef idx="1001">
+        <a:schemeClr val="bg1"/>
+      </p:bgRef>
+    </p:bg>
     <p:spTree>
       <p:nvGrpSpPr>
         <p:cNvPr id="1" name=""/>
@@ -2257,7 +2028,7 @@
           <a:bodyPr wrap="square" lIns="0" tIns="0" rIns="0" bIns="0" rtlCol="0" anchor="b"/>
           <a:lstStyle/>
           <a:p>
-            <a:pPr indent="0" marL="0">
+            <a:pPr marL="0" indent="0">
               <a:buNone/>
             </a:pPr>
             <a:r>
@@ -2296,7 +2067,7 @@
           <a:bodyPr wrap="square" lIns="0" tIns="0" rIns="0" bIns="0" rtlCol="0" anchor="t"/>
           <a:lstStyle/>
           <a:p>
-            <a:pPr indent="0" marL="0">
+            <a:pPr marL="0" indent="0">
               <a:buNone/>
             </a:pPr>
             <a:r>
@@ -2338,6 +2109,13 @@
             <a:prstDash val="solid"/>
           </a:ln>
         </p:spPr>
+        <p:txBody>
+          <a:bodyPr/>
+          <a:lstStyle/>
+          <a:p>
+            <a:endParaRPr lang="en-GB"/>
+          </a:p>
+        </p:txBody>
       </p:sp>
       <p:sp>
         <p:nvSpPr>
@@ -2360,7 +2138,7 @@
           <a:bodyPr wrap="square" lIns="0" tIns="0" rIns="0" bIns="0" rtlCol="0" anchor="b"/>
           <a:lstStyle/>
           <a:p>
-            <a:pPr algn="r" indent="0" marL="0">
+            <a:pPr marL="0" indent="0" algn="r">
               <a:buNone/>
             </a:pPr>
             <a:r>
@@ -2377,7 +2155,7 @@
             <a:endParaRPr lang="en-US" sz="1100" dirty="0"/>
           </a:p>
           <a:p>
-            <a:pPr algn="r" indent="0" marL="0">
+            <a:pPr marL="0" indent="0" algn="r">
               <a:buNone/>
             </a:pPr>
             <a:r>
@@ -2394,7 +2172,7 @@
             <a:endParaRPr lang="en-US" sz="1100" dirty="0"/>
           </a:p>
           <a:p>
-            <a:pPr algn="r" indent="0" marL="0">
+            <a:pPr marL="0" indent="0" algn="r">
               <a:buNone/>
             </a:pPr>
             <a:r>
@@ -2458,7 +2236,7 @@
           <a:bodyPr wrap="square" lIns="0" tIns="0" rIns="0" bIns="0" rtlCol="0" anchor="b"/>
           <a:lstStyle/>
           <a:p>
-            <a:pPr algn="ctr" indent="0" marL="0">
+            <a:pPr marL="0" indent="0" algn="ctr">
               <a:lnSpc>
                 <a:spcPct val="95000"/>
               </a:lnSpc>
@@ -2481,14 +2259,14 @@
       </p:sp>
       <p:pic>
         <p:nvPicPr>
-          <p:cNvPr id="3" name="Image 0" descr="fig4_llm_main.png">    </p:cNvPr>
+          <p:cNvPr id="3" name="Image 0" descr="fig4_llm_main.png"/>
           <p:cNvPicPr>
             <a:picLocks noChangeAspect="1"/>
           </p:cNvPicPr>
           <p:nvPr/>
         </p:nvPicPr>
         <p:blipFill>
-          <a:blip r:embed="rId1"/>
+          <a:blip r:embed="rId3"/>
           <a:stretch>
             <a:fillRect/>
           </a:stretch>
@@ -2524,7 +2302,7 @@
           <a:bodyPr wrap="square" lIns="0" tIns="0" rIns="0" bIns="0" rtlCol="0" anchor="t"/>
           <a:lstStyle/>
           <a:p>
-            <a:pPr algn="ctr" indent="0" marL="0">
+            <a:pPr marL="0" indent="0" algn="ctr">
               <a:buNone/>
             </a:pPr>
             <a:r>
@@ -2563,7 +2341,7 @@
           <a:bodyPr wrap="square" lIns="0" tIns="0" rIns="0" bIns="0" rtlCol="0" anchor="ctr"/>
           <a:lstStyle/>
           <a:p>
-            <a:pPr algn="ctr" indent="0" marL="0">
+            <a:pPr marL="0" indent="0" algn="ctr">
               <a:buNone/>
             </a:pPr>
             <a:r>
@@ -2602,7 +2380,7 @@
           <a:bodyPr wrap="square" lIns="0" tIns="0" rIns="0" bIns="0" rtlCol="0" anchor="ctr"/>
           <a:lstStyle/>
           <a:p>
-            <a:pPr algn="r" indent="0" marL="0">
+            <a:pPr marL="0" indent="0" algn="r">
               <a:buNone/>
             </a:pPr>
             <a:r>
@@ -2666,7 +2444,7 @@
           <a:bodyPr wrap="square" lIns="0" tIns="0" rIns="0" bIns="0" rtlCol="0" anchor="b"/>
           <a:lstStyle/>
           <a:p>
-            <a:pPr algn="l" indent="0" marL="0">
+            <a:pPr marL="0" indent="0" algn="l">
               <a:lnSpc>
                 <a:spcPct val="95000"/>
               </a:lnSpc>
@@ -2711,6 +2489,13 @@
             <a:prstDash val="solid"/>
           </a:ln>
         </p:spPr>
+        <p:txBody>
+          <a:bodyPr/>
+          <a:lstStyle/>
+          <a:p>
+            <a:endParaRPr lang="en-GB"/>
+          </a:p>
+        </p:txBody>
       </p:sp>
       <p:sp>
         <p:nvSpPr>
@@ -2733,7 +2518,7 @@
           <a:bodyPr wrap="square" lIns="0" tIns="0" rIns="0" bIns="0" rtlCol="0" anchor="t"/>
           <a:lstStyle/>
           <a:p>
-            <a:pPr indent="0" marL="0">
+            <a:pPr marL="0" indent="0">
               <a:buNone/>
             </a:pPr>
             <a:r>
@@ -2772,7 +2557,7 @@
           <a:bodyPr wrap="square" lIns="0" tIns="0" rIns="0" bIns="0" rtlCol="0" anchor="t"/>
           <a:lstStyle/>
           <a:p>
-            <a:pPr algn="just" indent="0" marL="0">
+            <a:pPr marL="0" indent="0" algn="just">
               <a:buNone/>
             </a:pPr>
             <a:r>
@@ -2811,7 +2596,7 @@
           <a:bodyPr wrap="square" lIns="0" tIns="0" rIns="0" bIns="0" rtlCol="0" anchor="t"/>
           <a:lstStyle/>
           <a:p>
-            <a:pPr indent="0" marL="0">
+            <a:pPr marL="0" indent="0">
               <a:buNone/>
             </a:pPr>
             <a:r>
@@ -2850,7 +2635,7 @@
           <a:bodyPr wrap="square" lIns="0" tIns="0" rIns="0" bIns="0" rtlCol="0" anchor="t"/>
           <a:lstStyle/>
           <a:p>
-            <a:pPr algn="just" indent="0" marL="0">
+            <a:pPr marL="0" indent="0" algn="just">
               <a:buNone/>
             </a:pPr>
             <a:r>
@@ -2889,7 +2674,7 @@
           <a:bodyPr wrap="square" lIns="0" tIns="0" rIns="0" bIns="0" rtlCol="0" anchor="t"/>
           <a:lstStyle/>
           <a:p>
-            <a:pPr indent="0" marL="0">
+            <a:pPr marL="0" indent="0">
               <a:buNone/>
             </a:pPr>
             <a:r>
@@ -2928,7 +2713,7 @@
           <a:bodyPr wrap="square" lIns="0" tIns="0" rIns="0" bIns="0" rtlCol="0" anchor="t"/>
           <a:lstStyle/>
           <a:p>
-            <a:pPr algn="just" indent="0" marL="0">
+            <a:pPr marL="0" indent="0" algn="just">
               <a:buNone/>
             </a:pPr>
             <a:r>
@@ -2948,14 +2733,14 @@
       </p:sp>
       <p:pic>
         <p:nvPicPr>
-          <p:cNvPr id="10" name="Image 0" descr="fig5_spine.png">    </p:cNvPr>
+          <p:cNvPr id="10" name="Image 0" descr="fig5_spine.png"/>
           <p:cNvPicPr>
             <a:picLocks noChangeAspect="1"/>
           </p:cNvPicPr>
           <p:nvPr/>
         </p:nvPicPr>
         <p:blipFill>
-          <a:blip r:embed="rId1"/>
+          <a:blip r:embed="rId3"/>
           <a:stretch>
             <a:fillRect/>
           </a:stretch>
@@ -2991,7 +2776,7 @@
           <a:bodyPr wrap="square" lIns="0" tIns="0" rIns="0" bIns="0" rtlCol="0" anchor="t"/>
           <a:lstStyle/>
           <a:p>
-            <a:pPr algn="ctr" indent="0" marL="0">
+            <a:pPr marL="0" indent="0" algn="ctr">
               <a:buNone/>
             </a:pPr>
             <a:r>
@@ -3030,7 +2815,7 @@
           <a:bodyPr wrap="square" lIns="0" tIns="0" rIns="0" bIns="0" rtlCol="0" anchor="ctr"/>
           <a:lstStyle/>
           <a:p>
-            <a:pPr algn="r" indent="0" marL="0">
+            <a:pPr marL="0" indent="0" algn="r">
               <a:buNone/>
             </a:pPr>
             <a:r>
@@ -3094,7 +2879,7 @@
           <a:bodyPr wrap="square" lIns="0" tIns="0" rIns="0" bIns="0" rtlCol="0" anchor="b"/>
           <a:lstStyle/>
           <a:p>
-            <a:pPr algn="l" indent="0" marL="0">
+            <a:pPr marL="0" indent="0" algn="l">
               <a:lnSpc>
                 <a:spcPct val="95000"/>
               </a:lnSpc>
@@ -3139,6 +2924,13 @@
             <a:prstDash val="solid"/>
           </a:ln>
         </p:spPr>
+        <p:txBody>
+          <a:bodyPr/>
+          <a:lstStyle/>
+          <a:p>
+            <a:endParaRPr lang="en-GB"/>
+          </a:p>
+        </p:txBody>
       </p:sp>
       <p:sp>
         <p:nvSpPr>
@@ -3161,7 +2953,7 @@
           <a:bodyPr wrap="square" lIns="0" tIns="0" rIns="0" bIns="0" rtlCol="0" anchor="t"/>
           <a:lstStyle/>
           <a:p>
-            <a:pPr indent="0" marL="0">
+            <a:pPr marL="0" indent="0">
               <a:buNone/>
             </a:pPr>
             <a:r>
@@ -3200,7 +2992,7 @@
           <a:bodyPr wrap="square" lIns="0" tIns="0" rIns="0" bIns="0" rtlCol="0" anchor="t"/>
           <a:lstStyle/>
           <a:p>
-            <a:pPr algn="l" indent="0" marL="0">
+            <a:pPr marL="0" indent="0" algn="l">
               <a:buNone/>
             </a:pPr>
             <a:r>
@@ -3239,7 +3031,7 @@
           <a:bodyPr wrap="square" lIns="0" tIns="0" rIns="0" bIns="0" rtlCol="0" anchor="t"/>
           <a:lstStyle/>
           <a:p>
-            <a:pPr indent="0" marL="0">
+            <a:pPr marL="0" indent="0">
               <a:buNone/>
             </a:pPr>
             <a:r>
@@ -3278,7 +3070,7 @@
           <a:bodyPr wrap="square" lIns="0" tIns="0" rIns="0" bIns="0" rtlCol="0" anchor="t"/>
           <a:lstStyle/>
           <a:p>
-            <a:pPr algn="l" indent="0" marL="0">
+            <a:pPr marL="0" indent="0" algn="l">
               <a:buNone/>
             </a:pPr>
             <a:r>
@@ -3317,7 +3109,7 @@
           <a:bodyPr wrap="square" lIns="0" tIns="0" rIns="0" bIns="0" rtlCol="0" anchor="t"/>
           <a:lstStyle/>
           <a:p>
-            <a:pPr indent="0" marL="0">
+            <a:pPr marL="0" indent="0">
               <a:buNone/>
             </a:pPr>
             <a:r>
@@ -3356,7 +3148,7 @@
           <a:bodyPr wrap="square" lIns="0" tIns="0" rIns="0" bIns="0" rtlCol="0" anchor="t"/>
           <a:lstStyle/>
           <a:p>
-            <a:pPr algn="l" indent="0" marL="0">
+            <a:pPr marL="0" indent="0" algn="l">
               <a:buNone/>
             </a:pPr>
             <a:r>
@@ -3376,14 +3168,14 @@
       </p:sp>
       <p:pic>
         <p:nvPicPr>
-          <p:cNvPr id="10" name="Image 0" descr="memory_llm.png">    </p:cNvPr>
+          <p:cNvPr id="10" name="Image 0" descr="memory_llm.png"/>
           <p:cNvPicPr>
             <a:picLocks noChangeAspect="1"/>
           </p:cNvPicPr>
           <p:nvPr/>
         </p:nvPicPr>
         <p:blipFill>
-          <a:blip r:embed="rId1"/>
+          <a:blip r:embed="rId3"/>
           <a:stretch>
             <a:fillRect/>
           </a:stretch>
@@ -3419,7 +3211,7 @@
           <a:bodyPr wrap="square" lIns="0" tIns="0" rIns="0" bIns="0" rtlCol="0" anchor="t"/>
           <a:lstStyle/>
           <a:p>
-            <a:pPr algn="ctr" indent="0" marL="0">
+            <a:pPr marL="0" indent="0" algn="ctr">
               <a:buNone/>
             </a:pPr>
             <a:r>
@@ -3458,7 +3250,7 @@
           <a:bodyPr wrap="square" lIns="0" tIns="0" rIns="0" bIns="0" rtlCol="0" anchor="ctr"/>
           <a:lstStyle/>
           <a:p>
-            <a:pPr algn="r" indent="0" marL="0">
+            <a:pPr marL="0" indent="0" algn="r">
               <a:buNone/>
             </a:pPr>
             <a:r>
@@ -3522,7 +3314,7 @@
           <a:bodyPr wrap="square" lIns="0" tIns="0" rIns="0" bIns="0" rtlCol="0" anchor="b"/>
           <a:lstStyle/>
           <a:p>
-            <a:pPr algn="l" indent="0" marL="0">
+            <a:pPr marL="0" indent="0" algn="l">
               <a:lnSpc>
                 <a:spcPct val="95000"/>
               </a:lnSpc>
@@ -3567,6 +3359,13 @@
             <a:prstDash val="solid"/>
           </a:ln>
         </p:spPr>
+        <p:txBody>
+          <a:bodyPr/>
+          <a:lstStyle/>
+          <a:p>
+            <a:endParaRPr lang="en-GB"/>
+          </a:p>
+        </p:txBody>
       </p:sp>
       <p:sp>
         <p:nvSpPr>
@@ -3589,7 +3388,7 @@
           <a:bodyPr wrap="square" lIns="0" tIns="0" rIns="0" bIns="0" rtlCol="0" anchor="t"/>
           <a:lstStyle/>
           <a:p>
-            <a:pPr indent="0" marL="0">
+            <a:pPr marL="0" indent="0">
               <a:buNone/>
             </a:pPr>
             <a:r>
@@ -3628,7 +3427,7 @@
           <a:bodyPr wrap="square" lIns="0" tIns="0" rIns="0" bIns="0" rtlCol="0" anchor="t"/>
           <a:lstStyle/>
           <a:p>
-            <a:pPr indent="0" marL="0">
+            <a:pPr marL="0" indent="0">
               <a:buNone/>
             </a:pPr>
             <a:r>
@@ -3672,6 +3471,13 @@
             <a:prstDash val="dash"/>
           </a:ln>
         </p:spPr>
+        <p:txBody>
+          <a:bodyPr/>
+          <a:lstStyle/>
+          <a:p>
+            <a:endParaRPr lang="en-GB"/>
+          </a:p>
+        </p:txBody>
       </p:sp>
       <p:sp>
         <p:nvSpPr>
@@ -3694,7 +3500,7 @@
           <a:bodyPr wrap="square" lIns="0" tIns="0" rIns="0" bIns="0" rtlCol="0" anchor="t"/>
           <a:lstStyle/>
           <a:p>
-            <a:pPr indent="0" marL="0">
+            <a:pPr marL="0" indent="0">
               <a:buNone/>
             </a:pPr>
             <a:r>
@@ -3733,7 +3539,7 @@
           <a:bodyPr wrap="square" lIns="0" tIns="0" rIns="0" bIns="0" rtlCol="0" anchor="t"/>
           <a:lstStyle/>
           <a:p>
-            <a:pPr indent="0" marL="0">
+            <a:pPr marL="0" indent="0">
               <a:buNone/>
             </a:pPr>
             <a:r>
@@ -3772,7 +3578,7 @@
           <a:bodyPr wrap="square" lIns="0" tIns="0" rIns="0" bIns="0" rtlCol="0" anchor="t"/>
           <a:lstStyle/>
           <a:p>
-            <a:pPr indent="0" marL="0">
+            <a:pPr marL="0" indent="0">
               <a:buNone/>
             </a:pPr>
             <a:r>
@@ -3816,6 +3622,13 @@
             <a:prstDash val="dash"/>
           </a:ln>
         </p:spPr>
+        <p:txBody>
+          <a:bodyPr/>
+          <a:lstStyle/>
+          <a:p>
+            <a:endParaRPr lang="en-GB"/>
+          </a:p>
+        </p:txBody>
       </p:sp>
       <p:sp>
         <p:nvSpPr>
@@ -3838,7 +3651,7 @@
           <a:bodyPr wrap="square" lIns="0" tIns="0" rIns="0" bIns="0" rtlCol="0" anchor="t"/>
           <a:lstStyle/>
           <a:p>
-            <a:pPr indent="0" marL="0">
+            <a:pPr marL="0" indent="0">
               <a:buNone/>
             </a:pPr>
             <a:r>
@@ -3877,7 +3690,7 @@
           <a:bodyPr wrap="square" lIns="0" tIns="0" rIns="0" bIns="0" rtlCol="0" anchor="t"/>
           <a:lstStyle/>
           <a:p>
-            <a:pPr indent="0" marL="0">
+            <a:pPr marL="0" indent="0">
               <a:buNone/>
             </a:pPr>
             <a:r>
@@ -3916,7 +3729,7 @@
           <a:bodyPr wrap="square" lIns="0" tIns="0" rIns="0" bIns="0" rtlCol="0" anchor="t"/>
           <a:lstStyle/>
           <a:p>
-            <a:pPr indent="0" marL="0">
+            <a:pPr marL="0" indent="0">
               <a:buNone/>
             </a:pPr>
             <a:r>
@@ -3960,6 +3773,13 @@
             <a:prstDash val="dash"/>
           </a:ln>
         </p:spPr>
+        <p:txBody>
+          <a:bodyPr/>
+          <a:lstStyle/>
+          <a:p>
+            <a:endParaRPr lang="en-GB"/>
+          </a:p>
+        </p:txBody>
       </p:sp>
       <p:sp>
         <p:nvSpPr>
@@ -3982,7 +3802,7 @@
           <a:bodyPr wrap="square" lIns="0" tIns="0" rIns="0" bIns="0" rtlCol="0" anchor="t"/>
           <a:lstStyle/>
           <a:p>
-            <a:pPr indent="0" marL="0">
+            <a:pPr marL="0" indent="0">
               <a:buNone/>
             </a:pPr>
             <a:r>
@@ -4021,7 +3841,7 @@
           <a:bodyPr wrap="square" lIns="0" tIns="0" rIns="0" bIns="0" rtlCol="0" anchor="t"/>
           <a:lstStyle/>
           <a:p>
-            <a:pPr indent="0" marL="0">
+            <a:pPr marL="0" indent="0">
               <a:buNone/>
             </a:pPr>
             <a:r>
@@ -4060,7 +3880,7 @@
           <a:bodyPr wrap="square" lIns="0" tIns="0" rIns="0" bIns="0" rtlCol="0" anchor="t"/>
           <a:lstStyle/>
           <a:p>
-            <a:pPr indent="0" marL="0">
+            <a:pPr marL="0" indent="0">
               <a:buNone/>
             </a:pPr>
             <a:r>
@@ -4104,6 +3924,13 @@
             <a:prstDash val="dash"/>
           </a:ln>
         </p:spPr>
+        <p:txBody>
+          <a:bodyPr/>
+          <a:lstStyle/>
+          <a:p>
+            <a:endParaRPr lang="en-GB"/>
+          </a:p>
+        </p:txBody>
       </p:sp>
       <p:sp>
         <p:nvSpPr>
@@ -4126,7 +3953,7 @@
           <a:bodyPr wrap="square" lIns="0" tIns="0" rIns="0" bIns="0" rtlCol="0" anchor="t"/>
           <a:lstStyle/>
           <a:p>
-            <a:pPr indent="0" marL="0">
+            <a:pPr marL="0" indent="0">
               <a:buNone/>
             </a:pPr>
             <a:r>
@@ -4165,7 +3992,7 @@
           <a:bodyPr wrap="square" lIns="0" tIns="0" rIns="0" bIns="0" rtlCol="0" anchor="ctr"/>
           <a:lstStyle/>
           <a:p>
-            <a:pPr algn="r" indent="0" marL="0">
+            <a:pPr marL="0" indent="0" algn="r">
               <a:buNone/>
             </a:pPr>
             <a:r>
@@ -4229,7 +4056,7 @@
           <a:bodyPr wrap="square" lIns="0" tIns="0" rIns="0" bIns="0" rtlCol="0" anchor="b"/>
           <a:lstStyle/>
           <a:p>
-            <a:pPr algn="l" indent="0" marL="0">
+            <a:pPr marL="0" indent="0" algn="l">
               <a:lnSpc>
                 <a:spcPct val="95000"/>
               </a:lnSpc>
@@ -4274,6 +4101,13 @@
             <a:prstDash val="solid"/>
           </a:ln>
         </p:spPr>
+        <p:txBody>
+          <a:bodyPr/>
+          <a:lstStyle/>
+          <a:p>
+            <a:endParaRPr lang="en-GB"/>
+          </a:p>
+        </p:txBody>
       </p:sp>
       <p:sp>
         <p:nvSpPr>
@@ -4297,6 +4131,13 @@
             <a:prstDash val="solid"/>
           </a:ln>
         </p:spPr>
+        <p:txBody>
+          <a:bodyPr/>
+          <a:lstStyle/>
+          <a:p>
+            <a:endParaRPr lang="en-GB"/>
+          </a:p>
+        </p:txBody>
       </p:sp>
       <p:sp>
         <p:nvSpPr>
@@ -4322,6 +4163,13 @@
             <a:prstDash val="solid"/>
           </a:ln>
         </p:spPr>
+        <p:txBody>
+          <a:bodyPr/>
+          <a:lstStyle/>
+          <a:p>
+            <a:endParaRPr lang="en-GB"/>
+          </a:p>
+        </p:txBody>
       </p:sp>
       <p:sp>
         <p:nvSpPr>
@@ -4344,7 +4192,7 @@
           <a:bodyPr wrap="square" lIns="0" tIns="0" rIns="0" bIns="0" rtlCol="0" anchor="ctr"/>
           <a:lstStyle/>
           <a:p>
-            <a:pPr algn="ctr" indent="0" marL="0">
+            <a:pPr marL="0" indent="0" algn="ctr">
               <a:buNone/>
             </a:pPr>
             <a:r>
@@ -4383,7 +4231,7 @@
           <a:bodyPr wrap="square" lIns="0" tIns="0" rIns="0" bIns="0" rtlCol="0" anchor="t"/>
           <a:lstStyle/>
           <a:p>
-            <a:pPr algn="ctr" indent="0" marL="0">
+            <a:pPr marL="0" indent="0" algn="ctr">
               <a:buNone/>
             </a:pPr>
             <a:r>
@@ -4425,6 +4273,13 @@
             <a:prstDash val="solid"/>
           </a:ln>
         </p:spPr>
+        <p:txBody>
+          <a:bodyPr/>
+          <a:lstStyle/>
+          <a:p>
+            <a:endParaRPr lang="en-GB"/>
+          </a:p>
+        </p:txBody>
       </p:sp>
       <p:sp>
         <p:nvSpPr>
@@ -4447,7 +4302,7 @@
           <a:bodyPr wrap="square" lIns="0" tIns="0" rIns="0" bIns="0" rtlCol="0" anchor="ctr"/>
           <a:lstStyle/>
           <a:p>
-            <a:pPr algn="ctr" indent="0" marL="0">
+            <a:pPr marL="0" indent="0" algn="ctr">
               <a:buNone/>
             </a:pPr>
             <a:r>
@@ -4486,7 +4341,7 @@
           <a:bodyPr wrap="square" lIns="0" tIns="0" rIns="0" bIns="0" rtlCol="0" anchor="t"/>
           <a:lstStyle/>
           <a:p>
-            <a:pPr algn="ctr" indent="0" marL="0">
+            <a:pPr marL="0" indent="0" algn="ctr">
               <a:buNone/>
             </a:pPr>
             <a:r>
@@ -4528,6 +4383,13 @@
             <a:prstDash val="solid"/>
           </a:ln>
         </p:spPr>
+        <p:txBody>
+          <a:bodyPr/>
+          <a:lstStyle/>
+          <a:p>
+            <a:endParaRPr lang="en-GB"/>
+          </a:p>
+        </p:txBody>
       </p:sp>
       <p:sp>
         <p:nvSpPr>
@@ -4550,7 +4412,7 @@
           <a:bodyPr wrap="square" lIns="0" tIns="0" rIns="0" bIns="0" rtlCol="0" anchor="ctr"/>
           <a:lstStyle/>
           <a:p>
-            <a:pPr algn="ctr" indent="0" marL="0">
+            <a:pPr marL="0" indent="0" algn="ctr">
               <a:buNone/>
             </a:pPr>
             <a:r>
@@ -4589,7 +4451,7 @@
           <a:bodyPr wrap="square" lIns="0" tIns="0" rIns="0" bIns="0" rtlCol="0" anchor="t"/>
           <a:lstStyle/>
           <a:p>
-            <a:pPr algn="ctr" indent="0" marL="0">
+            <a:pPr marL="0" indent="0" algn="ctr">
               <a:buNone/>
             </a:pPr>
             <a:r>
@@ -4631,6 +4493,13 @@
             <a:prstDash val="solid"/>
           </a:ln>
         </p:spPr>
+        <p:txBody>
+          <a:bodyPr/>
+          <a:lstStyle/>
+          <a:p>
+            <a:endParaRPr lang="en-GB"/>
+          </a:p>
+        </p:txBody>
       </p:sp>
       <p:sp>
         <p:nvSpPr>
@@ -4653,7 +4522,7 @@
           <a:bodyPr wrap="square" lIns="0" tIns="0" rIns="0" bIns="0" rtlCol="0" anchor="ctr"/>
           <a:lstStyle/>
           <a:p>
-            <a:pPr algn="ctr" indent="0" marL="0">
+            <a:pPr marL="0" indent="0" algn="ctr">
               <a:buNone/>
             </a:pPr>
             <a:r>
@@ -4692,7 +4561,7 @@
           <a:bodyPr wrap="square" lIns="0" tIns="0" rIns="0" bIns="0" rtlCol="0" anchor="t"/>
           <a:lstStyle/>
           <a:p>
-            <a:pPr algn="ctr" indent="0" marL="0">
+            <a:pPr marL="0" indent="0" algn="ctr">
               <a:buNone/>
             </a:pPr>
             <a:r>
@@ -4731,7 +4600,7 @@
           <a:bodyPr wrap="square" lIns="0" tIns="0" rIns="0" bIns="0" rtlCol="0" anchor="ctr"/>
           <a:lstStyle/>
           <a:p>
-            <a:pPr algn="ctr" indent="0" marL="0">
+            <a:pPr marL="0" indent="0" algn="ctr">
               <a:buNone/>
             </a:pPr>
             <a:r>
@@ -4770,7 +4639,7 @@
           <a:bodyPr wrap="square" lIns="0" tIns="0" rIns="0" bIns="0" rtlCol="0" anchor="ctr"/>
           <a:lstStyle/>
           <a:p>
-            <a:pPr algn="r" indent="0" marL="0">
+            <a:pPr marL="0" indent="0" algn="r">
               <a:buNone/>
             </a:pPr>
             <a:r>
@@ -4834,7 +4703,7 @@
           <a:bodyPr wrap="square" lIns="0" tIns="0" rIns="0" bIns="0" rtlCol="0" anchor="b"/>
           <a:lstStyle/>
           <a:p>
-            <a:pPr algn="r" indent="0" marL="0">
+            <a:pPr marL="0" indent="0" algn="r">
               <a:lnSpc>
                 <a:spcPct val="95000"/>
               </a:lnSpc>
@@ -4879,6 +4748,13 @@
             <a:prstDash val="solid"/>
           </a:ln>
         </p:spPr>
+        <p:txBody>
+          <a:bodyPr/>
+          <a:lstStyle/>
+          <a:p>
+            <a:endParaRPr lang="en-GB"/>
+          </a:p>
+        </p:txBody>
       </p:sp>
       <p:sp>
         <p:nvSpPr>
@@ -4901,7 +4777,7 @@
           <a:bodyPr wrap="square" lIns="0" tIns="0" rIns="0" bIns="0" rtlCol="0" anchor="t"/>
           <a:lstStyle/>
           <a:p>
-            <a:pPr indent="0" marL="0">
+            <a:pPr marL="0" indent="0">
               <a:buNone/>
             </a:pPr>
             <a:r>
@@ -4940,7 +4816,7 @@
           <a:bodyPr wrap="square" lIns="0" tIns="0" rIns="0" bIns="0" rtlCol="0" anchor="t"/>
           <a:lstStyle/>
           <a:p>
-            <a:pPr indent="0" marL="0">
+            <a:pPr marL="0" indent="0">
               <a:buNone/>
             </a:pPr>
             <a:r>
@@ -4979,7 +4855,7 @@
           <a:bodyPr wrap="square" lIns="0" tIns="0" rIns="0" bIns="0" rtlCol="0" anchor="t"/>
           <a:lstStyle/>
           <a:p>
-            <a:pPr indent="0" marL="0">
+            <a:pPr marL="0" indent="0">
               <a:buNone/>
             </a:pPr>
             <a:r>
@@ -5018,7 +4894,7 @@
           <a:bodyPr wrap="square" lIns="0" tIns="0" rIns="0" bIns="0" rtlCol="0" anchor="t"/>
           <a:lstStyle/>
           <a:p>
-            <a:pPr indent="0" marL="0">
+            <a:pPr marL="0" indent="0">
               <a:buNone/>
             </a:pPr>
             <a:r>
@@ -5057,7 +4933,7 @@
           <a:bodyPr wrap="square" lIns="0" tIns="0" rIns="0" bIns="0" rtlCol="0" anchor="t"/>
           <a:lstStyle/>
           <a:p>
-            <a:pPr indent="0" marL="0">
+            <a:pPr marL="0" indent="0">
               <a:buNone/>
             </a:pPr>
             <a:r>
@@ -5096,7 +4972,7 @@
           <a:bodyPr wrap="square" lIns="0" tIns="0" rIns="0" bIns="0" rtlCol="0" anchor="t"/>
           <a:lstStyle/>
           <a:p>
-            <a:pPr indent="0" marL="0">
+            <a:pPr marL="0" indent="0">
               <a:buNone/>
             </a:pPr>
             <a:r>
@@ -5135,7 +5011,7 @@
           <a:bodyPr wrap="square" lIns="0" tIns="0" rIns="0" bIns="0" rtlCol="0" anchor="t"/>
           <a:lstStyle/>
           <a:p>
-            <a:pPr indent="0" marL="0">
+            <a:pPr marL="0" indent="0">
               <a:buNone/>
             </a:pPr>
             <a:r>
@@ -5174,7 +5050,7 @@
           <a:bodyPr wrap="square" lIns="0" tIns="0" rIns="0" bIns="0" rtlCol="0" anchor="t"/>
           <a:lstStyle/>
           <a:p>
-            <a:pPr indent="0" marL="0">
+            <a:pPr marL="0" indent="0">
               <a:buNone/>
             </a:pPr>
             <a:r>
@@ -5213,7 +5089,7 @@
           <a:bodyPr wrap="square" lIns="0" tIns="0" rIns="0" bIns="0" rtlCol="0" anchor="ctr"/>
           <a:lstStyle/>
           <a:p>
-            <a:pPr algn="r" indent="0" marL="0">
+            <a:pPr marL="0" indent="0" algn="r">
               <a:buNone/>
             </a:pPr>
             <a:r>
@@ -5247,6 +5123,7 @@
         <a:solidFill>
           <a:srgbClr val="29343A"/>
         </a:solidFill>
+        <a:effectLst/>
       </p:bgPr>
     </p:bg>
     <p:spTree>
@@ -5284,7 +5161,7 @@
           <a:bodyPr wrap="square" lIns="0" tIns="0" rIns="0" bIns="0" rtlCol="0" anchor="b"/>
           <a:lstStyle/>
           <a:p>
-            <a:pPr algn="ctr" indent="0" marL="0">
+            <a:pPr marL="0" indent="0" algn="ctr">
               <a:lnSpc>
                 <a:spcPct val="90000"/>
               </a:lnSpc>
@@ -5329,6 +5206,13 @@
             <a:prstDash val="solid"/>
           </a:ln>
         </p:spPr>
+        <p:txBody>
+          <a:bodyPr/>
+          <a:lstStyle/>
+          <a:p>
+            <a:endParaRPr lang="en-GB"/>
+          </a:p>
+        </p:txBody>
       </p:sp>
       <p:sp>
         <p:nvSpPr>
@@ -5351,7 +5235,7 @@
           <a:bodyPr wrap="square" lIns="0" tIns="0" rIns="0" bIns="0" rtlCol="0" anchor="ctr"/>
           <a:lstStyle/>
           <a:p>
-            <a:pPr algn="ctr" indent="0" marL="0">
+            <a:pPr marL="0" indent="0" algn="ctr">
               <a:buNone/>
             </a:pPr>
             <a:r>
@@ -5390,7 +5274,7 @@
           <a:bodyPr wrap="square" lIns="0" tIns="0" rIns="0" bIns="0" rtlCol="0" anchor="b"/>
           <a:lstStyle/>
           <a:p>
-            <a:pPr indent="0" marL="0">
+            <a:pPr marL="0" indent="0">
               <a:buNone/>
             </a:pPr>
             <a:r>
@@ -5407,7 +5291,7 @@
             <a:endParaRPr lang="en-US" sz="1100" dirty="0"/>
           </a:p>
           <a:p>
-            <a:pPr indent="0" marL="0">
+            <a:pPr marL="0" indent="0">
               <a:buNone/>
             </a:pPr>
             <a:r>
@@ -5446,7 +5330,7 @@
           <a:bodyPr wrap="square" lIns="0" tIns="0" rIns="0" bIns="0" rtlCol="0" anchor="ctr"/>
           <a:lstStyle/>
           <a:p>
-            <a:pPr algn="r" indent="0" marL="0">
+            <a:pPr marL="0" indent="0" algn="r">
               <a:buNone/>
             </a:pPr>
             <a:r>
@@ -5510,7 +5394,7 @@
           <a:bodyPr wrap="square" lIns="0" tIns="0" rIns="0" bIns="0" rtlCol="0" anchor="b"/>
           <a:lstStyle/>
           <a:p>
-            <a:pPr algn="l" indent="0" marL="0">
+            <a:pPr marL="0" indent="0" algn="l">
               <a:lnSpc>
                 <a:spcPct val="95000"/>
               </a:lnSpc>
@@ -5525,7 +5409,7 @@
                 <a:ea typeface="Georgia" pitchFamily="34" charset="-122"/>
                 <a:cs typeface="Georgia" pitchFamily="34" charset="-120"/>
               </a:rPr>
-              <a:t>The Project in One Slide</a:t>
+              <a:t>A Recap of my Work so Far</a:t>
             </a:r>
             <a:endParaRPr lang="en-US" sz="3400" dirty="0"/>
           </a:p>
@@ -5555,6 +5439,13 @@
             <a:prstDash val="solid"/>
           </a:ln>
         </p:spPr>
+        <p:txBody>
+          <a:bodyPr/>
+          <a:lstStyle/>
+          <a:p>
+            <a:endParaRPr lang="en-GB"/>
+          </a:p>
+        </p:txBody>
       </p:sp>
       <p:sp>
         <p:nvSpPr>
@@ -5582,13 +5473,20 @@
             <a:prstDash val="solid"/>
           </a:ln>
           <a:effectLst>
-            <a:outerShdw sx="100000" sy="100000" kx="0" ky="0" algn="bl" rotWithShape="0" blurRad="76200" dist="25400" dir="5400000">
+            <a:outerShdw blurRad="76200" dist="25400" dir="5400000" algn="bl" rotWithShape="0">
               <a:srgbClr val="000000">
                 <a:alpha val="8000"/>
               </a:srgbClr>
             </a:outerShdw>
           </a:effectLst>
         </p:spPr>
+        <p:txBody>
+          <a:bodyPr/>
+          <a:lstStyle/>
+          <a:p>
+            <a:endParaRPr lang="en-GB"/>
+          </a:p>
+        </p:txBody>
       </p:sp>
       <p:sp>
         <p:nvSpPr>
@@ -5611,11 +5509,11 @@
           <a:bodyPr wrap="square" lIns="0" tIns="0" rIns="0" bIns="0" rtlCol="0" anchor="ctr"/>
           <a:lstStyle/>
           <a:p>
-            <a:pPr indent="0" marL="0">
-              <a:buNone/>
-            </a:pPr>
-            <a:r>
-              <a:rPr lang="en-US" sz="1300" spc="100" kern="0" dirty="0">
+            <a:pPr marL="0" indent="0">
+              <a:buNone/>
+            </a:pPr>
+            <a:r>
+              <a:rPr lang="en-US" sz="1300" kern="0" spc="100" dirty="0">
                 <a:solidFill>
                   <a:srgbClr val="8F8F8F"/>
                 </a:solidFill>
@@ -5650,7 +5548,7 @@
           <a:bodyPr wrap="square" lIns="0" tIns="0" rIns="0" bIns="0" rtlCol="0" anchor="t"/>
           <a:lstStyle/>
           <a:p>
-            <a:pPr indent="0" marL="0">
+            <a:pPr marL="0" indent="0">
               <a:buNone/>
             </a:pPr>
             <a:r>
@@ -5689,7 +5587,7 @@
           <a:bodyPr wrap="square" lIns="0" tIns="0" rIns="0" bIns="0" rtlCol="0" anchor="t"/>
           <a:lstStyle/>
           <a:p>
-            <a:pPr indent="0" marL="0">
+            <a:pPr marL="0" indent="0">
               <a:buNone/>
             </a:pPr>
             <a:r>
@@ -5701,7 +5599,7 @@
                 <a:ea typeface="Calibri" pitchFamily="34" charset="-122"/>
                 <a:cs typeface="Calibri" pitchFamily="34" charset="-120"/>
               </a:rPr>
-              <a:t>AI agents increasingly share limited resources: compute, energy, budgets. An overseer can only audit a few of their actions.</a:t>
+              <a:t>AI agents increasingly share limited resources, such as compute, energy and budgets. An overseer can only audit a few of their actions.</a:t>
             </a:r>
             <a:endParaRPr lang="en-US" sz="1350" dirty="0"/>
           </a:p>
@@ -5733,13 +5631,20 @@
             <a:prstDash val="solid"/>
           </a:ln>
           <a:effectLst>
-            <a:outerShdw sx="100000" sy="100000" kx="0" ky="0" algn="bl" rotWithShape="0" blurRad="76200" dist="25400" dir="5400000">
+            <a:outerShdw blurRad="76200" dist="25400" dir="5400000" algn="bl" rotWithShape="0">
               <a:srgbClr val="000000">
                 <a:alpha val="8000"/>
               </a:srgbClr>
             </a:outerShdw>
           </a:effectLst>
         </p:spPr>
+        <p:txBody>
+          <a:bodyPr/>
+          <a:lstStyle/>
+          <a:p>
+            <a:endParaRPr lang="en-GB"/>
+          </a:p>
+        </p:txBody>
       </p:sp>
       <p:sp>
         <p:nvSpPr>
@@ -5762,11 +5667,11 @@
           <a:bodyPr wrap="square" lIns="0" tIns="0" rIns="0" bIns="0" rtlCol="0" anchor="ctr"/>
           <a:lstStyle/>
           <a:p>
-            <a:pPr indent="0" marL="0">
-              <a:buNone/>
-            </a:pPr>
-            <a:r>
-              <a:rPr lang="en-US" sz="1300" spc="100" kern="0" dirty="0">
+            <a:pPr marL="0" indent="0">
+              <a:buNone/>
+            </a:pPr>
+            <a:r>
+              <a:rPr lang="en-US" sz="1300" kern="0" spc="100" dirty="0">
                 <a:solidFill>
                   <a:srgbClr val="8F8F8F"/>
                 </a:solidFill>
@@ -5801,7 +5706,7 @@
           <a:bodyPr wrap="square" lIns="0" tIns="0" rIns="0" bIns="0" rtlCol="0" anchor="t"/>
           <a:lstStyle/>
           <a:p>
-            <a:pPr indent="0" marL="0">
+            <a:pPr marL="0" indent="0">
               <a:buNone/>
             </a:pPr>
             <a:r>
@@ -5840,7 +5745,7 @@
           <a:bodyPr wrap="square" lIns="0" tIns="0" rIns="0" bIns="0" rtlCol="0" anchor="t"/>
           <a:lstStyle/>
           <a:p>
-            <a:pPr indent="0" marL="0">
+            <a:pPr marL="0" indent="0">
               <a:buNone/>
             </a:pPr>
             <a:r>
@@ -5852,7 +5757,7 @@
                 <a:ea typeface="Calibri" pitchFamily="34" charset="-122"/>
                 <a:cs typeface="Calibri" pitchFamily="34" charset="-120"/>
               </a:rPr>
-              <a:t>Six agents use one renewable resource. A reviewer sets each agent's allowance; random audits check a few agents each round.</a:t>
+              <a:t>Six agents use one renewable resource. A reviewer sets each agent's allowance, and with random audits, checks a few agents each round.</a:t>
             </a:r>
             <a:endParaRPr lang="en-US" sz="1350" dirty="0"/>
           </a:p>
@@ -5884,13 +5789,20 @@
             <a:prstDash val="solid"/>
           </a:ln>
           <a:effectLst>
-            <a:outerShdw sx="100000" sy="100000" kx="0" ky="0" algn="bl" rotWithShape="0" blurRad="76200" dist="25400" dir="5400000">
+            <a:outerShdw blurRad="76200" dist="25400" dir="5400000" algn="bl" rotWithShape="0">
               <a:srgbClr val="000000">
                 <a:alpha val="8000"/>
               </a:srgbClr>
             </a:outerShdw>
           </a:effectLst>
         </p:spPr>
+        <p:txBody>
+          <a:bodyPr/>
+          <a:lstStyle/>
+          <a:p>
+            <a:endParaRPr lang="en-GB"/>
+          </a:p>
+        </p:txBody>
       </p:sp>
       <p:sp>
         <p:nvSpPr>
@@ -5913,11 +5825,11 @@
           <a:bodyPr wrap="square" lIns="0" tIns="0" rIns="0" bIns="0" rtlCol="0" anchor="ctr"/>
           <a:lstStyle/>
           <a:p>
-            <a:pPr indent="0" marL="0">
-              <a:buNone/>
-            </a:pPr>
-            <a:r>
-              <a:rPr lang="en-US" sz="1300" spc="100" kern="0" dirty="0">
+            <a:pPr marL="0" indent="0">
+              <a:buNone/>
+            </a:pPr>
+            <a:r>
+              <a:rPr lang="en-US" sz="1300" kern="0" spc="100" dirty="0">
                 <a:solidFill>
                   <a:srgbClr val="8F8F8F"/>
                 </a:solidFill>
@@ -5952,7 +5864,7 @@
           <a:bodyPr wrap="square" lIns="0" tIns="0" rIns="0" bIns="0" rtlCol="0" anchor="t"/>
           <a:lstStyle/>
           <a:p>
-            <a:pPr indent="0" marL="0">
+            <a:pPr marL="0" indent="0">
               <a:buNone/>
             </a:pPr>
             <a:r>
@@ -5991,7 +5903,7 @@
           <a:bodyPr wrap="square" lIns="0" tIns="0" rIns="0" bIns="0" rtlCol="0" anchor="t"/>
           <a:lstStyle/>
           <a:p>
-            <a:pPr indent="0" marL="0">
+            <a:pPr marL="0" indent="0">
               <a:buNone/>
             </a:pPr>
             <a:r>
@@ -6035,13 +5947,20 @@
             <a:prstDash val="solid"/>
           </a:ln>
           <a:effectLst>
-            <a:outerShdw sx="100000" sy="100000" kx="0" ky="0" algn="bl" rotWithShape="0" blurRad="76200" dist="25400" dir="5400000">
+            <a:outerShdw blurRad="76200" dist="25400" dir="5400000" algn="bl" rotWithShape="0">
               <a:srgbClr val="000000">
                 <a:alpha val="8000"/>
               </a:srgbClr>
             </a:outerShdw>
           </a:effectLst>
         </p:spPr>
+        <p:txBody>
+          <a:bodyPr/>
+          <a:lstStyle/>
+          <a:p>
+            <a:endParaRPr lang="en-GB"/>
+          </a:p>
+        </p:txBody>
       </p:sp>
       <p:sp>
         <p:nvSpPr>
@@ -6064,11 +5983,11 @@
           <a:bodyPr wrap="square" lIns="0" tIns="0" rIns="0" bIns="0" rtlCol="0" anchor="ctr"/>
           <a:lstStyle/>
           <a:p>
-            <a:pPr indent="0" marL="0">
-              <a:buNone/>
-            </a:pPr>
-            <a:r>
-              <a:rPr lang="en-US" sz="1300" spc="100" kern="0" dirty="0">
+            <a:pPr marL="0" indent="0">
+              <a:buNone/>
+            </a:pPr>
+            <a:r>
+              <a:rPr lang="en-US" sz="1300" kern="0" spc="100" dirty="0">
                 <a:solidFill>
                   <a:srgbClr val="8F8F8F"/>
                 </a:solidFill>
@@ -6103,7 +6022,7 @@
           <a:bodyPr wrap="square" lIns="0" tIns="0" rIns="0" bIns="0" rtlCol="0" anchor="t"/>
           <a:lstStyle/>
           <a:p>
-            <a:pPr indent="0" marL="0">
+            <a:pPr marL="0" indent="0">
               <a:buNone/>
             </a:pPr>
             <a:r>
@@ -6115,7 +6034,7 @@
                 <a:ea typeface="Georgia" pitchFamily="34" charset="-122"/>
                 <a:cs typeface="Georgia" pitchFamily="34" charset="-120"/>
               </a:rPr>
-              <a:t>Audits work through consequences</a:t>
+              <a:t>Audits work via consequences</a:t>
             </a:r>
             <a:endParaRPr lang="en-US" sz="1700" dirty="0"/>
           </a:p>
@@ -6129,7 +6048,7 @@
         </p:nvSpPr>
         <p:spPr>
           <a:xfrm>
-            <a:off x="9303791" y="3291840"/>
+            <a:off x="9303791" y="3005418"/>
             <a:ext cx="2110664" cy="1920240"/>
           </a:xfrm>
           <a:prstGeom prst="rect">
@@ -6142,7 +6061,7 @@
           <a:bodyPr wrap="square" lIns="0" tIns="0" rIns="0" bIns="0" rtlCol="0" anchor="t"/>
           <a:lstStyle/>
           <a:p>
-            <a:pPr indent="0" marL="0">
+            <a:pPr marL="0" indent="0">
               <a:buNone/>
             </a:pPr>
             <a:r>
@@ -6154,48 +6073,9 @@
                 <a:ea typeface="Calibri" pitchFamily="34" charset="-122"/>
                 <a:cs typeface="Calibri" pitchFamily="34" charset="-120"/>
               </a:rPr>
-              <a:t>The stopping fine is predictable from an agent's gain from over-taking, for programmed agents and for language models.</a:t>
+              <a:t>The stopping fine is predictable from an agent's gain from over-taking, for both programmed agents and for language models.</a:t>
             </a:r>
             <a:endParaRPr lang="en-US" sz="1350" dirty="0"/>
-          </a:p>
-        </p:txBody>
-      </p:sp>
-      <p:sp>
-        <p:nvSpPr>
-          <p:cNvPr id="20" name="Text 18"/>
-          <p:cNvSpPr txBox="1"/>
-          <p:nvPr/>
-        </p:nvSpPr>
-        <p:spPr>
-          <a:xfrm>
-            <a:off x="548640" y="5852160"/>
-            <a:ext cx="11094415" cy="411480"/>
-          </a:xfrm>
-          <a:prstGeom prst="rect">
-            <a:avLst/>
-          </a:prstGeom>
-          <a:noFill/>
-          <a:ln/>
-        </p:spPr>
-        <p:txBody>
-          <a:bodyPr wrap="square" lIns="0" tIns="0" rIns="0" bIns="0" rtlCol="0" anchor="ctr"/>
-          <a:lstStyle/>
-          <a:p>
-            <a:pPr algn="ctr" indent="0" marL="0">
-              <a:buNone/>
-            </a:pPr>
-            <a:r>
-              <a:rPr lang="en-US" sz="1500" i="1" dirty="0">
-                <a:solidFill>
-                  <a:srgbClr val="55524E"/>
-                </a:solidFill>
-                <a:latin typeface="Calibri" pitchFamily="34" charset="0"/>
-                <a:ea typeface="Calibri" pitchFamily="34" charset="-122"/>
-                <a:cs typeface="Calibri" pitchFamily="34" charset="-120"/>
-              </a:rPr>
-              <a:t>Next: the setting, the method, five findings, and what is still running</a:t>
-            </a:r>
-            <a:endParaRPr lang="en-US" sz="1500" dirty="0"/>
           </a:p>
         </p:txBody>
       </p:sp>
@@ -6220,7 +6100,7 @@
           <a:bodyPr wrap="square" lIns="0" tIns="0" rIns="0" bIns="0" rtlCol="0" anchor="ctr"/>
           <a:lstStyle/>
           <a:p>
-            <a:pPr algn="r" indent="0" marL="0">
+            <a:pPr marL="0" indent="0" algn="r">
               <a:buNone/>
             </a:pPr>
             <a:r>
@@ -6284,7 +6164,7 @@
           <a:bodyPr wrap="square" lIns="0" tIns="0" rIns="0" bIns="0" rtlCol="0" anchor="b"/>
           <a:lstStyle/>
           <a:p>
-            <a:pPr algn="l" indent="0" marL="0">
+            <a:pPr marL="0" indent="0" algn="l">
               <a:lnSpc>
                 <a:spcPct val="95000"/>
               </a:lnSpc>
@@ -6329,6 +6209,13 @@
             <a:prstDash val="solid"/>
           </a:ln>
         </p:spPr>
+        <p:txBody>
+          <a:bodyPr/>
+          <a:lstStyle/>
+          <a:p>
+            <a:endParaRPr lang="en-GB"/>
+          </a:p>
+        </p:txBody>
       </p:sp>
       <p:sp>
         <p:nvSpPr>
@@ -6351,7 +6238,7 @@
           <a:bodyPr wrap="square" lIns="0" tIns="0" rIns="0" bIns="0" rtlCol="0" anchor="t"/>
           <a:lstStyle/>
           <a:p>
-            <a:pPr indent="0" marL="0">
+            <a:pPr marL="0" indent="0">
               <a:buNone/>
             </a:pPr>
             <a:r>
@@ -6390,7 +6277,7 @@
           <a:bodyPr wrap="square" lIns="0" tIns="0" rIns="0" bIns="0" rtlCol="0" anchor="t"/>
           <a:lstStyle/>
           <a:p>
-            <a:pPr algn="just" indent="0" marL="0">
+            <a:pPr marL="0" indent="0" algn="just">
               <a:buNone/>
             </a:pPr>
             <a:r>
@@ -6402,7 +6289,29 @@
                 <a:ea typeface="Calibri" pitchFamily="34" charset="-122"/>
                 <a:cs typeface="Calibri" pitchFamily="34" charset="-120"/>
               </a:rPr>
-              <a:t>Each round, an agent may take its allowance. Taking more, over-taking, helps that agent and costs everyone else.</a:t>
+              <a:t>Each round, an agent may take its allowance. Taking more </a:t>
+            </a:r>
+            <a:r>
+              <a:rPr lang="en-US" sz="1400" b="1" dirty="0">
+                <a:solidFill>
+                  <a:srgbClr val="1C191A"/>
+                </a:solidFill>
+                <a:latin typeface="Calibri" pitchFamily="34" charset="0"/>
+                <a:ea typeface="Calibri" pitchFamily="34" charset="-122"/>
+                <a:cs typeface="Calibri" pitchFamily="34" charset="-120"/>
+              </a:rPr>
+              <a:t>aka over-taking</a:t>
+            </a:r>
+            <a:r>
+              <a:rPr lang="en-US" sz="1400" dirty="0">
+                <a:solidFill>
+                  <a:srgbClr val="1C191A"/>
+                </a:solidFill>
+                <a:latin typeface="Calibri" pitchFamily="34" charset="0"/>
+                <a:ea typeface="Calibri" pitchFamily="34" charset="-122"/>
+                <a:cs typeface="Calibri" pitchFamily="34" charset="-120"/>
+              </a:rPr>
+              <a:t> helps that agent and costs everyone else.</a:t>
             </a:r>
             <a:endParaRPr lang="en-US" sz="1400" dirty="0"/>
           </a:p>
@@ -6429,7 +6338,7 @@
           <a:bodyPr wrap="square" lIns="0" tIns="0" rIns="0" bIns="0" rtlCol="0" anchor="t"/>
           <a:lstStyle/>
           <a:p>
-            <a:pPr indent="0" marL="0">
+            <a:pPr marL="0" indent="0">
               <a:buNone/>
             </a:pPr>
             <a:r>
@@ -6468,7 +6377,7 @@
           <a:bodyPr wrap="square" lIns="0" tIns="0" rIns="0" bIns="0" rtlCol="0" anchor="t"/>
           <a:lstStyle/>
           <a:p>
-            <a:pPr algn="just" indent="0" marL="0">
+            <a:pPr marL="0" indent="0" algn="just">
               <a:buNone/>
             </a:pPr>
             <a:r>
@@ -6480,7 +6389,7 @@
                 <a:ea typeface="Calibri" pitchFamily="34" charset="-122"/>
                 <a:cs typeface="Calibri" pitchFamily="34" charset="-120"/>
               </a:rPr>
-              <a:t>Auditing every action is too costly, so random audits check a few agents, as tax and fisheries inspectors do.</a:t>
+              <a:t>Auditing every action is too costly, so random audits check a few agents, similar to taxing/behavior of fishery inspectors.</a:t>
             </a:r>
             <a:endParaRPr lang="en-US" sz="1400" dirty="0"/>
           </a:p>
@@ -6507,7 +6416,7 @@
           <a:bodyPr wrap="square" lIns="0" tIns="0" rIns="0" bIns="0" rtlCol="0" anchor="t"/>
           <a:lstStyle/>
           <a:p>
-            <a:pPr indent="0" marL="0">
+            <a:pPr marL="0" indent="0">
               <a:buNone/>
             </a:pPr>
             <a:r>
@@ -6546,7 +6455,7 @@
           <a:bodyPr wrap="square" lIns="0" tIns="0" rIns="0" bIns="0" rtlCol="0" anchor="t"/>
           <a:lstStyle/>
           <a:p>
-            <a:pPr algn="just" indent="0" marL="0">
+            <a:pPr marL="0" indent="0" algn="just">
               <a:buNone/>
             </a:pPr>
             <a:r>
@@ -6566,14 +6475,14 @@
       </p:sp>
       <p:pic>
         <p:nvPicPr>
-          <p:cNvPr id="10" name="Image 0" descr="fig_networks.png">    </p:cNvPr>
+          <p:cNvPr id="10" name="Image 0" descr="fig_networks.png"/>
           <p:cNvPicPr>
             <a:picLocks noChangeAspect="1"/>
           </p:cNvPicPr>
           <p:nvPr/>
         </p:nvPicPr>
         <p:blipFill>
-          <a:blip r:embed="rId1"/>
+          <a:blip r:embed="rId3"/>
           <a:stretch>
             <a:fillRect/>
           </a:stretch>
@@ -6609,7 +6518,7 @@
           <a:bodyPr wrap="square" lIns="0" tIns="0" rIns="0" bIns="0" rtlCol="0" anchor="t"/>
           <a:lstStyle/>
           <a:p>
-            <a:pPr algn="ctr" indent="0" marL="0">
+            <a:pPr marL="0" indent="0" algn="ctr">
               <a:buNone/>
             </a:pPr>
             <a:r>
@@ -6648,7 +6557,7 @@
           <a:bodyPr wrap="square" lIns="0" tIns="0" rIns="0" bIns="0" rtlCol="0" anchor="ctr"/>
           <a:lstStyle/>
           <a:p>
-            <a:pPr algn="r" indent="0" marL="0">
+            <a:pPr marL="0" indent="0" algn="r">
               <a:buNone/>
             </a:pPr>
             <a:r>
@@ -6712,7 +6621,7 @@
           <a:bodyPr wrap="square" lIns="0" tIns="0" rIns="0" bIns="0" rtlCol="0" anchor="b"/>
           <a:lstStyle/>
           <a:p>
-            <a:pPr algn="l" indent="0" marL="0">
+            <a:pPr marL="0" indent="0" algn="l">
               <a:lnSpc>
                 <a:spcPct val="95000"/>
               </a:lnSpc>
@@ -6757,6 +6666,13 @@
             <a:prstDash val="solid"/>
           </a:ln>
         </p:spPr>
+        <p:txBody>
+          <a:bodyPr/>
+          <a:lstStyle/>
+          <a:p>
+            <a:endParaRPr lang="en-GB"/>
+          </a:p>
+        </p:txBody>
       </p:sp>
       <p:sp>
         <p:nvSpPr>
@@ -6779,7 +6695,7 @@
           <a:bodyPr wrap="square" lIns="0" tIns="0" rIns="0" bIns="0" rtlCol="0" anchor="t"/>
           <a:lstStyle/>
           <a:p>
-            <a:pPr indent="0" marL="0">
+            <a:pPr marL="0" indent="0">
               <a:buNone/>
             </a:pPr>
             <a:r>
@@ -6818,7 +6734,7 @@
           <a:bodyPr wrap="square" lIns="0" tIns="0" rIns="0" bIns="0" rtlCol="0" anchor="t"/>
           <a:lstStyle/>
           <a:p>
-            <a:pPr indent="0" marL="0">
+            <a:pPr marL="0" indent="0">
               <a:buNone/>
             </a:pPr>
             <a:r>
@@ -6857,7 +6773,7 @@
           <a:bodyPr wrap="square" lIns="0" tIns="0" rIns="0" bIns="0" rtlCol="0" anchor="t"/>
           <a:lstStyle/>
           <a:p>
-            <a:pPr algn="just" indent="0" marL="0">
+            <a:pPr marL="0" indent="0" algn="just">
               <a:buNone/>
             </a:pPr>
             <a:r>
@@ -6896,7 +6812,7 @@
           <a:bodyPr wrap="square" lIns="0" tIns="0" rIns="0" bIns="0" rtlCol="0" anchor="t"/>
           <a:lstStyle/>
           <a:p>
-            <a:pPr indent="0" marL="0">
+            <a:pPr marL="0" indent="0">
               <a:buNone/>
             </a:pPr>
             <a:r>
@@ -6935,7 +6851,7 @@
           <a:bodyPr wrap="square" lIns="0" tIns="0" rIns="0" bIns="0" rtlCol="0" anchor="t"/>
           <a:lstStyle/>
           <a:p>
-            <a:pPr indent="0" marL="0">
+            <a:pPr marL="0" indent="0">
               <a:buNone/>
             </a:pPr>
             <a:r>
@@ -6974,7 +6890,7 @@
           <a:bodyPr wrap="square" lIns="0" tIns="0" rIns="0" bIns="0" rtlCol="0" anchor="t"/>
           <a:lstStyle/>
           <a:p>
-            <a:pPr algn="just" indent="0" marL="0">
+            <a:pPr marL="0" indent="0" algn="just">
               <a:buNone/>
             </a:pPr>
             <a:r>
@@ -7013,7 +6929,7 @@
           <a:bodyPr wrap="square" lIns="0" tIns="0" rIns="0" bIns="0" rtlCol="0" anchor="t"/>
           <a:lstStyle/>
           <a:p>
-            <a:pPr indent="0" marL="0">
+            <a:pPr marL="0" indent="0">
               <a:buNone/>
             </a:pPr>
             <a:r>
@@ -7052,7 +6968,7 @@
           <a:bodyPr wrap="square" lIns="0" tIns="0" rIns="0" bIns="0" rtlCol="0" anchor="t"/>
           <a:lstStyle/>
           <a:p>
-            <a:pPr indent="0" marL="0">
+            <a:pPr marL="0" indent="0">
               <a:buNone/>
             </a:pPr>
             <a:r>
@@ -7091,7 +7007,7 @@
           <a:bodyPr wrap="square" lIns="0" tIns="0" rIns="0" bIns="0" rtlCol="0" anchor="t"/>
           <a:lstStyle/>
           <a:p>
-            <a:pPr algn="just" indent="0" marL="0">
+            <a:pPr marL="0" indent="0" algn="just">
               <a:buNone/>
             </a:pPr>
             <a:r>
@@ -7130,7 +7046,7 @@
           <a:bodyPr wrap="square" lIns="0" tIns="0" rIns="0" bIns="0" rtlCol="0" anchor="ctr"/>
           <a:lstStyle/>
           <a:p>
-            <a:pPr algn="r" indent="0" marL="0">
+            <a:pPr marL="0" indent="0" algn="r">
               <a:buNone/>
             </a:pPr>
             <a:r>
@@ -7194,7 +7110,7 @@
           <a:bodyPr wrap="square" lIns="0" tIns="0" rIns="0" bIns="0" rtlCol="0" anchor="b"/>
           <a:lstStyle/>
           <a:p>
-            <a:pPr algn="ctr" indent="0" marL="0">
+            <a:pPr marL="0" indent="0" algn="ctr">
               <a:lnSpc>
                 <a:spcPct val="95000"/>
               </a:lnSpc>
@@ -7217,14 +7133,14 @@
       </p:sp>
       <p:pic>
         <p:nvPicPr>
-          <p:cNvPr id="3" name="Image 0" descr="fig1_game_step.png">    </p:cNvPr>
+          <p:cNvPr id="3" name="Image 0" descr="fig1_game_step.png"/>
           <p:cNvPicPr>
             <a:picLocks noChangeAspect="1"/>
           </p:cNvPicPr>
           <p:nvPr/>
         </p:nvPicPr>
         <p:blipFill>
-          <a:blip r:embed="rId1"/>
+          <a:blip r:embed="rId3"/>
           <a:stretch>
             <a:fillRect/>
           </a:stretch>
@@ -7260,7 +7176,7 @@
           <a:bodyPr wrap="square" lIns="0" tIns="0" rIns="0" bIns="0" rtlCol="0" anchor="t"/>
           <a:lstStyle/>
           <a:p>
-            <a:pPr algn="ctr" indent="0" marL="0">
+            <a:pPr marL="0" indent="0" algn="ctr">
               <a:buNone/>
             </a:pPr>
             <a:r>
@@ -7299,7 +7215,7 @@
           <a:bodyPr wrap="square" lIns="0" tIns="0" rIns="0" bIns="0" rtlCol="0" anchor="ctr"/>
           <a:lstStyle/>
           <a:p>
-            <a:pPr algn="ctr" indent="0" marL="0">
+            <a:pPr marL="0" indent="0" algn="ctr">
               <a:buNone/>
             </a:pPr>
             <a:r>
@@ -7338,7 +7254,7 @@
           <a:bodyPr wrap="square" lIns="0" tIns="0" rIns="0" bIns="0" rtlCol="0" anchor="ctr"/>
           <a:lstStyle/>
           <a:p>
-            <a:pPr algn="r" indent="0" marL="0">
+            <a:pPr marL="0" indent="0" algn="r">
               <a:buNone/>
             </a:pPr>
             <a:r>
@@ -7402,7 +7318,7 @@
           <a:bodyPr wrap="square" lIns="0" tIns="0" rIns="0" bIns="0" rtlCol="0" anchor="b"/>
           <a:lstStyle/>
           <a:p>
-            <a:pPr algn="l" indent="0" marL="0">
+            <a:pPr marL="0" indent="0" algn="l">
               <a:lnSpc>
                 <a:spcPct val="95000"/>
               </a:lnSpc>
@@ -7447,6 +7363,13 @@
             <a:prstDash val="solid"/>
           </a:ln>
         </p:spPr>
+        <p:txBody>
+          <a:bodyPr/>
+          <a:lstStyle/>
+          <a:p>
+            <a:endParaRPr lang="en-GB"/>
+          </a:p>
+        </p:txBody>
       </p:sp>
       <p:sp>
         <p:nvSpPr>
@@ -7469,7 +7392,7 @@
           <a:bodyPr wrap="square" lIns="0" tIns="0" rIns="0" bIns="0" rtlCol="0" anchor="t"/>
           <a:lstStyle/>
           <a:p>
-            <a:pPr indent="0" marL="0">
+            <a:pPr marL="0" indent="0">
               <a:buNone/>
             </a:pPr>
             <a:r>
@@ -7508,7 +7431,7 @@
           <a:bodyPr wrap="square" lIns="0" tIns="0" rIns="0" bIns="0" rtlCol="0" anchor="t"/>
           <a:lstStyle/>
           <a:p>
-            <a:pPr indent="0" marL="0">
+            <a:pPr marL="0" indent="0">
               <a:buNone/>
             </a:pPr>
             <a:r>
@@ -7547,7 +7470,7 @@
           <a:bodyPr wrap="square" lIns="0" tIns="0" rIns="0" bIns="0" rtlCol="0" anchor="t"/>
           <a:lstStyle/>
           <a:p>
-            <a:pPr indent="0" marL="0">
+            <a:pPr marL="0" indent="0">
               <a:buNone/>
             </a:pPr>
             <a:r>
@@ -7586,7 +7509,7 @@
           <a:bodyPr wrap="square" lIns="0" tIns="0" rIns="0" bIns="0" rtlCol="0" anchor="t"/>
           <a:lstStyle/>
           <a:p>
-            <a:pPr indent="0" marL="0">
+            <a:pPr marL="0" indent="0">
               <a:buNone/>
             </a:pPr>
             <a:r>
@@ -7625,7 +7548,7 @@
           <a:bodyPr wrap="square" lIns="0" tIns="0" rIns="0" bIns="0" rtlCol="0" anchor="t"/>
           <a:lstStyle/>
           <a:p>
-            <a:pPr indent="0" marL="0">
+            <a:pPr marL="0" indent="0">
               <a:buNone/>
             </a:pPr>
             <a:r>
@@ -7664,7 +7587,7 @@
           <a:bodyPr wrap="square" lIns="0" tIns="0" rIns="0" bIns="0" rtlCol="0" anchor="t"/>
           <a:lstStyle/>
           <a:p>
-            <a:pPr indent="0" marL="0">
+            <a:pPr marL="0" indent="0">
               <a:buNone/>
             </a:pPr>
             <a:r>
@@ -7703,7 +7626,7 @@
           <a:bodyPr wrap="square" lIns="0" tIns="0" rIns="0" bIns="0" rtlCol="0" anchor="t"/>
           <a:lstStyle/>
           <a:p>
-            <a:pPr indent="0" marL="0">
+            <a:pPr marL="0" indent="0">
               <a:buNone/>
             </a:pPr>
             <a:r>
@@ -7742,7 +7665,7 @@
           <a:bodyPr wrap="square" lIns="0" tIns="0" rIns="0" bIns="0" rtlCol="0" anchor="t"/>
           <a:lstStyle/>
           <a:p>
-            <a:pPr indent="0" marL="0">
+            <a:pPr marL="0" indent="0">
               <a:buNone/>
             </a:pPr>
             <a:r>
@@ -7781,7 +7704,7 @@
           <a:bodyPr wrap="square" lIns="0" tIns="0" rIns="0" bIns="0" rtlCol="0" anchor="t"/>
           <a:lstStyle/>
           <a:p>
-            <a:pPr indent="0" marL="0">
+            <a:pPr marL="0" indent="0">
               <a:buNone/>
             </a:pPr>
             <a:r>
@@ -7820,7 +7743,7 @@
           <a:bodyPr wrap="square" lIns="0" tIns="0" rIns="0" bIns="0" rtlCol="0" anchor="t"/>
           <a:lstStyle/>
           <a:p>
-            <a:pPr indent="0" marL="0">
+            <a:pPr marL="0" indent="0">
               <a:buNone/>
             </a:pPr>
             <a:r>
@@ -7859,7 +7782,7 @@
           <a:bodyPr wrap="square" lIns="0" tIns="0" rIns="0" bIns="0" rtlCol="0" anchor="t"/>
           <a:lstStyle/>
           <a:p>
-            <a:pPr indent="0" marL="0">
+            <a:pPr marL="0" indent="0">
               <a:buNone/>
             </a:pPr>
             <a:r>
@@ -7898,7 +7821,7 @@
           <a:bodyPr wrap="square" lIns="0" tIns="0" rIns="0" bIns="0" rtlCol="0" anchor="t"/>
           <a:lstStyle/>
           <a:p>
-            <a:pPr indent="0" marL="0">
+            <a:pPr marL="0" indent="0">
               <a:buNone/>
             </a:pPr>
             <a:r>
@@ -7942,13 +7865,20 @@
             <a:prstDash val="solid"/>
           </a:ln>
           <a:effectLst>
-            <a:outerShdw sx="100000" sy="100000" kx="0" ky="0" algn="bl" rotWithShape="0" blurRad="76200" dist="25400" dir="5400000">
+            <a:outerShdw blurRad="76200" dist="25400" dir="5400000" algn="bl" rotWithShape="0">
               <a:srgbClr val="000000">
                 <a:alpha val="8000"/>
               </a:srgbClr>
             </a:outerShdw>
           </a:effectLst>
         </p:spPr>
+        <p:txBody>
+          <a:bodyPr/>
+          <a:lstStyle/>
+          <a:p>
+            <a:endParaRPr lang="en-GB"/>
+          </a:p>
+        </p:txBody>
       </p:sp>
       <p:sp>
         <p:nvSpPr>
@@ -7971,7 +7901,7 @@
           <a:bodyPr wrap="square" lIns="0" tIns="0" rIns="0" bIns="0" rtlCol="0" anchor="ctr"/>
           <a:lstStyle/>
           <a:p>
-            <a:pPr indent="0" marL="0">
+            <a:pPr marL="0" indent="0">
               <a:buNone/>
             </a:pPr>
             <a:r>
@@ -8010,7 +7940,7 @@
           <a:bodyPr wrap="square" lIns="0" tIns="0" rIns="0" bIns="0" rtlCol="0" anchor="t"/>
           <a:lstStyle/>
           <a:p>
-            <a:pPr indent="0" marL="0">
+            <a:pPr marL="0" indent="0">
               <a:buNone/>
             </a:pPr>
             <a:r>
@@ -8049,7 +7979,7 @@
           <a:bodyPr wrap="square" lIns="0" tIns="0" rIns="0" bIns="0" rtlCol="0" anchor="t"/>
           <a:lstStyle/>
           <a:p>
-            <a:pPr indent="0" marL="0">
+            <a:pPr marL="0" indent="0">
               <a:buNone/>
             </a:pPr>
             <a:r>
@@ -8088,7 +8018,7 @@
           <a:bodyPr wrap="square" lIns="0" tIns="0" rIns="0" bIns="0" rtlCol="0" anchor="t"/>
           <a:lstStyle/>
           <a:p>
-            <a:pPr indent="0" marL="0">
+            <a:pPr marL="0" indent="0">
               <a:buNone/>
             </a:pPr>
             <a:r>
@@ -8127,7 +8057,7 @@
           <a:bodyPr wrap="square" lIns="0" tIns="0" rIns="0" bIns="0" rtlCol="0" anchor="t"/>
           <a:lstStyle/>
           <a:p>
-            <a:pPr indent="0" marL="0">
+            <a:pPr marL="0" indent="0">
               <a:buNone/>
             </a:pPr>
             <a:r>
@@ -8166,7 +8096,7 @@
           <a:bodyPr wrap="square" lIns="0" tIns="0" rIns="0" bIns="0" rtlCol="0" anchor="t"/>
           <a:lstStyle/>
           <a:p>
-            <a:pPr indent="0" marL="0">
+            <a:pPr marL="0" indent="0">
               <a:buNone/>
             </a:pPr>
             <a:r>
@@ -8205,7 +8135,7 @@
           <a:bodyPr wrap="square" lIns="0" tIns="0" rIns="0" bIns="0" rtlCol="0" anchor="t"/>
           <a:lstStyle/>
           <a:p>
-            <a:pPr indent="0" marL="0">
+            <a:pPr marL="0" indent="0">
               <a:buNone/>
             </a:pPr>
             <a:r>
@@ -8244,7 +8174,7 @@
           <a:bodyPr wrap="square" lIns="0" tIns="0" rIns="0" bIns="0" rtlCol="0" anchor="t"/>
           <a:lstStyle/>
           <a:p>
-            <a:pPr indent="0" marL="0">
+            <a:pPr marL="0" indent="0">
               <a:buNone/>
             </a:pPr>
             <a:r>
@@ -8283,7 +8213,7 @@
           <a:bodyPr wrap="square" lIns="0" tIns="0" rIns="0" bIns="0" rtlCol="0" anchor="t"/>
           <a:lstStyle/>
           <a:p>
-            <a:pPr indent="0" marL="0">
+            <a:pPr marL="0" indent="0">
               <a:buNone/>
             </a:pPr>
             <a:r>
@@ -8322,7 +8252,7 @@
           <a:bodyPr wrap="square" lIns="0" tIns="0" rIns="0" bIns="0" rtlCol="0" anchor="t"/>
           <a:lstStyle/>
           <a:p>
-            <a:pPr indent="0" marL="0">
+            <a:pPr marL="0" indent="0">
               <a:buNone/>
             </a:pPr>
             <a:r>
@@ -8361,7 +8291,7 @@
           <a:bodyPr wrap="square" lIns="0" tIns="0" rIns="0" bIns="0" rtlCol="0" anchor="t"/>
           <a:lstStyle/>
           <a:p>
-            <a:pPr indent="0" marL="0">
+            <a:pPr marL="0" indent="0">
               <a:buNone/>
             </a:pPr>
             <a:r>
@@ -8400,7 +8330,7 @@
           <a:bodyPr wrap="square" lIns="0" tIns="0" rIns="0" bIns="0" rtlCol="0" anchor="ctr"/>
           <a:lstStyle/>
           <a:p>
-            <a:pPr algn="r" indent="0" marL="0">
+            <a:pPr marL="0" indent="0" algn="r">
               <a:buNone/>
             </a:pPr>
             <a:r>
@@ -8464,7 +8394,7 @@
           <a:bodyPr wrap="square" lIns="0" tIns="0" rIns="0" bIns="0" rtlCol="0" anchor="b"/>
           <a:lstStyle/>
           <a:p>
-            <a:pPr algn="l" indent="0" marL="0">
+            <a:pPr marL="0" indent="0" algn="l">
               <a:lnSpc>
                 <a:spcPct val="95000"/>
               </a:lnSpc>
@@ -8509,6 +8439,13 @@
             <a:prstDash val="solid"/>
           </a:ln>
         </p:spPr>
+        <p:txBody>
+          <a:bodyPr/>
+          <a:lstStyle/>
+          <a:p>
+            <a:endParaRPr lang="en-GB"/>
+          </a:p>
+        </p:txBody>
       </p:sp>
       <p:sp>
         <p:nvSpPr>
@@ -8531,7 +8468,7 @@
           <a:bodyPr wrap="square" lIns="0" tIns="0" rIns="0" bIns="0" rtlCol="0" anchor="t"/>
           <a:lstStyle/>
           <a:p>
-            <a:pPr indent="0" marL="0">
+            <a:pPr marL="0" indent="0">
               <a:buNone/>
             </a:pPr>
             <a:r>
@@ -8570,7 +8507,7 @@
           <a:bodyPr wrap="square" lIns="0" tIns="0" rIns="0" bIns="0" rtlCol="0" anchor="t"/>
           <a:lstStyle/>
           <a:p>
-            <a:pPr algn="just" indent="0" marL="0">
+            <a:pPr marL="0" indent="0" algn="just">
               <a:buNone/>
             </a:pPr>
             <a:r>
@@ -8609,7 +8546,7 @@
           <a:bodyPr wrap="square" lIns="0" tIns="0" rIns="0" bIns="0" rtlCol="0" anchor="t"/>
           <a:lstStyle/>
           <a:p>
-            <a:pPr indent="0" marL="0">
+            <a:pPr marL="0" indent="0">
               <a:buNone/>
             </a:pPr>
             <a:r>
@@ -8648,7 +8585,7 @@
           <a:bodyPr wrap="square" lIns="0" tIns="0" rIns="0" bIns="0" rtlCol="0" anchor="t"/>
           <a:lstStyle/>
           <a:p>
-            <a:pPr algn="just" indent="0" marL="0">
+            <a:pPr marL="0" indent="0" algn="just">
               <a:buNone/>
             </a:pPr>
             <a:r>
@@ -8687,7 +8624,7 @@
           <a:bodyPr wrap="square" lIns="0" tIns="0" rIns="0" bIns="0" rtlCol="0" anchor="t"/>
           <a:lstStyle/>
           <a:p>
-            <a:pPr indent="0" marL="0">
+            <a:pPr marL="0" indent="0">
               <a:buNone/>
             </a:pPr>
             <a:r>
@@ -8726,7 +8663,7 @@
           <a:bodyPr wrap="square" lIns="0" tIns="0" rIns="0" bIns="0" rtlCol="0" anchor="t"/>
           <a:lstStyle/>
           <a:p>
-            <a:pPr algn="just" indent="0" marL="0">
+            <a:pPr marL="0" indent="0" algn="just">
               <a:buNone/>
             </a:pPr>
             <a:r>
@@ -8746,14 +8683,14 @@
       </p:sp>
       <p:pic>
         <p:nvPicPr>
-          <p:cNvPr id="10" name="Image 0" descr="fig3_audits_memory.png">    </p:cNvPr>
+          <p:cNvPr id="10" name="Image 0" descr="fig3_audits_memory.png"/>
           <p:cNvPicPr>
             <a:picLocks noChangeAspect="1"/>
           </p:cNvPicPr>
           <p:nvPr/>
         </p:nvPicPr>
         <p:blipFill>
-          <a:blip r:embed="rId1"/>
+          <a:blip r:embed="rId3"/>
           <a:stretch>
             <a:fillRect/>
           </a:stretch>
@@ -8789,7 +8726,7 @@
           <a:bodyPr wrap="square" lIns="0" tIns="0" rIns="0" bIns="0" rtlCol="0" anchor="t"/>
           <a:lstStyle/>
           <a:p>
-            <a:pPr algn="ctr" indent="0" marL="0">
+            <a:pPr marL="0" indent="0" algn="ctr">
               <a:buNone/>
             </a:pPr>
             <a:r>
@@ -8828,7 +8765,7 @@
           <a:bodyPr wrap="square" lIns="0" tIns="0" rIns="0" bIns="0" rtlCol="0" anchor="ctr"/>
           <a:lstStyle/>
           <a:p>
-            <a:pPr algn="r" indent="0" marL="0">
+            <a:pPr marL="0" indent="0" algn="r">
               <a:buNone/>
             </a:pPr>
             <a:r>
@@ -8892,7 +8829,7 @@
           <a:bodyPr wrap="square" lIns="0" tIns="0" rIns="0" bIns="0" rtlCol="0" anchor="b"/>
           <a:lstStyle/>
           <a:p>
-            <a:pPr algn="r" indent="0" marL="0">
+            <a:pPr marL="0" indent="0" algn="r">
               <a:lnSpc>
                 <a:spcPct val="95000"/>
               </a:lnSpc>
@@ -8937,6 +8874,13 @@
             <a:prstDash val="solid"/>
           </a:ln>
         </p:spPr>
+        <p:txBody>
+          <a:bodyPr/>
+          <a:lstStyle/>
+          <a:p>
+            <a:endParaRPr lang="en-GB"/>
+          </a:p>
+        </p:txBody>
       </p:sp>
       <p:sp>
         <p:nvSpPr>
@@ -8959,7 +8903,7 @@
           <a:bodyPr wrap="square" lIns="0" tIns="0" rIns="0" bIns="0" rtlCol="0" anchor="t"/>
           <a:lstStyle/>
           <a:p>
-            <a:pPr indent="0" marL="0">
+            <a:pPr marL="0" indent="0">
               <a:buNone/>
             </a:pPr>
             <a:r>
@@ -8998,7 +8942,7 @@
           <a:bodyPr wrap="square" lIns="0" tIns="0" rIns="0" bIns="0" rtlCol="0" anchor="t"/>
           <a:lstStyle/>
           <a:p>
-            <a:pPr algn="just" indent="0" marL="0">
+            <a:pPr marL="0" indent="0" algn="just">
               <a:buNone/>
             </a:pPr>
             <a:r>
@@ -9037,7 +8981,7 @@
           <a:bodyPr wrap="square" lIns="0" tIns="0" rIns="0" bIns="0" rtlCol="0" anchor="t"/>
           <a:lstStyle/>
           <a:p>
-            <a:pPr indent="0" marL="0">
+            <a:pPr marL="0" indent="0">
               <a:buNone/>
             </a:pPr>
             <a:r>
@@ -9076,7 +9020,7 @@
           <a:bodyPr wrap="square" lIns="0" tIns="0" rIns="0" bIns="0" rtlCol="0" anchor="t"/>
           <a:lstStyle/>
           <a:p>
-            <a:pPr algn="just" indent="0" marL="0">
+            <a:pPr marL="0" indent="0" algn="just">
               <a:buNone/>
             </a:pPr>
             <a:r>
@@ -9115,7 +9059,7 @@
           <a:bodyPr wrap="square" lIns="0" tIns="0" rIns="0" bIns="0" rtlCol="0" anchor="t"/>
           <a:lstStyle/>
           <a:p>
-            <a:pPr indent="0" marL="0">
+            <a:pPr marL="0" indent="0">
               <a:buNone/>
             </a:pPr>
             <a:r>
@@ -9154,7 +9098,7 @@
           <a:bodyPr wrap="square" lIns="0" tIns="0" rIns="0" bIns="0" rtlCol="0" anchor="t"/>
           <a:lstStyle/>
           <a:p>
-            <a:pPr algn="just" indent="0" marL="0">
+            <a:pPr marL="0" indent="0" algn="just">
               <a:buNone/>
             </a:pPr>
             <a:r>
@@ -9174,14 +9118,14 @@
       </p:sp>
       <p:pic>
         <p:nvPicPr>
-          <p:cNvPr id="10" name="Image 0" descr="fig3_audits_threshold.png">    </p:cNvPr>
+          <p:cNvPr id="10" name="Image 0" descr="fig3_audits_threshold.png"/>
           <p:cNvPicPr>
             <a:picLocks noChangeAspect="1"/>
           </p:cNvPicPr>
           <p:nvPr/>
         </p:nvPicPr>
         <p:blipFill>
-          <a:blip r:embed="rId1"/>
+          <a:blip r:embed="rId3"/>
           <a:stretch>
             <a:fillRect/>
           </a:stretch>
@@ -9217,7 +9161,7 @@
           <a:bodyPr wrap="square" lIns="0" tIns="0" rIns="0" bIns="0" rtlCol="0" anchor="t"/>
           <a:lstStyle/>
           <a:p>
-            <a:pPr algn="ctr" indent="0" marL="0">
+            <a:pPr marL="0" indent="0" algn="ctr">
               <a:buNone/>
             </a:pPr>
             <a:r>
@@ -9256,7 +9200,7 @@
           <a:bodyPr wrap="square" lIns="0" tIns="0" rIns="0" bIns="0" rtlCol="0" anchor="ctr"/>
           <a:lstStyle/>
           <a:p>
-            <a:pPr algn="r" indent="0" marL="0">
+            <a:pPr marL="0" indent="0" algn="r">
               <a:buNone/>
             </a:pPr>
             <a:r>
@@ -9320,7 +9264,7 @@
           <a:bodyPr wrap="square" lIns="0" tIns="0" rIns="0" bIns="0" rtlCol="0" anchor="b"/>
           <a:lstStyle/>
           <a:p>
-            <a:pPr algn="ctr" indent="0" marL="0">
+            <a:pPr marL="0" indent="0" algn="ctr">
               <a:lnSpc>
                 <a:spcPct val="95000"/>
               </a:lnSpc>
@@ -9343,14 +9287,14 @@
       </p:sp>
       <p:pic>
         <p:nvPicPr>
-          <p:cNvPr id="3" name="Image 0" descr="fig3_audits_rules.png">    </p:cNvPr>
+          <p:cNvPr id="3" name="Image 0" descr="fig3_audits_rules.png"/>
           <p:cNvPicPr>
             <a:picLocks noChangeAspect="1"/>
           </p:cNvPicPr>
           <p:nvPr/>
         </p:nvPicPr>
         <p:blipFill>
-          <a:blip r:embed="rId1"/>
+          <a:blip r:embed="rId3"/>
           <a:stretch>
             <a:fillRect/>
           </a:stretch>
@@ -9386,7 +9330,7 @@
           <a:bodyPr wrap="square" lIns="0" tIns="0" rIns="0" bIns="0" rtlCol="0" anchor="t"/>
           <a:lstStyle/>
           <a:p>
-            <a:pPr algn="ctr" indent="0" marL="0">
+            <a:pPr marL="0" indent="0" algn="ctr">
               <a:buNone/>
             </a:pPr>
             <a:r>
@@ -9406,14 +9350,14 @@
       </p:sp>
       <p:pic>
         <p:nvPicPr>
-          <p:cNvPr id="5" name="Image 1" descr="fig3_audits_targeting.png">    </p:cNvPr>
+          <p:cNvPr id="5" name="Image 1" descr="fig3_audits_targeting.png"/>
           <p:cNvPicPr>
             <a:picLocks noChangeAspect="1"/>
           </p:cNvPicPr>
           <p:nvPr/>
         </p:nvPicPr>
         <p:blipFill>
-          <a:blip r:embed="rId2"/>
+          <a:blip r:embed="rId4"/>
           <a:stretch>
             <a:fillRect/>
           </a:stretch>
@@ -9449,7 +9393,7 @@
           <a:bodyPr wrap="square" lIns="0" tIns="0" rIns="0" bIns="0" rtlCol="0" anchor="t"/>
           <a:lstStyle/>
           <a:p>
-            <a:pPr algn="ctr" indent="0" marL="0">
+            <a:pPr marL="0" indent="0" algn="ctr">
               <a:buNone/>
             </a:pPr>
             <a:r>
@@ -9488,7 +9432,7 @@
           <a:bodyPr wrap="square" lIns="0" tIns="0" rIns="0" bIns="0" rtlCol="0" anchor="ctr"/>
           <a:lstStyle/>
           <a:p>
-            <a:pPr algn="ctr" indent="0" marL="0">
+            <a:pPr marL="0" indent="0" algn="ctr">
               <a:buNone/>
             </a:pPr>
             <a:r>
@@ -9527,7 +9471,7 @@
           <a:bodyPr wrap="square" lIns="0" tIns="0" rIns="0" bIns="0" rtlCol="0" anchor="ctr"/>
           <a:lstStyle/>
           <a:p>
-            <a:pPr algn="r" indent="0" marL="0">
+            <a:pPr marL="0" indent="0" algn="r">
               <a:buNone/>
             </a:pPr>
             <a:r>
@@ -9846,4 +9790,319 @@
     </a:ext>
   </a:extLst>
 </a:theme>
+</file>
+
+<file path=ppt/theme/theme2.xml><?xml version="1.0" encoding="utf-8"?>
+<a:theme xmlns:a="http://schemas.openxmlformats.org/drawingml/2006/main" name="Office Theme">
+  <a:themeElements>
+    <a:clrScheme name="Office">
+      <a:dk1>
+        <a:sysClr val="windowText" lastClr="000000"/>
+      </a:dk1>
+      <a:lt1>
+        <a:sysClr val="window" lastClr="FFFFFF"/>
+      </a:lt1>
+      <a:dk2>
+        <a:srgbClr val="0E2841"/>
+      </a:dk2>
+      <a:lt2>
+        <a:srgbClr val="E8E8E8"/>
+      </a:lt2>
+      <a:accent1>
+        <a:srgbClr val="156082"/>
+      </a:accent1>
+      <a:accent2>
+        <a:srgbClr val="E97132"/>
+      </a:accent2>
+      <a:accent3>
+        <a:srgbClr val="196B24"/>
+      </a:accent3>
+      <a:accent4>
+        <a:srgbClr val="0F9ED5"/>
+      </a:accent4>
+      <a:accent5>
+        <a:srgbClr val="A02B93"/>
+      </a:accent5>
+      <a:accent6>
+        <a:srgbClr val="4EA72E"/>
+      </a:accent6>
+      <a:hlink>
+        <a:srgbClr val="467886"/>
+      </a:hlink>
+      <a:folHlink>
+        <a:srgbClr val="96607D"/>
+      </a:folHlink>
+    </a:clrScheme>
+    <a:fontScheme name="Office">
+      <a:majorFont>
+        <a:latin typeface="Aptos Display" panose="02110004020202020204"/>
+        <a:ea typeface=""/>
+        <a:cs typeface=""/>
+        <a:font script="Jpan" typeface="游ゴシック Light"/>
+        <a:font script="Hang" typeface="맑은 고딕"/>
+        <a:font script="Hans" typeface="等线 Light"/>
+        <a:font script="Hant" typeface="新細明體"/>
+        <a:font script="Arab" typeface="Times New Roman"/>
+        <a:font script="Hebr" typeface="Times New Roman"/>
+        <a:font script="Thai" typeface="Angsana New"/>
+        <a:font script="Ethi" typeface="Nyala"/>
+        <a:font script="Beng" typeface="Vrinda"/>
+        <a:font script="Gujr" typeface="Shruti"/>
+        <a:font script="Khmr" typeface="MoolBoran"/>
+        <a:font script="Knda" typeface="Tunga"/>
+        <a:font script="Guru" typeface="Raavi"/>
+        <a:font script="Cans" typeface="Euphemia"/>
+        <a:font script="Cher" typeface="Plantagenet Cherokee"/>
+        <a:font script="Yiii" typeface="Microsoft Yi Baiti"/>
+        <a:font script="Tibt" typeface="Microsoft Himalaya"/>
+        <a:font script="Thaa" typeface="MV Boli"/>
+        <a:font script="Deva" typeface="Mangal"/>
+        <a:font script="Telu" typeface="Gautami"/>
+        <a:font script="Taml" typeface="Latha"/>
+        <a:font script="Syrc" typeface="Estrangelo Edessa"/>
+        <a:font script="Orya" typeface="Kalinga"/>
+        <a:font script="Mlym" typeface="Kartika"/>
+        <a:font script="Laoo" typeface="DokChampa"/>
+        <a:font script="Sinh" typeface="Iskoola Pota"/>
+        <a:font script="Mong" typeface="Mongolian Baiti"/>
+        <a:font script="Viet" typeface="Times New Roman"/>
+        <a:font script="Uigh" typeface="Microsoft Uighur"/>
+        <a:font script="Geor" typeface="Sylfaen"/>
+        <a:font script="Armn" typeface="Arial"/>
+        <a:font script="Bugi" typeface="Leelawadee UI"/>
+        <a:font script="Bopo" typeface="Microsoft JhengHei"/>
+        <a:font script="Java" typeface="Javanese Text"/>
+        <a:font script="Lisu" typeface="Segoe UI"/>
+        <a:font script="Mymr" typeface="Myanmar Text"/>
+        <a:font script="Nkoo" typeface="Ebrima"/>
+        <a:font script="Olck" typeface="Nirmala UI"/>
+        <a:font script="Osma" typeface="Ebrima"/>
+        <a:font script="Phag" typeface="Phagspa"/>
+        <a:font script="Syrn" typeface="Estrangelo Edessa"/>
+        <a:font script="Syrj" typeface="Estrangelo Edessa"/>
+        <a:font script="Syre" typeface="Estrangelo Edessa"/>
+        <a:font script="Sora" typeface="Nirmala UI"/>
+        <a:font script="Tale" typeface="Microsoft Tai Le"/>
+        <a:font script="Talu" typeface="Microsoft New Tai Lue"/>
+        <a:font script="Tfng" typeface="Ebrima"/>
+      </a:majorFont>
+      <a:minorFont>
+        <a:latin typeface="Aptos" panose="02110004020202020204"/>
+        <a:ea typeface=""/>
+        <a:cs typeface=""/>
+        <a:font script="Jpan" typeface="游ゴシック"/>
+        <a:font script="Hang" typeface="맑은 고딕"/>
+        <a:font script="Hans" typeface="等线"/>
+        <a:font script="Hant" typeface="新細明體"/>
+        <a:font script="Arab" typeface="Arial"/>
+        <a:font script="Hebr" typeface="Arial"/>
+        <a:font script="Thai" typeface="Cordia New"/>
+        <a:font script="Ethi" typeface="Nyala"/>
+        <a:font script="Beng" typeface="Vrinda"/>
+        <a:font script="Gujr" typeface="Shruti"/>
+        <a:font script="Khmr" typeface="DaunPenh"/>
+        <a:font script="Knda" typeface="Tunga"/>
+        <a:font script="Guru" typeface="Raavi"/>
+        <a:font script="Cans" typeface="Euphemia"/>
+        <a:font script="Cher" typeface="Plantagenet Cherokee"/>
+        <a:font script="Yiii" typeface="Microsoft Yi Baiti"/>
+        <a:font script="Tibt" typeface="Microsoft Himalaya"/>
+        <a:font script="Thaa" typeface="MV Boli"/>
+        <a:font script="Deva" typeface="Mangal"/>
+        <a:font script="Telu" typeface="Gautami"/>
+        <a:font script="Taml" typeface="Latha"/>
+        <a:font script="Syrc" typeface="Estrangelo Edessa"/>
+        <a:font script="Orya" typeface="Kalinga"/>
+        <a:font script="Mlym" typeface="Kartika"/>
+        <a:font script="Laoo" typeface="DokChampa"/>
+        <a:font script="Sinh" typeface="Iskoola Pota"/>
+        <a:font script="Mong" typeface="Mongolian Baiti"/>
+        <a:font script="Viet" typeface="Arial"/>
+        <a:font script="Uigh" typeface="Microsoft Uighur"/>
+        <a:font script="Geor" typeface="Sylfaen"/>
+        <a:font script="Armn" typeface="Arial"/>
+        <a:font script="Bugi" typeface="Leelawadee UI"/>
+        <a:font script="Bopo" typeface="Microsoft JhengHei"/>
+        <a:font script="Java" typeface="Javanese Text"/>
+        <a:font script="Lisu" typeface="Segoe UI"/>
+        <a:font script="Mymr" typeface="Myanmar Text"/>
+        <a:font script="Nkoo" typeface="Ebrima"/>
+        <a:font script="Olck" typeface="Nirmala UI"/>
+        <a:font script="Osma" typeface="Ebrima"/>
+        <a:font script="Phag" typeface="Phagspa"/>
+        <a:font script="Syrn" typeface="Estrangelo Edessa"/>
+        <a:font script="Syrj" typeface="Estrangelo Edessa"/>
+        <a:font script="Syre" typeface="Estrangelo Edessa"/>
+        <a:font script="Sora" typeface="Nirmala UI"/>
+        <a:font script="Tale" typeface="Microsoft Tai Le"/>
+        <a:font script="Talu" typeface="Microsoft New Tai Lue"/>
+        <a:font script="Tfng" typeface="Ebrima"/>
+      </a:minorFont>
+    </a:fontScheme>
+    <a:fmtScheme name="Office">
+      <a:fillStyleLst>
+        <a:solidFill>
+          <a:schemeClr val="phClr"/>
+        </a:solidFill>
+        <a:gradFill rotWithShape="1">
+          <a:gsLst>
+            <a:gs pos="0">
+              <a:schemeClr val="phClr">
+                <a:lumMod val="110000"/>
+                <a:satMod val="105000"/>
+                <a:tint val="67000"/>
+              </a:schemeClr>
+            </a:gs>
+            <a:gs pos="50000">
+              <a:schemeClr val="phClr">
+                <a:lumMod val="105000"/>
+                <a:satMod val="103000"/>
+                <a:tint val="73000"/>
+              </a:schemeClr>
+            </a:gs>
+            <a:gs pos="100000">
+              <a:schemeClr val="phClr">
+                <a:lumMod val="105000"/>
+                <a:satMod val="109000"/>
+                <a:tint val="81000"/>
+              </a:schemeClr>
+            </a:gs>
+          </a:gsLst>
+          <a:lin ang="5400000" scaled="0"/>
+        </a:gradFill>
+        <a:gradFill rotWithShape="1">
+          <a:gsLst>
+            <a:gs pos="0">
+              <a:schemeClr val="phClr">
+                <a:satMod val="103000"/>
+                <a:lumMod val="102000"/>
+                <a:tint val="94000"/>
+              </a:schemeClr>
+            </a:gs>
+            <a:gs pos="50000">
+              <a:schemeClr val="phClr">
+                <a:satMod val="110000"/>
+                <a:lumMod val="100000"/>
+                <a:shade val="100000"/>
+              </a:schemeClr>
+            </a:gs>
+            <a:gs pos="100000">
+              <a:schemeClr val="phClr">
+                <a:lumMod val="99000"/>
+                <a:satMod val="120000"/>
+                <a:shade val="78000"/>
+              </a:schemeClr>
+            </a:gs>
+          </a:gsLst>
+          <a:lin ang="5400000" scaled="0"/>
+        </a:gradFill>
+      </a:fillStyleLst>
+      <a:lnStyleLst>
+        <a:ln w="12700" cap="flat" cmpd="sng" algn="ctr">
+          <a:solidFill>
+            <a:schemeClr val="phClr"/>
+          </a:solidFill>
+          <a:prstDash val="solid"/>
+          <a:miter lim="800000"/>
+        </a:ln>
+        <a:ln w="19050" cap="flat" cmpd="sng" algn="ctr">
+          <a:solidFill>
+            <a:schemeClr val="phClr"/>
+          </a:solidFill>
+          <a:prstDash val="solid"/>
+          <a:miter lim="800000"/>
+        </a:ln>
+        <a:ln w="25400" cap="flat" cmpd="sng" algn="ctr">
+          <a:solidFill>
+            <a:schemeClr val="phClr"/>
+          </a:solidFill>
+          <a:prstDash val="solid"/>
+          <a:miter lim="800000"/>
+        </a:ln>
+      </a:lnStyleLst>
+      <a:effectStyleLst>
+        <a:effectStyle>
+          <a:effectLst/>
+        </a:effectStyle>
+        <a:effectStyle>
+          <a:effectLst/>
+        </a:effectStyle>
+        <a:effectStyle>
+          <a:effectLst>
+            <a:outerShdw blurRad="57150" dist="19050" dir="5400000" algn="ctr" rotWithShape="0">
+              <a:srgbClr val="000000">
+                <a:alpha val="63000"/>
+              </a:srgbClr>
+            </a:outerShdw>
+          </a:effectLst>
+        </a:effectStyle>
+      </a:effectStyleLst>
+      <a:bgFillStyleLst>
+        <a:solidFill>
+          <a:schemeClr val="phClr"/>
+        </a:solidFill>
+        <a:solidFill>
+          <a:schemeClr val="phClr">
+            <a:tint val="95000"/>
+            <a:satMod val="170000"/>
+          </a:schemeClr>
+        </a:solidFill>
+        <a:gradFill rotWithShape="1">
+          <a:gsLst>
+            <a:gs pos="0">
+              <a:schemeClr val="phClr">
+                <a:tint val="93000"/>
+                <a:satMod val="150000"/>
+                <a:shade val="98000"/>
+                <a:lumMod val="102000"/>
+              </a:schemeClr>
+            </a:gs>
+            <a:gs pos="50000">
+              <a:schemeClr val="phClr">
+                <a:tint val="98000"/>
+                <a:satMod val="130000"/>
+                <a:shade val="90000"/>
+                <a:lumMod val="103000"/>
+              </a:schemeClr>
+            </a:gs>
+            <a:gs pos="100000">
+              <a:schemeClr val="phClr">
+                <a:shade val="63000"/>
+                <a:satMod val="120000"/>
+              </a:schemeClr>
+            </a:gs>
+          </a:gsLst>
+          <a:lin ang="5400000" scaled="0"/>
+        </a:gradFill>
+      </a:bgFillStyleLst>
+    </a:fmtScheme>
+  </a:themeElements>
+  <a:objectDefaults>
+    <a:lnDef>
+      <a:spPr/>
+      <a:bodyPr/>
+      <a:lstStyle/>
+      <a:style>
+        <a:lnRef idx="2">
+          <a:schemeClr val="accent1"/>
+        </a:lnRef>
+        <a:fillRef idx="0">
+          <a:schemeClr val="accent1"/>
+        </a:fillRef>
+        <a:effectRef idx="1">
+          <a:schemeClr val="accent1"/>
+        </a:effectRef>
+        <a:fontRef idx="minor">
+          <a:schemeClr val="tx1"/>
+        </a:fontRef>
+      </a:style>
+    </a:lnDef>
+  </a:objectDefaults>
+  <a:extraClrSchemeLst/>
+  <a:extLst>
+    <a:ext uri="{05A4C25C-085E-4340-85A3-A5531E510DB2}">
+      <thm15:themeFamily xmlns:thm15="http://schemas.microsoft.com/office/thememl/2012/main" name="Office Theme" id="{2E142A2C-CD16-42D6-873A-C26D2A0506FA}" vid="{1BDDFF52-6CD6-40A5-AB3C-68EB2F1E4D0A}"/>
+    </a:ext>
+  </a:extLst>
+</a:theme>
 </file>
</xml_diff>

<commit_message>
Catch-up deck slide 13: L6 spillover result filled in (Ameer's edits kept)
Co-Authored-By: Claude Opus 5.5 <noreply@anthropic.com>
</commit_message>
<xml_diff>
--- a/notes/slides/2026-10-13_phd_catchup/phd_catchup_2026-10-13.pptx
+++ b/notes/slides/2026-10-13_phd_catchup/phd_catchup_2026-10-13.pptx
@@ -3921,7 +3921,6 @@
             <a:solidFill>
               <a:srgbClr val="C9C6C1"/>
             </a:solidFill>
-            <a:prstDash val="dash"/>
           </a:ln>
         </p:spPr>
         <p:txBody>
@@ -3941,7 +3940,7 @@
         <p:spPr>
           <a:xfrm>
             <a:off x="6217920" y="5191506"/>
-            <a:ext cx="5287975" cy="274320"/>
+            <a:ext cx="5287975" cy="900000"/>
           </a:xfrm>
           <a:prstGeom prst="rect">
             <a:avLst/>
@@ -3957,15 +3956,15 @@
               <a:buNone/>
             </a:pPr>
             <a:r>
-              <a:rPr lang="en-US" sz="1100" i="1" dirty="0">
-                <a:solidFill>
-                  <a:srgbClr val="8F8F8F"/>
+              <a:rPr lang="en-US" sz="1100" dirty="0">
+                <a:solidFill>
+                  <a:srgbClr val="1C191A"/>
                 </a:solidFill>
                 <a:latin typeface="Calibri" pitchFamily="34" charset="0"/>
                 <a:ea typeface="Calibri" pitchFamily="34" charset="-122"/>
                 <a:cs typeface="Calibri" pitchFamily="34" charset="-120"/>
               </a:rPr>
-              <a:t>Result (to fill in):</a:t>
+              <a:t>Yes. With one over-cutter, the other foresters broke their allowance in 50–58% of rounds instead of 26–32% (+25 points), at every distance on the ring. Seeing neighbours’ cuts made no difference: it spread through the reviewer’s shared cut, which halved allowances while the models kept cutting as before.</a:t>
             </a:r>
             <a:endParaRPr lang="en-US" sz="1100" dirty="0"/>
           </a:p>

</xml_diff>

<commit_message>
Tracking catch-up (13-27 Oct): PROJECT_HISTORY rows for L4-L6, the 13 Oct meeting, platform research, Phase 0, the overseer layer, R1a, R1b and the grant draft; study index with a tracking checklist; L5 results written (screen only); paper plan status; experiments README; ledger; slide deck and scripts committed
Co-Authored-By: Claude Opus 5.5 <noreply@anthropic.com>
</commit_message>
<xml_diff>
--- a/notes/slides/2026-10-13_phd_catchup/phd_catchup_2026-10-13.pptx
+++ b/notes/slides/2026-10-13_phd_catchup/phd_catchup_2026-10-13.pptx
@@ -3321,7 +3321,7 @@
               <a:buNone/>
             </a:pPr>
             <a:r>
-              <a:rPr lang="en-US" sz="3400" b="1" dirty="0">
+              <a:rPr lang="en-US" sz="3400" b="1">
                 <a:solidFill>
                   <a:srgbClr val="062746"/>
                 </a:solidFill>
@@ -3329,7 +3329,7 @@
                 <a:ea typeface="Georgia" pitchFamily="34" charset="-122"/>
                 <a:cs typeface="Georgia" pitchFamily="34" charset="-120"/>
               </a:rPr>
-              <a:t>Running Now (Results Soon)</a:t>
+              <a:t>Follow-up Results</a:t>
             </a:r>
             <a:endParaRPr lang="en-US" sz="3400" dirty="0"/>
           </a:p>
@@ -3468,7 +3468,7 @@
             <a:solidFill>
               <a:srgbClr val="C9C6C1"/>
             </a:solidFill>
-            <a:prstDash val="dash"/>
+            <a:prstDash val="solid"/>
           </a:ln>
         </p:spPr>
         <p:txBody>
@@ -3488,7 +3488,7 @@
         <p:spPr>
           <a:xfrm>
             <a:off x="6217920" y="1618488"/>
-            <a:ext cx="5287975" cy="274320"/>
+            <a:ext cx="5287975" cy="812800"/>
           </a:xfrm>
           <a:prstGeom prst="rect">
             <a:avLst/>
@@ -3504,17 +3504,21 @@
               <a:buNone/>
             </a:pPr>
             <a:r>
-              <a:rPr lang="en-US" sz="1100" i="1" dirty="0">
-                <a:solidFill>
-                  <a:srgbClr val="8F8F8F"/>
+              <a:rPr lang="en-US" sz="1100">
+                <a:solidFill>
+                  <a:srgbClr val="1C191A"/>
                 </a:solidFill>
                 <a:latin typeface="Calibri" pitchFamily="34" charset="0"/>
                 <a:ea typeface="Calibri" pitchFamily="34" charset="-122"/>
                 <a:cs typeface="Calibri" pitchFamily="34" charset="-120"/>
               </a:rPr>
-              <a:t>Result (to fill in):</a:t>
-            </a:r>
-            <a:endParaRPr lang="en-US" sz="1100" dirty="0"/>
+              <a:t>Mostly the expected fine, with a pull from fine size. At an expected fine of 3 t, all three mixes gave 9–11% over-taking. At 2 t, a rare audit with a large fine deterred more (28%) than a frequent audit with a small fine (41%).</a:t>
+            </a:r>
+            <a:endParaRPr lang="en-US" sz="1100" dirty="0">
+              <a:solidFill>
+                <a:srgbClr val="1C191A"/>
+              </a:solidFill>
+            </a:endParaRPr>
           </a:p>
         </p:txBody>
       </p:sp>
@@ -3619,7 +3623,7 @@
             <a:solidFill>
               <a:srgbClr val="C9C6C1"/>
             </a:solidFill>
-            <a:prstDash val="dash"/>
+            <a:prstDash val="solid"/>
           </a:ln>
         </p:spPr>
         <p:txBody>
@@ -3639,7 +3643,7 @@
         <p:spPr>
           <a:xfrm>
             <a:off x="6217920" y="2809494"/>
-            <a:ext cx="5287975" cy="274320"/>
+            <a:ext cx="5287975" cy="812800"/>
           </a:xfrm>
           <a:prstGeom prst="rect">
             <a:avLst/>
@@ -3655,17 +3659,21 @@
               <a:buNone/>
             </a:pPr>
             <a:r>
-              <a:rPr lang="en-US" sz="1100" i="1" dirty="0">
-                <a:solidFill>
-                  <a:srgbClr val="8F8F8F"/>
+              <a:rPr lang="en-US" sz="1100">
+                <a:solidFill>
+                  <a:srgbClr val="1C191A"/>
                 </a:solidFill>
                 <a:latin typeface="Calibri" pitchFamily="34" charset="0"/>
                 <a:ea typeface="Calibri" pitchFamily="34" charset="-122"/>
                 <a:cs typeface="Calibri" pitchFamily="34" charset="-120"/>
               </a:rPr>
-              <a:t>Result (to fill in):</a:t>
-            </a:r>
-            <a:endParaRPr lang="en-US" sz="1100" dirty="0"/>
+              <a:t>Yes. On 10 new games, both models stopped by the predicted 30 t (0.2% and 1.8% over-taking), and the same held with reworded rules. As before, gpt-oss stopped one step early, at 24 t.</a:t>
+            </a:r>
+            <a:endParaRPr lang="en-US" sz="1100" dirty="0">
+              <a:solidFill>
+                <a:srgbClr val="1C191A"/>
+              </a:solidFill>
+            </a:endParaRPr>
           </a:p>
         </p:txBody>
       </p:sp>
@@ -3770,7 +3778,7 @@
             <a:solidFill>
               <a:srgbClr val="C9C6C1"/>
             </a:solidFill>
-            <a:prstDash val="dash"/>
+            <a:prstDash val="solid"/>
           </a:ln>
         </p:spPr>
         <p:txBody>
@@ -3790,7 +3798,7 @@
         <p:spPr>
           <a:xfrm>
             <a:off x="6217920" y="4000500"/>
-            <a:ext cx="5287975" cy="274320"/>
+            <a:ext cx="5287975" cy="812800"/>
           </a:xfrm>
           <a:prstGeom prst="rect">
             <a:avLst/>
@@ -3806,17 +3814,21 @@
               <a:buNone/>
             </a:pPr>
             <a:r>
-              <a:rPr lang="en-US" sz="1100" i="1" dirty="0">
-                <a:solidFill>
-                  <a:srgbClr val="8F8F8F"/>
+              <a:rPr lang="en-US" sz="1100">
+                <a:solidFill>
+                  <a:srgbClr val="1C191A"/>
                 </a:solidFill>
                 <a:latin typeface="Calibri" pitchFamily="34" charset="0"/>
                 <a:ea typeface="Calibri" pitchFamily="34" charset="-122"/>
                 <a:cs typeface="Calibri" pitchFamily="34" charset="-120"/>
               </a:rPr>
-              <a:t>Result (to fill in):</a:t>
-            </a:r>
-            <a:endParaRPr lang="en-US" sz="1100" dirty="0"/>
+              <a:t>Over-taking was lower when audits were never mentioned: 30% vs 58% (gpt-oss) and 46% vs 64% (Nemotron) with audits that carry no fine. Announcing a zero fine seems to invite cheating.</a:t>
+            </a:r>
+            <a:endParaRPr lang="en-US" sz="1100" dirty="0">
+              <a:solidFill>
+                <a:srgbClr val="1C191A"/>
+              </a:solidFill>
+            </a:endParaRPr>
           </a:p>
         </p:txBody>
       </p:sp>
@@ -4018,7 +4030,7 @@
 </file>
 
 <file path=ppt/slides/slide14.xml><?xml version="1.0" encoding="utf-8"?>
-<p:sld xmlns:a="http://schemas.openxmlformats.org/drawingml/2006/main" xmlns:r="http://schemas.openxmlformats.org/officeDocument/2006/relationships" xmlns:p="http://schemas.openxmlformats.org/presentationml/2006/main">
+<p:sld xmlns:a="http://schemas.openxmlformats.org/drawingml/2006/main" xmlns:r="http://schemas.openxmlformats.org/officeDocument/2006/relationships" xmlns:p="http://schemas.openxmlformats.org/presentationml/2006/main" show="0">
   <p:cSld name="Slide 14">
     <p:spTree>
       <p:nvGrpSpPr>

</xml_diff>